<commit_message>
Prioritize research communication and verify published example integrity
</commit_message>
<xml_diff>
--- a/examples/research-seminar/animated-ko.pptx
+++ b/examples/research-seminar/animated-ko.pptx
@@ -124,63 +124,144 @@
     <c:autoTitleDeleted val="1"/>
     <c:plotArea>
       <c:layout/>
-      <c:barChart>
-        <c:barDir val="col"/>
-        <c:grouping val="clustered"/>
-        <c:varyColors val="0"/>
+      <c:scatterChart>
+        <c:scatterStyle val="lineMarker"/>
+        <c:varyColors val="1"/>
         <c:ser>
           <c:idx val="0"/>
           <c:order val="0"/>
           <c:tx>
-            <c:v>지연 (ms)</c:v>
+            <c:v>Models</c:v>
           </c:tx>
           <c:spPr>
-            <a:solidFill>
-              <a:srgbClr val="287D78"/>
-            </a:solidFill>
+            <a:ln w="0">
+              <a:noFill/>
+            </a:ln>
           </c:spPr>
-          <c:invertIfNegative val="1"/>
-          <c:dPt>
-            <c:idx val="0"/>
-            <c:invertIfNegative val="0"/>
-            <c:bubble3D val="0"/>
+          <c:marker>
+            <c:symbol val="circle"/>
+            <c:size val="10"/>
             <c:spPr>
               <a:solidFill>
-                <a:srgbClr val="9EADA5"/>
+                <a:srgbClr val="287D78"/>
               </a:solidFill>
+              <a:ln>
+                <a:noFill/>
+              </a:ln>
             </c:spPr>
-            <c:extLst>
-              <c:ext xmlns:c16="http://schemas.microsoft.com/office/drawing/2014/chart" uri="{C3380CC4-5D6E-409C-BE32-E72D297353CC}">
-                <c16:uniqueId val="{00000001-42F6-4757-868A-53025752E36A}"/>
-              </c:ext>
-            </c:extLst>
-          </c:dPt>
-          <c:dPt>
-            <c:idx val="1"/>
-            <c:invertIfNegative val="0"/>
-            <c:bubble3D val="0"/>
-            <c:spPr>
-              <a:solidFill>
-                <a:srgbClr val="639D90"/>
-              </a:solidFill>
-            </c:spPr>
-            <c:extLst>
-              <c:ext xmlns:c16="http://schemas.microsoft.com/office/drawing/2014/chart" uri="{C3380CC4-5D6E-409C-BE32-E72D297353CC}">
-                <c16:uniqueId val="{00000003-42F6-4757-868A-53025752E36A}"/>
-              </c:ext>
-            </c:extLst>
-          </c:dPt>
-          <c:dPt>
-            <c:idx val="2"/>
-            <c:invertIfNegative val="0"/>
-            <c:bubble3D val="0"/>
-            <c:extLst>
-              <c:ext xmlns:c16="http://schemas.microsoft.com/office/drawing/2014/chart" uri="{C3380CC4-5D6E-409C-BE32-E72D297353CC}">
-                <c16:uniqueId val="{00000005-42F6-4757-868A-53025752E36A}"/>
-              </c:ext>
-            </c:extLst>
-          </c:dPt>
+          </c:marker>
           <c:dLbls>
+            <c:dLbl>
+              <c:idx val="0"/>
+              <c:tx>
+                <c:rich>
+                  <a:bodyPr/>
+                  <a:lstStyle/>
+                  <a:p>
+                    <a:r>
+                      <a:rPr sz="1800">
+                        <a:solidFill>
+                          <a:srgbClr val="1E302F"/>
+                        </a:solidFill>
+                        <a:latin typeface="Noto Sans KR"/>
+                        <a:ea typeface="Noto Sans KR"/>
+                        <a:cs typeface="Noto Sans KR"/>
+                      </a:rPr>
+                      <a:t>baseline</a:t>
+                    </a:r>
+                  </a:p>
+                </c:rich>
+              </c:tx>
+              <c:spPr/>
+              <c:showLegendKey val="0"/>
+              <c:showVal val="0"/>
+              <c:showCatName val="0"/>
+              <c:showSerName val="0"/>
+              <c:showPercent val="0"/>
+              <c:showBubbleSize val="0"/>
+              <c:extLst>
+                <c:ext xmlns:c15="http://schemas.microsoft.com/office/drawing/2012/chart" uri="{CE6537A1-D6FC-4f65-9D91-7224C49458BB}">
+                  <c15:showDataLabelsRange val="0"/>
+                </c:ext>
+                <c:ext xmlns:c16="http://schemas.microsoft.com/office/drawing/2014/chart" uri="{C3380CC4-5D6E-409C-BE32-E72D297353CC}">
+                  <c16:uniqueId val="{00000000-DE7C-4D94-8E1B-0E6D337F9C00}"/>
+                </c:ext>
+              </c:extLst>
+            </c:dLbl>
+            <c:dLbl>
+              <c:idx val="1"/>
+              <c:tx>
+                <c:rich>
+                  <a:bodyPr/>
+                  <a:lstStyle/>
+                  <a:p>
+                    <a:r>
+                      <a:rPr sz="1800">
+                        <a:solidFill>
+                          <a:srgbClr val="1E302F"/>
+                        </a:solidFill>
+                        <a:latin typeface="Noto Sans KR"/>
+                        <a:ea typeface="Noto Sans KR"/>
+                        <a:cs typeface="Noto Sans KR"/>
+                      </a:rPr>
+                      <a:t>distilled</a:t>
+                    </a:r>
+                  </a:p>
+                </c:rich>
+              </c:tx>
+              <c:spPr/>
+              <c:showLegendKey val="0"/>
+              <c:showVal val="0"/>
+              <c:showCatName val="0"/>
+              <c:showSerName val="0"/>
+              <c:showPercent val="0"/>
+              <c:showBubbleSize val="0"/>
+              <c:extLst>
+                <c:ext xmlns:c15="http://schemas.microsoft.com/office/drawing/2012/chart" uri="{CE6537A1-D6FC-4f65-9D91-7224C49458BB}">
+                  <c15:showDataLabelsRange val="0"/>
+                </c:ext>
+                <c:ext xmlns:c16="http://schemas.microsoft.com/office/drawing/2014/chart" uri="{C3380CC4-5D6E-409C-BE32-E72D297353CC}">
+                  <c16:uniqueId val="{00000001-DE7C-4D94-8E1B-0E6D337F9C00}"/>
+                </c:ext>
+              </c:extLst>
+            </c:dLbl>
+            <c:dLbl>
+              <c:idx val="2"/>
+              <c:tx>
+                <c:rich>
+                  <a:bodyPr/>
+                  <a:lstStyle/>
+                  <a:p>
+                    <a:r>
+                      <a:rPr sz="1800">
+                        <a:solidFill>
+                          <a:srgbClr val="1E302F"/>
+                        </a:solidFill>
+                        <a:latin typeface="Noto Sans KR"/>
+                        <a:ea typeface="Noto Sans KR"/>
+                        <a:cs typeface="Noto Sans KR"/>
+                      </a:rPr>
+                      <a:t>int8</a:t>
+                    </a:r>
+                  </a:p>
+                </c:rich>
+              </c:tx>
+              <c:spPr/>
+              <c:showLegendKey val="0"/>
+              <c:showVal val="0"/>
+              <c:showCatName val="0"/>
+              <c:showSerName val="0"/>
+              <c:showPercent val="0"/>
+              <c:showBubbleSize val="0"/>
+              <c:extLst>
+                <c:ext xmlns:c15="http://schemas.microsoft.com/office/drawing/2012/chart" uri="{CE6537A1-D6FC-4f65-9D91-7224C49458BB}">
+                  <c15:showDataLabelsRange val="0"/>
+                </c:ext>
+                <c:ext xmlns:c16="http://schemas.microsoft.com/office/drawing/2014/chart" uri="{C3380CC4-5D6E-409C-BE32-E72D297353CC}">
+                  <c16:uniqueId val="{00000002-DE7C-4D94-8E1B-0E6D337F9C00}"/>
+                </c:ext>
+              </c:extLst>
+            </c:dLbl>
             <c:spPr>
               <a:noFill/>
               <a:ln>
@@ -188,30 +269,12 @@
               </a:ln>
               <a:effectLst/>
             </c:spPr>
-            <c:txPr>
-              <a:bodyPr anchorCtr="1"/>
-              <a:lstStyle/>
-              <a:p>
-                <a:pPr>
-                  <a:defRPr sz="2025">
-                    <a:solidFill>
-                      <a:srgbClr val="1E302F"/>
-                    </a:solidFill>
-                    <a:latin typeface="Noto Sans KR"/>
-                    <a:ea typeface="Noto Sans KR"/>
-                    <a:cs typeface="Noto Sans KR"/>
-                  </a:defRPr>
-                </a:pPr>
-                <a:endParaRPr lang="ko-KR"/>
-              </a:p>
-            </c:txPr>
-            <c:dLblPos val="outEnd"/>
-            <c:showLegendKey val="0"/>
+            <c:showLegendKey val="1"/>
             <c:showVal val="1"/>
-            <c:showCatName val="0"/>
-            <c:showSerName val="0"/>
-            <c:showPercent val="0"/>
-            <c:showBubbleSize val="0"/>
+            <c:showCatName val="1"/>
+            <c:showSerName val="1"/>
+            <c:showPercent val="1"/>
+            <c:showBubbleSize val="1"/>
             <c:showLeaderLines val="0"/>
             <c:extLst>
               <c:ext xmlns:c15="http://schemas.microsoft.com/office/drawing/2012/chart" uri="{CE6537A1-D6FC-4f65-9D91-7224C49458BB}">
@@ -219,28 +282,11 @@
               </c:ext>
             </c:extLst>
           </c:dLbls>
-          <c:cat>
-            <c:strRef>
+          <c:xVal>
+            <c:numRef>
               <c:f>'Chart Data'!$A$2:$A$4</c:f>
-              <c:strCache>
-                <c:ptCount val="3"/>
-                <c:pt idx="0">
-                  <c:v>baseline</c:v>
-                </c:pt>
-                <c:pt idx="1">
-                  <c:v>distilled</c:v>
-                </c:pt>
-                <c:pt idx="2">
-                  <c:v>int8</c:v>
-                </c:pt>
-              </c:strCache>
-            </c:strRef>
-          </c:cat>
-          <c:val>
-            <c:numRef>
-              <c:f>'Chart Data'!$B$2:$B$4</c:f>
               <c:numCache>
-                <c:formatCode>0</c:formatCode>
+                <c:formatCode>General</c:formatCode>
                 <c:ptCount val="3"/>
                 <c:pt idx="0">
                   <c:v>120</c:v>
@@ -253,39 +299,100 @@
                 </c:pt>
               </c:numCache>
             </c:numRef>
-          </c:val>
+          </c:xVal>
+          <c:yVal>
+            <c:numRef>
+              <c:f>'Chart Data'!$B$2:$B$4</c:f>
+              <c:numCache>
+                <c:formatCode>0.000</c:formatCode>
+                <c:ptCount val="3"/>
+                <c:pt idx="0">
+                  <c:v>0.91</c:v>
+                </c:pt>
+                <c:pt idx="1">
+                  <c:v>0.90200000000000002</c:v>
+                </c:pt>
+                <c:pt idx="2">
+                  <c:v>0.89600000000000002</c:v>
+                </c:pt>
+              </c:numCache>
+            </c:numRef>
+          </c:yVal>
+          <c:smooth val="1"/>
           <c:extLst>
-            <c:ext xmlns:c14="http://schemas.microsoft.com/office/drawing/2007/8/2/chart" uri="{6F2FDCE9-48DA-4B69-8628-5D25D57E5C99}">
-              <c14:invertSolidFillFmt>
-                <c14:spPr xmlns:c14="http://schemas.microsoft.com/office/drawing/2007/8/2/chart">
-                  <a:solidFill>
-                    <a:srgbClr val="FFFFFF"/>
-                  </a:solidFill>
-                </c14:spPr>
-              </c14:invertSolidFillFmt>
-            </c:ext>
             <c:ext xmlns:c16="http://schemas.microsoft.com/office/drawing/2014/chart" uri="{C3380CC4-5D6E-409C-BE32-E72D297353CC}">
-              <c16:uniqueId val="{00000006-42F6-4757-868A-53025752E36A}"/>
+              <c16:uniqueId val="{00000003-DE7C-4D94-8E1B-0E6D337F9C00}"/>
             </c:ext>
           </c:extLst>
         </c:ser>
         <c:dLbls>
-          <c:dLblPos val="outEnd"/>
           <c:showLegendKey val="0"/>
-          <c:showVal val="1"/>
+          <c:showVal val="0"/>
           <c:showCatName val="0"/>
           <c:showSerName val="0"/>
           <c:showPercent val="0"/>
           <c:showBubbleSize val="0"/>
         </c:dLbls>
-        <c:gapWidth val="130"/>
         <c:axId val="48650112"/>
         <c:axId val="48672768"/>
-      </c:barChart>
-      <c:catAx>
+      </c:scatterChart>
+      <c:valAx>
+        <c:axId val="48672768"/>
+        <c:scaling>
+          <c:orientation val="minMax"/>
+          <c:max val="0.91500000000000004"/>
+          <c:min val="0.89"/>
+        </c:scaling>
+        <c:delete val="0"/>
+        <c:axPos val="l"/>
+        <c:majorGridlines>
+          <c:spPr>
+            <a:ln w="6668">
+              <a:solidFill>
+                <a:srgbClr val="CFD8D1"/>
+              </a:solidFill>
+            </a:ln>
+          </c:spPr>
+        </c:majorGridlines>
+        <c:numFmt formatCode="0.000" sourceLinked="1"/>
+        <c:majorTickMark val="none"/>
+        <c:minorTickMark val="none"/>
+        <c:tickLblPos val="nextTo"/>
+        <c:spPr>
+          <a:ln w="9525">
+            <a:solidFill>
+              <a:srgbClr val="CFD8D1"/>
+            </a:solidFill>
+          </a:ln>
+        </c:spPr>
+        <c:txPr>
+          <a:bodyPr anchorCtr="1"/>
+          <a:lstStyle/>
+          <a:p>
+            <a:pPr>
+              <a:defRPr sz="1725">
+                <a:solidFill>
+                  <a:srgbClr val="1E302F"/>
+                </a:solidFill>
+                <a:latin typeface="Noto Sans KR"/>
+                <a:ea typeface="Noto Sans KR"/>
+                <a:cs typeface="Noto Sans KR"/>
+              </a:defRPr>
+            </a:pPr>
+            <a:endParaRPr lang="ko-KR"/>
+          </a:p>
+        </c:txPr>
+        <c:crossAx val="48650112"/>
+        <c:crosses val="autoZero"/>
+        <c:crossBetween val="midCat"/>
+        <c:majorUnit val="5.0000000000000001E-3"/>
+      </c:valAx>
+      <c:valAx>
         <c:axId val="48650112"/>
         <c:scaling>
           <c:orientation val="minMax"/>
+          <c:max val="140"/>
+          <c:min val="40"/>
         </c:scaling>
         <c:delete val="0"/>
         <c:axPos val="b"/>
@@ -319,62 +426,8 @@
         </c:txPr>
         <c:crossAx val="48672768"/>
         <c:crosses val="autoZero"/>
-        <c:auto val="1"/>
-        <c:lblAlgn val="ctr"/>
-        <c:lblOffset val="100"/>
-        <c:noMultiLvlLbl val="1"/>
-      </c:catAx>
-      <c:valAx>
-        <c:axId val="48672768"/>
-        <c:scaling>
-          <c:orientation val="minMax"/>
-          <c:max val="140"/>
-          <c:min val="0"/>
-        </c:scaling>
-        <c:delete val="0"/>
-        <c:axPos val="l"/>
-        <c:majorGridlines>
-          <c:spPr>
-            <a:ln w="6668">
-              <a:solidFill>
-                <a:srgbClr val="CFD8D1"/>
-              </a:solidFill>
-            </a:ln>
-          </c:spPr>
-        </c:majorGridlines>
-        <c:numFmt formatCode="0" sourceLinked="1"/>
-        <c:majorTickMark val="none"/>
-        <c:minorTickMark val="none"/>
-        <c:tickLblPos val="nextTo"/>
-        <c:spPr>
-          <a:ln w="9525">
-            <a:solidFill>
-              <a:srgbClr val="D4D4D4"/>
-            </a:solidFill>
-            <a:prstDash val="solid"/>
-          </a:ln>
-        </c:spPr>
-        <c:txPr>
-          <a:bodyPr anchorCtr="1"/>
-          <a:lstStyle/>
-          <a:p>
-            <a:pPr>
-              <a:defRPr sz="1425">
-                <a:solidFill>
-                  <a:srgbClr val="586C68"/>
-                </a:solidFill>
-                <a:latin typeface="Noto Sans KR"/>
-                <a:ea typeface="Noto Sans KR"/>
-                <a:cs typeface="Noto Sans KR"/>
-              </a:defRPr>
-            </a:pPr>
-            <a:endParaRPr lang="ko-KR"/>
-          </a:p>
-        </c:txPr>
-        <c:crossAx val="48650112"/>
-        <c:crosses val="autoZero"/>
-        <c:crossBetween val="between"/>
-        <c:majorUnit val="40"/>
+        <c:crossBetween val="midCat"/>
+        <c:majorUnit val="20"/>
       </c:valAx>
       <c:spPr>
         <a:solidFill>
@@ -613,7 +666,7 @@
           <a:lstStyle/>
           <a:p>
             <a:r>
-              <a:t>30초. 모든 성능 수치는 사용자가 제공한 가상 예시이며 실험 결과가 아니다. 동일 장치와 데이터에서 비교한다는 조건만 주어졌으며 구체적인 장치와 데이터셋은 미제공이다. 표지는 AI가 만든 개념 이미지이며 모델 구조나 측정값이 아니다.</a:t>
+              <a:t>30초. 센서 이상 탐지 모델의 경량화를 살펴본다. 원본 모델과 INT8의 지연, F1, 크기를 같은 비중으로 비교한다. 모든 수치는 사용자가 제공한 가상 예시이며 실험 결과가 아니다. 동일 장치와 데이터를 가정하지만 구체적인 조건과 허용 F1 저하 기준은 미제공이다.</a:t>
             </a:r>
           </a:p>
         </p:txBody>
@@ -1311,37 +1364,12 @@
           <a:chExt cx="0" cy="0"/>
         </a:xfrm>
       </p:grpSpPr>
-      <p:pic>
-        <p:nvPicPr>
-          <p:cNvPr id="7" name="그림 6"/>
-          <p:cNvPicPr>
-            <a:picLocks noChangeAspect="1"/>
-          </p:cNvPicPr>
-          <p:nvPr/>
-        </p:nvPicPr>
-        <p:blipFill>
-          <a:blip r:embed="rId3"/>
-          <a:srcRect l="6092" r="6092"/>
-          <a:stretch>
-            <a:fillRect/>
-          </a:stretch>
-        </p:blipFill>
-        <p:spPr>
-          <a:xfrm>
-            <a:off x="7372350" y="0"/>
-            <a:ext cx="4819650" cy="6858000"/>
-          </a:xfrm>
-          <a:prstGeom prst="rect">
-            <a:avLst/>
-          </a:prstGeom>
-        </p:spPr>
-      </p:pic>
-      <p:sp>
-        <p:nvSpPr>
-          <p:cNvPr id="2" name="S01-section">
+      <p:sp>
+        <p:nvSpPr>
+          <p:cNvPr id="13" name="S01-section">
             <a:extLst>
               <a:ext uri="{FF2B5EF4-FFF2-40B4-BE49-F238E27FC236}">
-                <a16:creationId xmlns:a16="http://schemas.microsoft.com/office/drawing/2014/main" id="{EBE84B50-18DB-4993-8AEE-D88BC16297AD}"/>
+                <a16:creationId xmlns:a16="http://schemas.microsoft.com/office/drawing/2014/main" id="{420456A6-FCE9-4F6F-84C8-CF7264E539F3}"/>
               </a:ext>
             </a:extLst>
           </p:cNvPr>
@@ -1352,8 +1380,8 @@
         </p:nvSpPr>
         <p:spPr>
           <a:xfrm>
-            <a:off x="685800" y="590550"/>
-            <a:ext cx="6191250" cy="285750"/>
+            <a:off x="685800" y="609600"/>
+            <a:ext cx="10820400" cy="333375"/>
           </a:xfrm>
           <a:prstGeom prst="rect">
             <a:avLst/>
@@ -1370,9 +1398,9 @@
           <a:lstStyle/>
           <a:p>
             <a:pPr>
-              <a:defRPr sz="1425" b="0">
-                <a:solidFill>
-                  <a:srgbClr val="287D78"/>
+              <a:defRPr sz="1650" b="0">
+                <a:solidFill>
+                  <a:srgbClr val="586C68"/>
                 </a:solidFill>
                 <a:latin typeface="Noto Sans KR"/>
                 <a:ea typeface="Noto Sans KR"/>
@@ -1380,25 +1408,25 @@
               </a:defRPr>
             </a:pPr>
             <a:r>
-              <a:rPr sz="1425" b="0">
-                <a:solidFill>
-                  <a:srgbClr val="287D78"/>
+              <a:rPr sz="1650" b="0">
+                <a:solidFill>
+                  <a:srgbClr val="586C68"/>
                 </a:solidFill>
                 <a:latin typeface="Noto Sans KR"/>
                 <a:ea typeface="Noto Sans KR"/>
                 <a:cs typeface="Noto Sans KR"/>
               </a:rPr>
-              <a:t>연구 노트 / 01</a:t>
+              <a:t>연구실 세미나 · 5분</a:t>
             </a:r>
           </a:p>
         </p:txBody>
       </p:sp>
       <p:sp>
         <p:nvSpPr>
-          <p:cNvPr id="3" name="S01-title">
+          <p:cNvPr id="2" name="S01-title">
             <a:extLst>
               <a:ext uri="{FF2B5EF4-FFF2-40B4-BE49-F238E27FC236}">
-                <a16:creationId xmlns:a16="http://schemas.microsoft.com/office/drawing/2014/main" id="{1658625D-B341-4C6F-9392-4E85E4C9B858}"/>
+                <a16:creationId xmlns:a16="http://schemas.microsoft.com/office/drawing/2014/main" id="{B9AFD74C-2672-413F-8675-C61FF1B8F984}"/>
               </a:ext>
             </a:extLst>
           </p:cNvPr>
@@ -1409,8 +1437,8 @@
         </p:nvSpPr>
         <p:spPr>
           <a:xfrm>
-            <a:off x="685800" y="1895475"/>
-            <a:ext cx="6591300" cy="1600200"/>
+            <a:off x="685800" y="1438275"/>
+            <a:ext cx="10820400" cy="1476375"/>
           </a:xfrm>
           <a:prstGeom prst="rect">
             <a:avLst/>
@@ -1427,7 +1455,7 @@
           <a:lstStyle/>
           <a:p>
             <a:pPr>
-              <a:defRPr sz="4125" b="0">
+              <a:defRPr sz="4050" b="0">
                 <a:solidFill>
                   <a:srgbClr val="1E302F"/>
                 </a:solidFill>
@@ -1437,7 +1465,7 @@
               </a:defRPr>
             </a:pPr>
             <a:r>
-              <a:rPr sz="4125" b="0">
+              <a:rPr sz="4050" b="0">
                 <a:solidFill>
                   <a:srgbClr val="1E302F"/>
                 </a:solidFill>
@@ -1445,12 +1473,12 @@
                 <a:ea typeface="Noto Sans KR"/>
                 <a:cs typeface="Noto Sans KR"/>
               </a:rPr>
-              <a:t>센서 이상 탐지,</a:t>
+              <a:t>센서 이상 탐지 모델의</a:t>
             </a:r>
           </a:p>
           <a:p>
             <a:pPr>
-              <a:defRPr sz="4125" b="0">
+              <a:defRPr sz="4050" b="0">
                 <a:solidFill>
                   <a:srgbClr val="1E302F"/>
                 </a:solidFill>
@@ -1460,7 +1488,7 @@
               </a:defRPr>
             </a:pPr>
             <a:r>
-              <a:rPr sz="4125" b="0">
+              <a:rPr sz="4050" b="0">
                 <a:solidFill>
                   <a:srgbClr val="1E302F"/>
                 </a:solidFill>
@@ -1468,17 +1496,17 @@
                 <a:ea typeface="Noto Sans KR"/>
                 <a:cs typeface="Noto Sans KR"/>
               </a:rPr>
-              <a:t>더 가벼운 모델로</a:t>
+              <a:t>경량화와 성능 변화</a:t>
             </a:r>
           </a:p>
         </p:txBody>
       </p:sp>
       <p:sp>
         <p:nvSpPr>
-          <p:cNvPr id="4" name="S01-subtitle">
+          <p:cNvPr id="3" name="S01-subtitle">
             <a:extLst>
               <a:ext uri="{FF2B5EF4-FFF2-40B4-BE49-F238E27FC236}">
-                <a16:creationId xmlns:a16="http://schemas.microsoft.com/office/drawing/2014/main" id="{0CB11D18-532D-40C1-B28C-28A674766489}"/>
+                <a16:creationId xmlns:a16="http://schemas.microsoft.com/office/drawing/2014/main" id="{6ECF9552-EC94-4D59-B398-6D7B8A23CAA8}"/>
               </a:ext>
             </a:extLst>
           </p:cNvPr>
@@ -1489,8 +1517,8 @@
         </p:nvSpPr>
         <p:spPr>
           <a:xfrm>
-            <a:off x="723900" y="3905250"/>
-            <a:ext cx="6048375" cy="781050"/>
+            <a:off x="685800" y="3133725"/>
+            <a:ext cx="10820400" cy="495300"/>
           </a:xfrm>
           <a:prstGeom prst="rect">
             <a:avLst/>
@@ -1507,7 +1535,7 @@
           <a:lstStyle/>
           <a:p>
             <a:pPr>
-              <a:defRPr sz="2025" b="0">
+              <a:defRPr sz="2175" b="0">
                 <a:solidFill>
                   <a:srgbClr val="586C68"/>
                 </a:solidFill>
@@ -1517,7 +1545,7 @@
               </a:defRPr>
             </a:pPr>
             <a:r>
-              <a:rPr sz="2025" b="0">
+              <a:rPr sz="2175" b="0">
                 <a:solidFill>
                   <a:srgbClr val="586C68"/>
                 </a:solidFill>
@@ -1525,40 +1553,17 @@
                 <a:ea typeface="Noto Sans KR"/>
                 <a:cs typeface="Noto Sans KR"/>
               </a:rPr>
-              <a:t>지식 증류와 INT8 양자화의</a:t>
+              <a:t>지식 증류와 INT8 양자화</a:t>
             </a:r>
           </a:p>
-          <a:p>
-            <a:pPr>
-              <a:defRPr sz="2025" b="0">
-                <a:solidFill>
-                  <a:srgbClr val="586C68"/>
-                </a:solidFill>
-                <a:latin typeface="Noto Sans KR"/>
-                <a:ea typeface="Noto Sans KR"/>
-                <a:cs typeface="Noto Sans KR"/>
-              </a:defRPr>
-            </a:pPr>
-            <a:r>
-              <a:rPr sz="2025" b="0">
-                <a:solidFill>
-                  <a:srgbClr val="586C68"/>
-                </a:solidFill>
-                <a:latin typeface="Noto Sans KR"/>
-                <a:ea typeface="Noto Sans KR"/>
-                <a:cs typeface="Noto Sans KR"/>
-              </a:rPr>
-              <a:t>성능 교환관계</a:t>
-            </a:r>
-          </a:p>
-        </p:txBody>
-      </p:sp>
-      <p:sp>
-        <p:nvSpPr>
-          <p:cNvPr id="5" name="S01-context">
+        </p:txBody>
+      </p:sp>
+      <p:sp>
+        <p:nvSpPr>
+          <p:cNvPr id="4" name="S01-basis">
             <a:extLst>
               <a:ext uri="{FF2B5EF4-FFF2-40B4-BE49-F238E27FC236}">
-                <a16:creationId xmlns:a16="http://schemas.microsoft.com/office/drawing/2014/main" id="{2585B41B-2836-4641-9358-2FE41FFBA81C}"/>
+                <a16:creationId xmlns:a16="http://schemas.microsoft.com/office/drawing/2014/main" id="{B39041A1-C695-49C2-9A48-FF38407411D4}"/>
               </a:ext>
             </a:extLst>
           </p:cNvPr>
@@ -1569,8 +1574,8 @@
         </p:nvSpPr>
         <p:spPr>
           <a:xfrm>
-            <a:off x="723900" y="5410200"/>
-            <a:ext cx="5905500" cy="333375"/>
+            <a:off x="685800" y="4105275"/>
+            <a:ext cx="10820400" cy="342900"/>
           </a:xfrm>
           <a:prstGeom prst="rect">
             <a:avLst/>
@@ -1589,7 +1594,7 @@
             <a:pPr>
               <a:defRPr sz="1725" b="0">
                 <a:solidFill>
-                  <a:srgbClr val="1E302F"/>
+                  <a:srgbClr val="586C68"/>
                 </a:solidFill>
                 <a:latin typeface="Noto Sans KR"/>
                 <a:ea typeface="Noto Sans KR"/>
@@ -1599,23 +1604,23 @@
             <a:r>
               <a:rPr sz="1725" b="0">
                 <a:solidFill>
-                  <a:srgbClr val="1E302F"/>
+                  <a:srgbClr val="586C68"/>
                 </a:solidFill>
                 <a:latin typeface="Noto Sans KR"/>
                 <a:ea typeface="Noto Sans KR"/>
                 <a:cs typeface="Noto Sans KR"/>
               </a:rPr>
-              <a:t>연구실 세미나 · 5분</a:t>
+              <a:t>원본 모델과 INT8 비교</a:t>
             </a:r>
           </a:p>
         </p:txBody>
       </p:sp>
       <p:sp>
         <p:nvSpPr>
-          <p:cNvPr id="6" name="S01-disclosure">
+          <p:cNvPr id="5" name="S01-value-1">
             <a:extLst>
               <a:ext uri="{FF2B5EF4-FFF2-40B4-BE49-F238E27FC236}">
-                <a16:creationId xmlns:a16="http://schemas.microsoft.com/office/drawing/2014/main" id="{714D5C9C-708A-4478-AA3C-5216D23BF917}"/>
+                <a16:creationId xmlns:a16="http://schemas.microsoft.com/office/drawing/2014/main" id="{B2B09459-D43D-4E70-9665-D02E90A3FF5F}"/>
               </a:ext>
             </a:extLst>
           </p:cNvPr>
@@ -1626,8 +1631,8 @@
         </p:nvSpPr>
         <p:spPr>
           <a:xfrm>
-            <a:off x="723900" y="6343650"/>
-            <a:ext cx="6191250" cy="247650"/>
+            <a:off x="685800" y="4619625"/>
+            <a:ext cx="2952750" cy="628650"/>
           </a:xfrm>
           <a:prstGeom prst="rect">
             <a:avLst/>
@@ -1644,6 +1649,348 @@
           <a:lstStyle/>
           <a:p>
             <a:pPr>
+              <a:defRPr sz="3225" b="0">
+                <a:solidFill>
+                  <a:srgbClr val="1E302F"/>
+                </a:solidFill>
+                <a:latin typeface="Noto Sans KR"/>
+                <a:ea typeface="Noto Sans KR"/>
+                <a:cs typeface="Noto Sans KR"/>
+              </a:defRPr>
+            </a:pPr>
+            <a:r>
+              <a:rPr sz="3225" b="0">
+                <a:solidFill>
+                  <a:srgbClr val="1E302F"/>
+                </a:solidFill>
+                <a:latin typeface="Noto Sans KR"/>
+                <a:ea typeface="Noto Sans KR"/>
+                <a:cs typeface="Noto Sans KR"/>
+              </a:rPr>
+              <a:t>120 → 54</a:t>
+            </a:r>
+          </a:p>
+        </p:txBody>
+      </p:sp>
+      <p:sp>
+        <p:nvSpPr>
+          <p:cNvPr id="6" name="S01-label-1">
+            <a:extLst>
+              <a:ext uri="{FF2B5EF4-FFF2-40B4-BE49-F238E27FC236}">
+                <a16:creationId xmlns:a16="http://schemas.microsoft.com/office/drawing/2014/main" id="{B98F8C9A-543B-4ED7-BED6-EFE72739E5EC}"/>
+              </a:ext>
+            </a:extLst>
+          </p:cNvPr>
+          <p:cNvSpPr>
+            <a:spLocks noGrp="1"/>
+          </p:cNvSpPr>
+          <p:nvPr/>
+        </p:nvSpPr>
+        <p:spPr>
+          <a:xfrm>
+            <a:off x="685800" y="5314950"/>
+            <a:ext cx="3143250" cy="361950"/>
+          </a:xfrm>
+          <a:prstGeom prst="rect">
+            <a:avLst/>
+          </a:prstGeom>
+          <a:noFill/>
+          <a:ln w="0">
+            <a:noFill/>
+          </a:ln>
+        </p:spPr>
+        <p:txBody>
+          <a:bodyPr wrap="none" lIns="0" tIns="0" rIns="0" bIns="0" anchor="ctr">
+            <a:noAutofit/>
+          </a:bodyPr>
+          <a:lstStyle/>
+          <a:p>
+            <a:pPr>
+              <a:defRPr sz="1800" b="0">
+                <a:solidFill>
+                  <a:srgbClr val="586C68"/>
+                </a:solidFill>
+                <a:latin typeface="Noto Sans KR"/>
+                <a:ea typeface="Noto Sans KR"/>
+                <a:cs typeface="Noto Sans KR"/>
+              </a:defRPr>
+            </a:pPr>
+            <a:r>
+              <a:rPr sz="1800" b="0">
+                <a:solidFill>
+                  <a:srgbClr val="586C68"/>
+                </a:solidFill>
+                <a:latin typeface="Noto Sans KR"/>
+                <a:ea typeface="Noto Sans KR"/>
+                <a:cs typeface="Noto Sans KR"/>
+              </a:rPr>
+              <a:t>지연 (ms)</a:t>
+            </a:r>
+          </a:p>
+        </p:txBody>
+      </p:sp>
+      <p:sp>
+        <p:nvSpPr>
+          <p:cNvPr id="7" name="S01-value-2">
+            <a:extLst>
+              <a:ext uri="{FF2B5EF4-FFF2-40B4-BE49-F238E27FC236}">
+                <a16:creationId xmlns:a16="http://schemas.microsoft.com/office/drawing/2014/main" id="{4DB64A30-8BA9-4D49-918B-5BEADF5DBD5A}"/>
+              </a:ext>
+            </a:extLst>
+          </p:cNvPr>
+          <p:cNvSpPr>
+            <a:spLocks noGrp="1"/>
+          </p:cNvSpPr>
+          <p:nvPr/>
+        </p:nvSpPr>
+        <p:spPr>
+          <a:xfrm>
+            <a:off x="4419600" y="4619625"/>
+            <a:ext cx="3810000" cy="628650"/>
+          </a:xfrm>
+          <a:prstGeom prst="rect">
+            <a:avLst/>
+          </a:prstGeom>
+          <a:noFill/>
+          <a:ln w="0">
+            <a:noFill/>
+          </a:ln>
+        </p:spPr>
+        <p:txBody>
+          <a:bodyPr wrap="none" lIns="0" tIns="0" rIns="0" bIns="0" anchor="ctr">
+            <a:noAutofit/>
+          </a:bodyPr>
+          <a:lstStyle/>
+          <a:p>
+            <a:pPr>
+              <a:defRPr sz="3225" b="0">
+                <a:solidFill>
+                  <a:srgbClr val="1E302F"/>
+                </a:solidFill>
+                <a:latin typeface="Noto Sans KR"/>
+                <a:ea typeface="Noto Sans KR"/>
+                <a:cs typeface="Noto Sans KR"/>
+              </a:defRPr>
+            </a:pPr>
+            <a:r>
+              <a:rPr sz="3225" b="0">
+                <a:solidFill>
+                  <a:srgbClr val="1E302F"/>
+                </a:solidFill>
+                <a:latin typeface="Noto Sans KR"/>
+                <a:ea typeface="Noto Sans KR"/>
+                <a:cs typeface="Noto Sans KR"/>
+              </a:rPr>
+              <a:t>0.910 → 0.896</a:t>
+            </a:r>
+          </a:p>
+        </p:txBody>
+      </p:sp>
+      <p:sp>
+        <p:nvSpPr>
+          <p:cNvPr id="8" name="S01-label-2">
+            <a:extLst>
+              <a:ext uri="{FF2B5EF4-FFF2-40B4-BE49-F238E27FC236}">
+                <a16:creationId xmlns:a16="http://schemas.microsoft.com/office/drawing/2014/main" id="{B900C037-6942-44D1-A0F7-B92FF7473D2F}"/>
+              </a:ext>
+            </a:extLst>
+          </p:cNvPr>
+          <p:cNvSpPr>
+            <a:spLocks noGrp="1"/>
+          </p:cNvSpPr>
+          <p:nvPr/>
+        </p:nvSpPr>
+        <p:spPr>
+          <a:xfrm>
+            <a:off x="4419600" y="5314950"/>
+            <a:ext cx="3143250" cy="361950"/>
+          </a:xfrm>
+          <a:prstGeom prst="rect">
+            <a:avLst/>
+          </a:prstGeom>
+          <a:noFill/>
+          <a:ln w="0">
+            <a:noFill/>
+          </a:ln>
+        </p:spPr>
+        <p:txBody>
+          <a:bodyPr wrap="none" lIns="0" tIns="0" rIns="0" bIns="0" anchor="ctr">
+            <a:noAutofit/>
+          </a:bodyPr>
+          <a:lstStyle/>
+          <a:p>
+            <a:pPr>
+              <a:defRPr sz="1800" b="0">
+                <a:solidFill>
+                  <a:srgbClr val="586C68"/>
+                </a:solidFill>
+                <a:latin typeface="Noto Sans KR"/>
+                <a:ea typeface="Noto Sans KR"/>
+                <a:cs typeface="Noto Sans KR"/>
+              </a:defRPr>
+            </a:pPr>
+            <a:r>
+              <a:rPr sz="1800" b="0">
+                <a:solidFill>
+                  <a:srgbClr val="586C68"/>
+                </a:solidFill>
+                <a:latin typeface="Noto Sans KR"/>
+                <a:ea typeface="Noto Sans KR"/>
+                <a:cs typeface="Noto Sans KR"/>
+              </a:rPr>
+              <a:t>F1</a:t>
+            </a:r>
+          </a:p>
+        </p:txBody>
+      </p:sp>
+      <p:sp>
+        <p:nvSpPr>
+          <p:cNvPr id="9" name="S01-value-3">
+            <a:extLst>
+              <a:ext uri="{FF2B5EF4-FFF2-40B4-BE49-F238E27FC236}">
+                <a16:creationId xmlns:a16="http://schemas.microsoft.com/office/drawing/2014/main" id="{A2B3E276-77D2-4999-8780-60E24892F8EC}"/>
+              </a:ext>
+            </a:extLst>
+          </p:cNvPr>
+          <p:cNvSpPr>
+            <a:spLocks noGrp="1"/>
+          </p:cNvSpPr>
+          <p:nvPr/>
+        </p:nvSpPr>
+        <p:spPr>
+          <a:xfrm>
+            <a:off x="8572500" y="4619625"/>
+            <a:ext cx="2952750" cy="628650"/>
+          </a:xfrm>
+          <a:prstGeom prst="rect">
+            <a:avLst/>
+          </a:prstGeom>
+          <a:noFill/>
+          <a:ln w="0">
+            <a:noFill/>
+          </a:ln>
+        </p:spPr>
+        <p:txBody>
+          <a:bodyPr wrap="none" lIns="0" tIns="0" rIns="0" bIns="0" anchor="ctr">
+            <a:noAutofit/>
+          </a:bodyPr>
+          <a:lstStyle/>
+          <a:p>
+            <a:pPr>
+              <a:defRPr sz="3225" b="0">
+                <a:solidFill>
+                  <a:srgbClr val="1E302F"/>
+                </a:solidFill>
+                <a:latin typeface="Noto Sans KR"/>
+                <a:ea typeface="Noto Sans KR"/>
+                <a:cs typeface="Noto Sans KR"/>
+              </a:defRPr>
+            </a:pPr>
+            <a:r>
+              <a:rPr sz="3225" b="0">
+                <a:solidFill>
+                  <a:srgbClr val="1E302F"/>
+                </a:solidFill>
+                <a:latin typeface="Noto Sans KR"/>
+                <a:ea typeface="Noto Sans KR"/>
+                <a:cs typeface="Noto Sans KR"/>
+              </a:rPr>
+              <a:t>48 → 12</a:t>
+            </a:r>
+          </a:p>
+        </p:txBody>
+      </p:sp>
+      <p:sp>
+        <p:nvSpPr>
+          <p:cNvPr id="10" name="S01-label-3">
+            <a:extLst>
+              <a:ext uri="{FF2B5EF4-FFF2-40B4-BE49-F238E27FC236}">
+                <a16:creationId xmlns:a16="http://schemas.microsoft.com/office/drawing/2014/main" id="{4E6EA8CD-99F8-4802-8730-F57527EF34AD}"/>
+              </a:ext>
+            </a:extLst>
+          </p:cNvPr>
+          <p:cNvSpPr>
+            <a:spLocks noGrp="1"/>
+          </p:cNvSpPr>
+          <p:nvPr/>
+        </p:nvSpPr>
+        <p:spPr>
+          <a:xfrm>
+            <a:off x="8572500" y="5314950"/>
+            <a:ext cx="3143250" cy="361950"/>
+          </a:xfrm>
+          <a:prstGeom prst="rect">
+            <a:avLst/>
+          </a:prstGeom>
+          <a:noFill/>
+          <a:ln w="0">
+            <a:noFill/>
+          </a:ln>
+        </p:spPr>
+        <p:txBody>
+          <a:bodyPr wrap="none" lIns="0" tIns="0" rIns="0" bIns="0" anchor="ctr">
+            <a:noAutofit/>
+          </a:bodyPr>
+          <a:lstStyle/>
+          <a:p>
+            <a:pPr>
+              <a:defRPr sz="1800" b="0">
+                <a:solidFill>
+                  <a:srgbClr val="586C68"/>
+                </a:solidFill>
+                <a:latin typeface="Noto Sans KR"/>
+                <a:ea typeface="Noto Sans KR"/>
+                <a:cs typeface="Noto Sans KR"/>
+              </a:defRPr>
+            </a:pPr>
+            <a:r>
+              <a:rPr sz="1800" b="0">
+                <a:solidFill>
+                  <a:srgbClr val="586C68"/>
+                </a:solidFill>
+                <a:latin typeface="Noto Sans KR"/>
+                <a:ea typeface="Noto Sans KR"/>
+                <a:cs typeface="Noto Sans KR"/>
+              </a:rPr>
+              <a:t>모델 크기 (MB)</a:t>
+            </a:r>
+          </a:p>
+        </p:txBody>
+      </p:sp>
+      <p:sp>
+        <p:nvSpPr>
+          <p:cNvPr id="11" name="S01-disclosure">
+            <a:extLst>
+              <a:ext uri="{FF2B5EF4-FFF2-40B4-BE49-F238E27FC236}">
+                <a16:creationId xmlns:a16="http://schemas.microsoft.com/office/drawing/2014/main" id="{5BA00A58-6419-4154-8F11-0C1C8EDA1169}"/>
+              </a:ext>
+            </a:extLst>
+          </p:cNvPr>
+          <p:cNvSpPr>
+            <a:spLocks noGrp="1"/>
+          </p:cNvSpPr>
+          <p:nvPr/>
+        </p:nvSpPr>
+        <p:spPr>
+          <a:xfrm>
+            <a:off x="685800" y="6372225"/>
+            <a:ext cx="9525000" cy="219075"/>
+          </a:xfrm>
+          <a:prstGeom prst="rect">
+            <a:avLst/>
+          </a:prstGeom>
+          <a:noFill/>
+          <a:ln w="0">
+            <a:noFill/>
+          </a:ln>
+        </p:spPr>
+        <p:txBody>
+          <a:bodyPr wrap="none" lIns="0" tIns="0" rIns="0" bIns="0" anchor="ctr">
+            <a:noAutofit/>
+          </a:bodyPr>
+          <a:lstStyle/>
+          <a:p>
+            <a:pPr>
               <a:defRPr sz="1275" b="0">
                 <a:solidFill>
                   <a:srgbClr val="586C68"/>
@@ -1667,10 +2014,67 @@
           </a:p>
         </p:txBody>
       </p:sp>
+      <p:sp>
+        <p:nvSpPr>
+          <p:cNvPr id="12" name="S01-number">
+            <a:extLst>
+              <a:ext uri="{FF2B5EF4-FFF2-40B4-BE49-F238E27FC236}">
+                <a16:creationId xmlns:a16="http://schemas.microsoft.com/office/drawing/2014/main" id="{E415156A-AD7E-4EFA-A4EA-0B630654AD8D}"/>
+              </a:ext>
+            </a:extLst>
+          </p:cNvPr>
+          <p:cNvSpPr>
+            <a:spLocks noGrp="1"/>
+          </p:cNvSpPr>
+          <p:nvPr/>
+        </p:nvSpPr>
+        <p:spPr>
+          <a:xfrm>
+            <a:off x="11144250" y="6372225"/>
+            <a:ext cx="361950" cy="219075"/>
+          </a:xfrm>
+          <a:prstGeom prst="rect">
+            <a:avLst/>
+          </a:prstGeom>
+          <a:noFill/>
+          <a:ln w="0">
+            <a:noFill/>
+          </a:ln>
+        </p:spPr>
+        <p:txBody>
+          <a:bodyPr wrap="none" lIns="0" tIns="0" rIns="0" bIns="0" anchor="ctr">
+            <a:noAutofit/>
+          </a:bodyPr>
+          <a:lstStyle/>
+          <a:p>
+            <a:pPr>
+              <a:defRPr sz="1275" b="0">
+                <a:solidFill>
+                  <a:srgbClr val="586C68"/>
+                </a:solidFill>
+                <a:latin typeface="Noto Sans KR"/>
+                <a:ea typeface="Noto Sans KR"/>
+                <a:cs typeface="Noto Sans KR"/>
+              </a:defRPr>
+            </a:pPr>
+            <a:r>
+              <a:rPr sz="1275" b="0">
+                <a:solidFill>
+                  <a:srgbClr val="586C68"/>
+                </a:solidFill>
+                <a:latin typeface="Noto Sans KR"/>
+                <a:ea typeface="Noto Sans KR"/>
+                <a:cs typeface="Noto Sans KR"/>
+              </a:rPr>
+              <a:t>01</a:t>
+            </a:r>
+          </a:p>
+        </p:txBody>
+      </p:sp>
     </p:spTree>
     <p:extLst>
       <p:ext uri="{BB962C8B-B14F-4D97-AF65-F5344CB8AC3E}">
-        <p14:creationId xmlns:p14="http://schemas.microsoft.com/office/powerpoint/2010/main" val="875799115"/>
+        <p14:creationId xmlns:p14="http://schemas.microsoft.com/office/powerpoint/2010/main" val="626593417"/>
       </p:ext>
     </p:extLst>
   </p:cSld>
@@ -1707,67 +2111,10 @@
       </p:grpSpPr>
       <p:sp>
         <p:nvSpPr>
-          <p:cNvPr id="22" name="S02-section">
+          <p:cNvPr id="21" name="S02-title">
             <a:extLst>
               <a:ext uri="{FF2B5EF4-FFF2-40B4-BE49-F238E27FC236}">
-                <a16:creationId xmlns:a16="http://schemas.microsoft.com/office/drawing/2014/main" id="{D477D5D5-7C51-4D1F-9754-6FD07C13BF92}"/>
-              </a:ext>
-            </a:extLst>
-          </p:cNvPr>
-          <p:cNvSpPr>
-            <a:spLocks noGrp="1"/>
-          </p:cNvSpPr>
-          <p:nvPr/>
-        </p:nvSpPr>
-        <p:spPr>
-          <a:xfrm>
-            <a:off x="685800" y="400050"/>
-            <a:ext cx="10744200" cy="257175"/>
-          </a:xfrm>
-          <a:prstGeom prst="rect">
-            <a:avLst/>
-          </a:prstGeom>
-          <a:noFill/>
-          <a:ln w="0">
-            <a:noFill/>
-          </a:ln>
-        </p:spPr>
-        <p:txBody>
-          <a:bodyPr wrap="none" lIns="0" tIns="0" rIns="0" bIns="0" anchor="ctr">
-            <a:noAutofit/>
-          </a:bodyPr>
-          <a:lstStyle/>
-          <a:p>
-            <a:pPr>
-              <a:defRPr sz="1425" b="0">
-                <a:solidFill>
-                  <a:srgbClr val="287D78"/>
-                </a:solidFill>
-                <a:latin typeface="Noto Sans KR"/>
-                <a:ea typeface="Noto Sans KR"/>
-                <a:cs typeface="Noto Sans KR"/>
-              </a:defRPr>
-            </a:pPr>
-            <a:r>
-              <a:rPr sz="1425" b="0">
-                <a:solidFill>
-                  <a:srgbClr val="287D78"/>
-                </a:solidFill>
-                <a:latin typeface="Noto Sans KR"/>
-                <a:ea typeface="Noto Sans KR"/>
-                <a:cs typeface="Noto Sans KR"/>
-              </a:rPr>
-              <a:t>방법 / 두 단계의 경량화</a:t>
-            </a:r>
-          </a:p>
-        </p:txBody>
-      </p:sp>
-      <p:sp>
-        <p:nvSpPr>
-          <p:cNvPr id="2" name="S02-title">
-            <a:extLst>
-              <a:ext uri="{FF2B5EF4-FFF2-40B4-BE49-F238E27FC236}">
-                <a16:creationId xmlns:a16="http://schemas.microsoft.com/office/drawing/2014/main" id="{F70F26EA-EAF1-45D1-B0D0-60E534FFD159}"/>
+                <a16:creationId xmlns:a16="http://schemas.microsoft.com/office/drawing/2014/main" id="{6BD0F392-7E29-44F0-8FE9-1D5672BE93AF}"/>
               </a:ext>
             </a:extLst>
           </p:cNvPr>
@@ -1814,17 +2161,17 @@
                 <a:ea typeface="Noto Sans KR"/>
                 <a:cs typeface="Noto Sans KR"/>
               </a:rPr>
-              <a:t>교사 모델에서 경량 학생 모델로</a:t>
+              <a:t>모델과 경량화 과정</a:t>
             </a:r>
           </a:p>
         </p:txBody>
       </p:sp>
       <p:sp>
         <p:nvSpPr>
-          <p:cNvPr id="3" name="S02-disclosure">
+          <p:cNvPr id="2" name="S02-disclosure">
             <a:extLst>
               <a:ext uri="{FF2B5EF4-FFF2-40B4-BE49-F238E27FC236}">
-                <a16:creationId xmlns:a16="http://schemas.microsoft.com/office/drawing/2014/main" id="{91B307CD-364F-433B-B440-B52C40D46A23}"/>
+                <a16:creationId xmlns:a16="http://schemas.microsoft.com/office/drawing/2014/main" id="{6EFE154F-3F7E-45BF-A3E5-BE8FF3038D35}"/>
               </a:ext>
             </a:extLst>
           </p:cNvPr>
@@ -1878,10 +2225,10 @@
       </p:sp>
       <p:sp>
         <p:nvSpPr>
-          <p:cNvPr id="4" name="S02-number">
+          <p:cNvPr id="3" name="S02-number">
             <a:extLst>
               <a:ext uri="{FF2B5EF4-FFF2-40B4-BE49-F238E27FC236}">
-                <a16:creationId xmlns:a16="http://schemas.microsoft.com/office/drawing/2014/main" id="{285D16D6-8E97-4EB5-9082-C7619E498210}"/>
+                <a16:creationId xmlns:a16="http://schemas.microsoft.com/office/drawing/2014/main" id="{289D943D-7D98-4F28-BC46-07F21B389451}"/>
               </a:ext>
             </a:extLst>
           </p:cNvPr>
@@ -1935,10 +2282,10 @@
       </p:sp>
       <p:sp>
         <p:nvSpPr>
-          <p:cNvPr id="5" name="S02-marker-1">
+          <p:cNvPr id="4" name="S02-marker-1">
             <a:extLst>
               <a:ext uri="{FF2B5EF4-FFF2-40B4-BE49-F238E27FC236}">
-                <a16:creationId xmlns:a16="http://schemas.microsoft.com/office/drawing/2014/main" id="{3E0BA238-CE3C-4056-B282-F070E4F0B9D4}"/>
+                <a16:creationId xmlns:a16="http://schemas.microsoft.com/office/drawing/2014/main" id="{96F4F6E2-1A66-47D3-ACEF-D193B4436C57}"/>
               </a:ext>
             </a:extLst>
           </p:cNvPr>
@@ -1992,10 +2339,10 @@
       </p:sp>
       <p:sp>
         <p:nvSpPr>
-          <p:cNvPr id="6" name="S02-marker-2">
+          <p:cNvPr id="5" name="S02-marker-2">
             <a:extLst>
               <a:ext uri="{FF2B5EF4-FFF2-40B4-BE49-F238E27FC236}">
-                <a16:creationId xmlns:a16="http://schemas.microsoft.com/office/drawing/2014/main" id="{16330369-0975-4DCE-BC13-78492A169E3E}"/>
+                <a16:creationId xmlns:a16="http://schemas.microsoft.com/office/drawing/2014/main" id="{F6496AC7-EA7C-4FC3-8A3F-2D911782723D}"/>
               </a:ext>
             </a:extLst>
           </p:cNvPr>
@@ -2049,10 +2396,10 @@
       </p:sp>
       <p:sp>
         <p:nvSpPr>
-          <p:cNvPr id="7" name="S02-marker-3">
+          <p:cNvPr id="6" name="S02-marker-3">
             <a:extLst>
               <a:ext uri="{FF2B5EF4-FFF2-40B4-BE49-F238E27FC236}">
-                <a16:creationId xmlns:a16="http://schemas.microsoft.com/office/drawing/2014/main" id="{F5CBCF1D-B475-4DE5-BC7B-D92543D7B69D}"/>
+                <a16:creationId xmlns:a16="http://schemas.microsoft.com/office/drawing/2014/main" id="{0A9B6237-08C8-422B-8350-9D20D6A4E836}"/>
               </a:ext>
             </a:extLst>
           </p:cNvPr>
@@ -2106,7 +2453,32 @@
       </p:sp>
       <p:cxnSp>
         <p:nvCxnSpPr>
-          <p:cNvPr id="29" name="S02-link-2"/>
+          <p:cNvPr id="27" name="S02-link-2"/>
+          <p:cNvCxnSpPr>
+            <a:stCxn id="4" idx="6"/>
+            <a:endCxn id="5" idx="2"/>
+          </p:cNvCxnSpPr>
+          <p:nvPr/>
+        </p:nvCxnSpPr>
+        <p:spPr>
+          <a:xfrm>
+            <a:off x="1219200" y="2600325"/>
+            <a:ext cx="3429000" cy="0"/>
+          </a:xfrm>
+          <a:prstGeom prst="straightConnector1">
+            <a:avLst/>
+          </a:prstGeom>
+          <a:ln w="17145">
+            <a:solidFill>
+              <a:srgbClr val="9EADA5"/>
+            </a:solidFill>
+            <a:tailEnd type="triangle" w="sm" len="sm"/>
+          </a:ln>
+        </p:spPr>
+      </p:cxnSp>
+      <p:cxnSp>
+        <p:nvCxnSpPr>
+          <p:cNvPr id="28" name="S02-link-3"/>
           <p:cNvCxnSpPr>
             <a:stCxn id="5" idx="6"/>
             <a:endCxn id="6" idx="2"/>
@@ -2115,7 +2487,7 @@
         </p:nvCxnSpPr>
         <p:spPr>
           <a:xfrm>
-            <a:off x="1219200" y="2600325"/>
+            <a:off x="5181600" y="2600325"/>
             <a:ext cx="3429000" cy="0"/>
           </a:xfrm>
           <a:prstGeom prst="straightConnector1">
@@ -2129,37 +2501,12 @@
           </a:ln>
         </p:spPr>
       </p:cxnSp>
-      <p:cxnSp>
-        <p:nvCxnSpPr>
-          <p:cNvPr id="30" name="S02-link-3"/>
-          <p:cNvCxnSpPr>
-            <a:stCxn id="6" idx="6"/>
-            <a:endCxn id="7" idx="2"/>
-          </p:cNvCxnSpPr>
-          <p:nvPr/>
-        </p:nvCxnSpPr>
-        <p:spPr>
-          <a:xfrm>
-            <a:off x="5181600" y="2600325"/>
-            <a:ext cx="3429000" cy="0"/>
-          </a:xfrm>
-          <a:prstGeom prst="straightConnector1">
-            <a:avLst/>
-          </a:prstGeom>
-          <a:ln w="17145">
-            <a:solidFill>
-              <a:srgbClr val="9EADA5"/>
-            </a:solidFill>
-            <a:tailEnd type="triangle" w="sm" len="sm"/>
-          </a:ln>
-        </p:spPr>
-      </p:cxnSp>
-      <p:sp>
-        <p:nvSpPr>
-          <p:cNvPr id="10" name="S02-flow-2">
+      <p:sp>
+        <p:nvSpPr>
+          <p:cNvPr id="9" name="S02-flow-2">
             <a:extLst>
               <a:ext uri="{FF2B5EF4-FFF2-40B4-BE49-F238E27FC236}">
-                <a16:creationId xmlns:a16="http://schemas.microsoft.com/office/drawing/2014/main" id="{639AEF92-B0AE-4D7D-A8A9-D6C507E72098}"/>
+                <a16:creationId xmlns:a16="http://schemas.microsoft.com/office/drawing/2014/main" id="{5CD9262E-1877-45DF-8C35-1383DB28BD36}"/>
               </a:ext>
             </a:extLst>
           </p:cNvPr>
@@ -2206,17 +2553,17 @@
                 <a:ea typeface="Noto Sans KR"/>
                 <a:cs typeface="Noto Sans KR"/>
               </a:rPr>
-              <a:t>예측 지식 전달</a:t>
+              <a:t>지식 증류</a:t>
             </a:r>
           </a:p>
         </p:txBody>
       </p:sp>
       <p:sp>
         <p:nvSpPr>
-          <p:cNvPr id="11" name="S02-flow-3">
+          <p:cNvPr id="10" name="S02-flow-3">
             <a:extLst>
               <a:ext uri="{FF2B5EF4-FFF2-40B4-BE49-F238E27FC236}">
-                <a16:creationId xmlns:a16="http://schemas.microsoft.com/office/drawing/2014/main" id="{F213E77E-B619-44BC-ADE6-7FACCCDE1E40}"/>
+                <a16:creationId xmlns:a16="http://schemas.microsoft.com/office/drawing/2014/main" id="{216D3EC5-F0D5-4E19-9E29-F8030FDCCC2B}"/>
               </a:ext>
             </a:extLst>
           </p:cNvPr>
@@ -2263,17 +2610,17 @@
                 <a:ea typeface="Noto Sans KR"/>
                 <a:cs typeface="Noto Sans KR"/>
               </a:rPr>
-              <a:t>수치 표현 변환</a:t>
+              <a:t>INT8 양자화</a:t>
             </a:r>
           </a:p>
         </p:txBody>
       </p:sp>
       <p:sp>
         <p:nvSpPr>
-          <p:cNvPr id="12" name="S02-stage-1">
+          <p:cNvPr id="11" name="S02-stage-1">
             <a:extLst>
               <a:ext uri="{FF2B5EF4-FFF2-40B4-BE49-F238E27FC236}">
-                <a16:creationId xmlns:a16="http://schemas.microsoft.com/office/drawing/2014/main" id="{3B255748-8C92-4116-80C5-4B5E2609D900}"/>
+                <a16:creationId xmlns:a16="http://schemas.microsoft.com/office/drawing/2014/main" id="{E9DFB455-BDD4-4253-894D-655A4272A29D}"/>
               </a:ext>
             </a:extLst>
           </p:cNvPr>
@@ -2320,17 +2667,17 @@
                 <a:ea typeface="Noto Sans KR"/>
                 <a:cs typeface="Noto Sans KR"/>
               </a:rPr>
-              <a:t>원본 모델</a:t>
+              <a:t>교사 모델</a:t>
             </a:r>
           </a:p>
         </p:txBody>
       </p:sp>
       <p:sp>
         <p:nvSpPr>
-          <p:cNvPr id="13" name="S02-name-1">
+          <p:cNvPr id="12" name="S02-name-1">
             <a:extLst>
               <a:ext uri="{FF2B5EF4-FFF2-40B4-BE49-F238E27FC236}">
-                <a16:creationId xmlns:a16="http://schemas.microsoft.com/office/drawing/2014/main" id="{A0B32358-522A-4BA5-BCDC-B4E517EE2F5A}"/>
+                <a16:creationId xmlns:a16="http://schemas.microsoft.com/office/drawing/2014/main" id="{9A89A7D0-CB6D-447A-A7BD-E95593B1F691}"/>
               </a:ext>
             </a:extLst>
           </p:cNvPr>
@@ -2384,10 +2731,10 @@
       </p:sp>
       <p:sp>
         <p:nvSpPr>
-          <p:cNvPr id="14" name="S02-detail-1">
+          <p:cNvPr id="13" name="S02-detail-1">
             <a:extLst>
               <a:ext uri="{FF2B5EF4-FFF2-40B4-BE49-F238E27FC236}">
-                <a16:creationId xmlns:a16="http://schemas.microsoft.com/office/drawing/2014/main" id="{8163D1DC-96EF-4ED4-8579-637CFF611AFD}"/>
+                <a16:creationId xmlns:a16="http://schemas.microsoft.com/office/drawing/2014/main" id="{6FA47F22-2A7B-4B45-AAD1-C50EEB9ADC3C}"/>
               </a:ext>
             </a:extLst>
           </p:cNvPr>
@@ -2464,10 +2811,10 @@
       </p:sp>
       <p:sp>
         <p:nvSpPr>
-          <p:cNvPr id="15" name="S02-stage-2">
+          <p:cNvPr id="14" name="S02-stage-2">
             <a:extLst>
               <a:ext uri="{FF2B5EF4-FFF2-40B4-BE49-F238E27FC236}">
-                <a16:creationId xmlns:a16="http://schemas.microsoft.com/office/drawing/2014/main" id="{EC6DF5DA-CB92-447B-824F-1136A9473C88}"/>
+                <a16:creationId xmlns:a16="http://schemas.microsoft.com/office/drawing/2014/main" id="{7B08D215-FA56-4B33-9119-7F2EEA786251}"/>
               </a:ext>
             </a:extLst>
           </p:cNvPr>
@@ -2514,17 +2861,17 @@
                 <a:ea typeface="Noto Sans KR"/>
                 <a:cs typeface="Noto Sans KR"/>
               </a:rPr>
-              <a:t>지식 증류</a:t>
+              <a:t>학생 모델</a:t>
             </a:r>
           </a:p>
         </p:txBody>
       </p:sp>
       <p:sp>
         <p:nvSpPr>
-          <p:cNvPr id="16" name="S02-name-2">
+          <p:cNvPr id="15" name="S02-name-2">
             <a:extLst>
               <a:ext uri="{FF2B5EF4-FFF2-40B4-BE49-F238E27FC236}">
-                <a16:creationId xmlns:a16="http://schemas.microsoft.com/office/drawing/2014/main" id="{3F995C22-AFC7-4DFD-908B-E11D787E3A71}"/>
+                <a16:creationId xmlns:a16="http://schemas.microsoft.com/office/drawing/2014/main" id="{E76094DB-3A7D-4526-9A34-02B28F700684}"/>
               </a:ext>
             </a:extLst>
           </p:cNvPr>
@@ -2578,10 +2925,10 @@
       </p:sp>
       <p:sp>
         <p:nvSpPr>
-          <p:cNvPr id="17" name="S02-detail-2">
+          <p:cNvPr id="16" name="S02-detail-2">
             <a:extLst>
               <a:ext uri="{FF2B5EF4-FFF2-40B4-BE49-F238E27FC236}">
-                <a16:creationId xmlns:a16="http://schemas.microsoft.com/office/drawing/2014/main" id="{3CBB847B-6A61-4C2B-9AB9-6D2F44CD338B}"/>
+                <a16:creationId xmlns:a16="http://schemas.microsoft.com/office/drawing/2014/main" id="{AD69CC82-A32F-4BCC-A3CF-2A2D8573CFB3}"/>
               </a:ext>
             </a:extLst>
           </p:cNvPr>
@@ -2658,10 +3005,10 @@
       </p:sp>
       <p:sp>
         <p:nvSpPr>
-          <p:cNvPr id="18" name="S02-stage-3">
+          <p:cNvPr id="17" name="S02-stage-3">
             <a:extLst>
               <a:ext uri="{FF2B5EF4-FFF2-40B4-BE49-F238E27FC236}">
-                <a16:creationId xmlns:a16="http://schemas.microsoft.com/office/drawing/2014/main" id="{82B7BC8E-9832-48D3-8016-25E9CB8E30CA}"/>
+                <a16:creationId xmlns:a16="http://schemas.microsoft.com/office/drawing/2014/main" id="{9666B0E2-C118-494B-89F5-479A395266C6}"/>
               </a:ext>
             </a:extLst>
           </p:cNvPr>
@@ -2708,17 +3055,17 @@
                 <a:ea typeface="Noto Sans KR"/>
                 <a:cs typeface="Noto Sans KR"/>
               </a:rPr>
-              <a:t>INT8 양자화</a:t>
+              <a:t>INT8 학생 모델</a:t>
             </a:r>
           </a:p>
         </p:txBody>
       </p:sp>
       <p:sp>
         <p:nvSpPr>
-          <p:cNvPr id="19" name="S02-name-3">
+          <p:cNvPr id="18" name="S02-name-3">
             <a:extLst>
               <a:ext uri="{FF2B5EF4-FFF2-40B4-BE49-F238E27FC236}">
-                <a16:creationId xmlns:a16="http://schemas.microsoft.com/office/drawing/2014/main" id="{820F9FF6-F9F0-419F-80D6-D18FDA8EA6BE}"/>
+                <a16:creationId xmlns:a16="http://schemas.microsoft.com/office/drawing/2014/main" id="{5EC11778-7709-4CE8-B12B-26A41AED01AA}"/>
               </a:ext>
             </a:extLst>
           </p:cNvPr>
@@ -2772,10 +3119,10 @@
       </p:sp>
       <p:sp>
         <p:nvSpPr>
-          <p:cNvPr id="20" name="S02-detail-3">
+          <p:cNvPr id="19" name="S02-detail-3">
             <a:extLst>
               <a:ext uri="{FF2B5EF4-FFF2-40B4-BE49-F238E27FC236}">
-                <a16:creationId xmlns:a16="http://schemas.microsoft.com/office/drawing/2014/main" id="{B0B51D7C-49A5-4EE0-AC3E-15CA075CCD37}"/>
+                <a16:creationId xmlns:a16="http://schemas.microsoft.com/office/drawing/2014/main" id="{D8BA29F8-EBAB-4E42-A3B7-882A8D8F600B}"/>
               </a:ext>
             </a:extLst>
           </p:cNvPr>
@@ -2822,7 +3169,7 @@
                 <a:ea typeface="Noto Sans KR"/>
                 <a:cs typeface="Noto Sans KR"/>
               </a:rPr>
-              <a:t>학생 모델의 수치를</a:t>
+              <a:t>모델 내 지정한 수치를</a:t>
             </a:r>
           </a:p>
           <a:p>
@@ -2852,10 +3199,10 @@
       </p:sp>
       <p:sp>
         <p:nvSpPr>
-          <p:cNvPr id="21" name="S02-caveat">
+          <p:cNvPr id="20" name="S02-caveat">
             <a:extLst>
               <a:ext uri="{FF2B5EF4-FFF2-40B4-BE49-F238E27FC236}">
-                <a16:creationId xmlns:a16="http://schemas.microsoft.com/office/drawing/2014/main" id="{DFB475F4-CA07-4E35-8D1A-33D2E166A989}"/>
+                <a16:creationId xmlns:a16="http://schemas.microsoft.com/office/drawing/2014/main" id="{DA2C80E0-00AB-4235-9AD2-B49031C1CCA1}"/>
               </a:ext>
             </a:extLst>
           </p:cNvPr>
@@ -2910,7 +3257,7 @@
     </p:spTree>
     <p:extLst>
       <p:ext uri="{BB962C8B-B14F-4D97-AF65-F5344CB8AC3E}">
-        <p14:creationId xmlns:p14="http://schemas.microsoft.com/office/powerpoint/2010/main" val="1730807046"/>
+        <p14:creationId xmlns:p14="http://schemas.microsoft.com/office/powerpoint/2010/main" val="649119494"/>
       </p:ext>
     </p:extLst>
   </p:cSld>
@@ -2951,7 +3298,7 @@
                                           </p:stCondLst>
                                         </p:cTn>
                                         <p:tgtEl>
-                                          <p:spTgt spid="6"/>
+                                          <p:spTgt spid="5"/>
                                         </p:tgtEl>
                                         <p:attrNameLst>
                                           <p:attrName>style.visibility</p:attrName>
@@ -2965,7 +3312,7 @@
                                       <p:cBhvr>
                                         <p:cTn id="7" dur="350"/>
                                         <p:tgtEl>
-                                          <p:spTgt spid="6"/>
+                                          <p:spTgt spid="5"/>
                                         </p:tgtEl>
                                       </p:cBhvr>
                                     </p:animEffect>
@@ -2986,7 +3333,7 @@
                                           </p:stCondLst>
                                         </p:cTn>
                                         <p:tgtEl>
-                                          <p:spTgt spid="29"/>
+                                          <p:spTgt spid="27"/>
                                         </p:tgtEl>
                                         <p:attrNameLst>
                                           <p:attrName>style.visibility</p:attrName>
@@ -3000,7 +3347,7 @@
                                       <p:cBhvr>
                                         <p:cTn id="10" dur="350"/>
                                         <p:tgtEl>
-                                          <p:spTgt spid="29"/>
+                                          <p:spTgt spid="27"/>
                                         </p:tgtEl>
                                       </p:cBhvr>
                                     </p:animEffect>
@@ -3021,7 +3368,7 @@
                                           </p:stCondLst>
                                         </p:cTn>
                                         <p:tgtEl>
-                                          <p:spTgt spid="10"/>
+                                          <p:spTgt spid="9"/>
                                         </p:tgtEl>
                                         <p:attrNameLst>
                                           <p:attrName>style.visibility</p:attrName>
@@ -3035,7 +3382,7 @@
                                       <p:cBhvr>
                                         <p:cTn id="13" dur="350"/>
                                         <p:tgtEl>
-                                          <p:spTgt spid="10"/>
+                                          <p:spTgt spid="9"/>
                                         </p:tgtEl>
                                       </p:cBhvr>
                                     </p:animEffect>
@@ -3056,7 +3403,7 @@
                                           </p:stCondLst>
                                         </p:cTn>
                                         <p:tgtEl>
-                                          <p:spTgt spid="15"/>
+                                          <p:spTgt spid="14"/>
                                         </p:tgtEl>
                                         <p:attrNameLst>
                                           <p:attrName>style.visibility</p:attrName>
@@ -3070,7 +3417,7 @@
                                       <p:cBhvr>
                                         <p:cTn id="16" dur="350"/>
                                         <p:tgtEl>
-                                          <p:spTgt spid="15"/>
+                                          <p:spTgt spid="14"/>
                                         </p:tgtEl>
                                       </p:cBhvr>
                                     </p:animEffect>
@@ -3091,7 +3438,7 @@
                                           </p:stCondLst>
                                         </p:cTn>
                                         <p:tgtEl>
-                                          <p:spTgt spid="16"/>
+                                          <p:spTgt spid="15"/>
                                         </p:tgtEl>
                                         <p:attrNameLst>
                                           <p:attrName>style.visibility</p:attrName>
@@ -3105,7 +3452,7 @@
                                       <p:cBhvr>
                                         <p:cTn id="19" dur="350"/>
                                         <p:tgtEl>
-                                          <p:spTgt spid="16"/>
+                                          <p:spTgt spid="15"/>
                                         </p:tgtEl>
                                       </p:cBhvr>
                                     </p:animEffect>
@@ -3126,7 +3473,7 @@
                                           </p:stCondLst>
                                         </p:cTn>
                                         <p:tgtEl>
-                                          <p:spTgt spid="17"/>
+                                          <p:spTgt spid="16"/>
                                         </p:tgtEl>
                                         <p:attrNameLst>
                                           <p:attrName>style.visibility</p:attrName>
@@ -3140,7 +3487,7 @@
                                       <p:cBhvr>
                                         <p:cTn id="22" dur="350"/>
                                         <p:tgtEl>
-                                          <p:spTgt spid="17"/>
+                                          <p:spTgt spid="16"/>
                                         </p:tgtEl>
                                       </p:cBhvr>
                                     </p:animEffect>
@@ -3179,7 +3526,7 @@
                                           </p:stCondLst>
                                         </p:cTn>
                                         <p:tgtEl>
-                                          <p:spTgt spid="7"/>
+                                          <p:spTgt spid="6"/>
                                         </p:tgtEl>
                                         <p:attrNameLst>
                                           <p:attrName>style.visibility</p:attrName>
@@ -3193,7 +3540,7 @@
                                       <p:cBhvr>
                                         <p:cTn id="27" dur="350"/>
                                         <p:tgtEl>
-                                          <p:spTgt spid="7"/>
+                                          <p:spTgt spid="6"/>
                                         </p:tgtEl>
                                       </p:cBhvr>
                                     </p:animEffect>
@@ -3214,7 +3561,7 @@
                                           </p:stCondLst>
                                         </p:cTn>
                                         <p:tgtEl>
-                                          <p:spTgt spid="30"/>
+                                          <p:spTgt spid="28"/>
                                         </p:tgtEl>
                                         <p:attrNameLst>
                                           <p:attrName>style.visibility</p:attrName>
@@ -3228,7 +3575,7 @@
                                       <p:cBhvr>
                                         <p:cTn id="30" dur="350"/>
                                         <p:tgtEl>
-                                          <p:spTgt spid="30"/>
+                                          <p:spTgt spid="28"/>
                                         </p:tgtEl>
                                       </p:cBhvr>
                                     </p:animEffect>
@@ -3249,7 +3596,7 @@
                                           </p:stCondLst>
                                         </p:cTn>
                                         <p:tgtEl>
-                                          <p:spTgt spid="11"/>
+                                          <p:spTgt spid="10"/>
                                         </p:tgtEl>
                                         <p:attrNameLst>
                                           <p:attrName>style.visibility</p:attrName>
@@ -3263,7 +3610,7 @@
                                       <p:cBhvr>
                                         <p:cTn id="33" dur="350"/>
                                         <p:tgtEl>
-                                          <p:spTgt spid="11"/>
+                                          <p:spTgt spid="10"/>
                                         </p:tgtEl>
                                       </p:cBhvr>
                                     </p:animEffect>
@@ -3284,7 +3631,7 @@
                                           </p:stCondLst>
                                         </p:cTn>
                                         <p:tgtEl>
-                                          <p:spTgt spid="18"/>
+                                          <p:spTgt spid="17"/>
                                         </p:tgtEl>
                                         <p:attrNameLst>
                                           <p:attrName>style.visibility</p:attrName>
@@ -3298,7 +3645,7 @@
                                       <p:cBhvr>
                                         <p:cTn id="36" dur="350"/>
                                         <p:tgtEl>
-                                          <p:spTgt spid="18"/>
+                                          <p:spTgt spid="17"/>
                                         </p:tgtEl>
                                       </p:cBhvr>
                                     </p:animEffect>
@@ -3319,7 +3666,7 @@
                                           </p:stCondLst>
                                         </p:cTn>
                                         <p:tgtEl>
-                                          <p:spTgt spid="19"/>
+                                          <p:spTgt spid="18"/>
                                         </p:tgtEl>
                                         <p:attrNameLst>
                                           <p:attrName>style.visibility</p:attrName>
@@ -3333,7 +3680,7 @@
                                       <p:cBhvr>
                                         <p:cTn id="39" dur="350"/>
                                         <p:tgtEl>
-                                          <p:spTgt spid="19"/>
+                                          <p:spTgt spid="18"/>
                                         </p:tgtEl>
                                       </p:cBhvr>
                                     </p:animEffect>
@@ -3354,7 +3701,7 @@
                                           </p:stCondLst>
                                         </p:cTn>
                                         <p:tgtEl>
-                                          <p:spTgt spid="20"/>
+                                          <p:spTgt spid="19"/>
                                         </p:tgtEl>
                                         <p:attrNameLst>
                                           <p:attrName>style.visibility</p:attrName>
@@ -3368,7 +3715,7 @@
                                       <p:cBhvr>
                                         <p:cTn id="42" dur="350"/>
                                         <p:tgtEl>
-                                          <p:spTgt spid="20"/>
+                                          <p:spTgt spid="19"/>
                                         </p:tgtEl>
                                       </p:cBhvr>
                                     </p:animEffect>
@@ -3403,16 +3750,16 @@
       </p:par>
     </p:tnLst>
     <p:bldLst>
+      <p:bldP spid="5" grpId="0" animBg="1"/>
       <p:bldP spid="6" grpId="0" animBg="1"/>
-      <p:bldP spid="7" grpId="0" animBg="1"/>
+      <p:bldP spid="9" grpId="0"/>
       <p:bldP spid="10" grpId="0"/>
-      <p:bldP spid="11" grpId="0"/>
+      <p:bldP spid="14" grpId="0"/>
       <p:bldP spid="15" grpId="0"/>
       <p:bldP spid="16" grpId="0"/>
       <p:bldP spid="17" grpId="0"/>
       <p:bldP spid="18" grpId="0"/>
       <p:bldP spid="19" grpId="0"/>
-      <p:bldP spid="20" grpId="0"/>
     </p:bldLst>
   </p:timing>
 </p:sld>
@@ -3445,67 +3792,10 @@
       </p:grpSpPr>
       <p:sp>
         <p:nvSpPr>
-          <p:cNvPr id="9" name="S03-section">
+          <p:cNvPr id="8" name="S03-title">
             <a:extLst>
               <a:ext uri="{FF2B5EF4-FFF2-40B4-BE49-F238E27FC236}">
-                <a16:creationId xmlns:a16="http://schemas.microsoft.com/office/drawing/2014/main" id="{4A977C47-17CC-4211-8A2E-874B03EB1C9F}"/>
-              </a:ext>
-            </a:extLst>
-          </p:cNvPr>
-          <p:cNvSpPr>
-            <a:spLocks noGrp="1"/>
-          </p:cNvSpPr>
-          <p:nvPr/>
-        </p:nvSpPr>
-        <p:spPr>
-          <a:xfrm>
-            <a:off x="685800" y="400050"/>
-            <a:ext cx="10744200" cy="257175"/>
-          </a:xfrm>
-          <a:prstGeom prst="rect">
-            <a:avLst/>
-          </a:prstGeom>
-          <a:noFill/>
-          <a:ln w="0">
-            <a:noFill/>
-          </a:ln>
-        </p:spPr>
-        <p:txBody>
-          <a:bodyPr wrap="none" lIns="0" tIns="0" rIns="0" bIns="0" anchor="ctr">
-            <a:noAutofit/>
-          </a:bodyPr>
-          <a:lstStyle/>
-          <a:p>
-            <a:pPr>
-              <a:defRPr sz="1425" b="0">
-                <a:solidFill>
-                  <a:srgbClr val="287D78"/>
-                </a:solidFill>
-                <a:latin typeface="Noto Sans KR"/>
-                <a:ea typeface="Noto Sans KR"/>
-                <a:cs typeface="Noto Sans KR"/>
-              </a:defRPr>
-            </a:pPr>
-            <a:r>
-              <a:rPr sz="1425" b="0">
-                <a:solidFill>
-                  <a:srgbClr val="287D78"/>
-                </a:solidFill>
-                <a:latin typeface="Noto Sans KR"/>
-                <a:ea typeface="Noto Sans KR"/>
-                <a:cs typeface="Noto Sans KR"/>
-              </a:rPr>
-              <a:t>근거 / 가상 성능 비교</a:t>
-            </a:r>
-          </a:p>
-        </p:txBody>
-      </p:sp>
-      <p:sp>
-        <p:nvSpPr>
-          <p:cNvPr id="2" name="S03-title">
-            <a:extLst>
-              <a:ext uri="{FF2B5EF4-FFF2-40B4-BE49-F238E27FC236}">
-                <a16:creationId xmlns:a16="http://schemas.microsoft.com/office/drawing/2014/main" id="{637CBAEC-8932-4949-883B-45B915562792}"/>
+                <a16:creationId xmlns:a16="http://schemas.microsoft.com/office/drawing/2014/main" id="{2BFCB33E-D440-4E8E-9045-EBC7B2A4A73F}"/>
               </a:ext>
             </a:extLst>
           </p:cNvPr>
@@ -3552,17 +3842,17 @@
                 <a:ea typeface="Noto Sans KR"/>
                 <a:cs typeface="Noto Sans KR"/>
               </a:rPr>
-              <a:t>같은 조건에서 비교한 세 모델</a:t>
+              <a:t>지연, F1, 모델 크기 비교</a:t>
             </a:r>
           </a:p>
         </p:txBody>
       </p:sp>
       <p:sp>
         <p:nvSpPr>
-          <p:cNvPr id="3" name="S03-disclosure">
+          <p:cNvPr id="2" name="S03-disclosure">
             <a:extLst>
               <a:ext uri="{FF2B5EF4-FFF2-40B4-BE49-F238E27FC236}">
-                <a16:creationId xmlns:a16="http://schemas.microsoft.com/office/drawing/2014/main" id="{FE134A85-4D4D-45CE-A707-FFA2EC007CF9}"/>
+                <a16:creationId xmlns:a16="http://schemas.microsoft.com/office/drawing/2014/main" id="{70AD51DF-4D9E-47A2-8535-1F0B7A490A4B}"/>
               </a:ext>
             </a:extLst>
           </p:cNvPr>
@@ -3616,10 +3906,10 @@
       </p:sp>
       <p:sp>
         <p:nvSpPr>
-          <p:cNvPr id="4" name="S03-number">
+          <p:cNvPr id="3" name="S03-number">
             <a:extLst>
               <a:ext uri="{FF2B5EF4-FFF2-40B4-BE49-F238E27FC236}">
-                <a16:creationId xmlns:a16="http://schemas.microsoft.com/office/drawing/2014/main" id="{92A6B5AD-B840-47F5-B622-8D0D07A06E95}"/>
+                <a16:creationId xmlns:a16="http://schemas.microsoft.com/office/drawing/2014/main" id="{FAB2F029-CE85-4FD1-BF84-7F7926589296}"/>
               </a:ext>
             </a:extLst>
           </p:cNvPr>
@@ -3673,10 +3963,10 @@
       </p:sp>
       <p:sp>
         <p:nvSpPr>
-          <p:cNvPr id="5" name="S03-direction">
+          <p:cNvPr id="4" name="S03-direction">
             <a:extLst>
               <a:ext uri="{FF2B5EF4-FFF2-40B4-BE49-F238E27FC236}">
-                <a16:creationId xmlns:a16="http://schemas.microsoft.com/office/drawing/2014/main" id="{E2651EEA-DA78-4796-99AD-7D447059044A}"/>
+                <a16:creationId xmlns:a16="http://schemas.microsoft.com/office/drawing/2014/main" id="{0C8B53CB-C902-45B2-9C8E-2CAB87D1DF26}"/>
               </a:ext>
             </a:extLst>
           </p:cNvPr>
@@ -3730,7 +4020,7 @@
       </p:sp>
       <p:graphicFrame>
         <p:nvGraphicFramePr>
-          <p:cNvPr id="14" name="표 13"/>
+          <p:cNvPr id="12" name="표 11"/>
           <p:cNvGraphicFramePr/>
           <p:nvPr/>
         </p:nvGraphicFramePr>
@@ -4319,7 +4609,7 @@
                       <a:r>
                         <a:rPr sz="2400" b="0">
                           <a:solidFill>
-                            <a:srgbClr val="287D78"/>
+                            <a:srgbClr val="1E302F"/>
                           </a:solidFill>
                           <a:latin typeface="Noto Sans KR"/>
                           <a:ea typeface="Noto Sans KR"/>
@@ -4349,7 +4639,7 @@
                       <a:noFill/>
                     </a:lnBlToTr>
                     <a:solidFill>
-                      <a:srgbClr val="E8EDE5"/>
+                      <a:srgbClr val="F6F4EE"/>
                     </a:solidFill>
                   </a:tcPr>
                 </a:tc>
@@ -4362,7 +4652,7 @@
                       <a:r>
                         <a:rPr sz="2400" b="0">
                           <a:solidFill>
-                            <a:srgbClr val="287D78"/>
+                            <a:srgbClr val="1E302F"/>
                           </a:solidFill>
                           <a:latin typeface="Noto Sans KR"/>
                           <a:ea typeface="Noto Sans KR"/>
@@ -4392,7 +4682,7 @@
                       <a:noFill/>
                     </a:lnBlToTr>
                     <a:solidFill>
-                      <a:srgbClr val="E8EDE5"/>
+                      <a:srgbClr val="F6F4EE"/>
                     </a:solidFill>
                   </a:tcPr>
                 </a:tc>
@@ -4405,7 +4695,7 @@
                       <a:r>
                         <a:rPr sz="2400" b="0">
                           <a:solidFill>
-                            <a:srgbClr val="287D78"/>
+                            <a:srgbClr val="1E302F"/>
                           </a:solidFill>
                           <a:latin typeface="Noto Sans KR"/>
                           <a:ea typeface="Noto Sans KR"/>
@@ -4435,7 +4725,7 @@
                       <a:noFill/>
                     </a:lnBlToTr>
                     <a:solidFill>
-                      <a:srgbClr val="E8EDE5"/>
+                      <a:srgbClr val="F6F4EE"/>
                     </a:solidFill>
                   </a:tcPr>
                 </a:tc>
@@ -4448,7 +4738,7 @@
                       <a:r>
                         <a:rPr sz="2400" b="0">
                           <a:solidFill>
-                            <a:srgbClr val="287D78"/>
+                            <a:srgbClr val="1E302F"/>
                           </a:solidFill>
                           <a:latin typeface="Noto Sans KR"/>
                           <a:ea typeface="Noto Sans KR"/>
@@ -4478,7 +4768,7 @@
                       <a:noFill/>
                     </a:lnBlToTr>
                     <a:solidFill>
-                      <a:srgbClr val="E8EDE5"/>
+                      <a:srgbClr val="F6F4EE"/>
                     </a:solidFill>
                   </a:tcPr>
                 </a:tc>
@@ -4494,10 +4784,10 @@
       </p:graphicFrame>
       <p:sp>
         <p:nvSpPr>
-          <p:cNvPr id="7" name="S03-header-rule">
+          <p:cNvPr id="6" name="S03-header-rule">
             <a:extLst>
               <a:ext uri="{FF2B5EF4-FFF2-40B4-BE49-F238E27FC236}">
-                <a16:creationId xmlns:a16="http://schemas.microsoft.com/office/drawing/2014/main" id="{94C32CC6-869D-49B4-A594-1986EF544B0B}"/>
+                <a16:creationId xmlns:a16="http://schemas.microsoft.com/office/drawing/2014/main" id="{D06DE6E8-A4B2-41DA-A73A-86E0E6937544}"/>
               </a:ext>
             </a:extLst>
           </p:cNvPr>
@@ -4523,10 +4813,10 @@
       </p:sp>
       <p:sp>
         <p:nvSpPr>
-          <p:cNvPr id="8" name="S03-limit">
+          <p:cNvPr id="7" name="S03-limit">
             <a:extLst>
               <a:ext uri="{FF2B5EF4-FFF2-40B4-BE49-F238E27FC236}">
-                <a16:creationId xmlns:a16="http://schemas.microsoft.com/office/drawing/2014/main" id="{E8B1A52B-4596-4032-B627-1DD543893D98}"/>
+                <a16:creationId xmlns:a16="http://schemas.microsoft.com/office/drawing/2014/main" id="{1E0049A3-4E3D-4EDE-A422-2484BCDE561B}"/>
               </a:ext>
             </a:extLst>
           </p:cNvPr>
@@ -4581,7 +4871,7 @@
     </p:spTree>
     <p:extLst>
       <p:ext uri="{BB962C8B-B14F-4D97-AF65-F5344CB8AC3E}">
-        <p14:creationId xmlns:p14="http://schemas.microsoft.com/office/powerpoint/2010/main" val="334039425"/>
+        <p14:creationId xmlns:p14="http://schemas.microsoft.com/office/powerpoint/2010/main" val="1457840297"/>
       </p:ext>
     </p:extLst>
   </p:cSld>
@@ -4618,67 +4908,10 @@
       </p:grpSpPr>
       <p:sp>
         <p:nvSpPr>
-          <p:cNvPr id="17" name="S04-section">
+          <p:cNvPr id="15" name="S04-title">
             <a:extLst>
               <a:ext uri="{FF2B5EF4-FFF2-40B4-BE49-F238E27FC236}">
-                <a16:creationId xmlns:a16="http://schemas.microsoft.com/office/drawing/2014/main" id="{AB55DE22-9EDD-4B78-8464-1109D65F2D1F}"/>
-              </a:ext>
-            </a:extLst>
-          </p:cNvPr>
-          <p:cNvSpPr>
-            <a:spLocks noGrp="1"/>
-          </p:cNvSpPr>
-          <p:nvPr/>
-        </p:nvSpPr>
-        <p:spPr>
-          <a:xfrm>
-            <a:off x="685800" y="400050"/>
-            <a:ext cx="10744200" cy="257175"/>
-          </a:xfrm>
-          <a:prstGeom prst="rect">
-            <a:avLst/>
-          </a:prstGeom>
-          <a:noFill/>
-          <a:ln w="0">
-            <a:noFill/>
-          </a:ln>
-        </p:spPr>
-        <p:txBody>
-          <a:bodyPr wrap="none" lIns="0" tIns="0" rIns="0" bIns="0" anchor="ctr">
-            <a:noAutofit/>
-          </a:bodyPr>
-          <a:lstStyle/>
-          <a:p>
-            <a:pPr>
-              <a:defRPr sz="1425" b="0">
-                <a:solidFill>
-                  <a:srgbClr val="287D78"/>
-                </a:solidFill>
-                <a:latin typeface="Noto Sans KR"/>
-                <a:ea typeface="Noto Sans KR"/>
-                <a:cs typeface="Noto Sans KR"/>
-              </a:defRPr>
-            </a:pPr>
-            <a:r>
-              <a:rPr sz="1425" b="0">
-                <a:solidFill>
-                  <a:srgbClr val="287D78"/>
-                </a:solidFill>
-                <a:latin typeface="Noto Sans KR"/>
-                <a:ea typeface="Noto Sans KR"/>
-                <a:cs typeface="Noto Sans KR"/>
-              </a:rPr>
-              <a:t>결과 / 원본 대비 INT8</a:t>
-            </a:r>
-          </a:p>
-        </p:txBody>
-      </p:sp>
-      <p:sp>
-        <p:nvSpPr>
-          <p:cNvPr id="2" name="S04-title">
-            <a:extLst>
-              <a:ext uri="{FF2B5EF4-FFF2-40B4-BE49-F238E27FC236}">
-                <a16:creationId xmlns:a16="http://schemas.microsoft.com/office/drawing/2014/main" id="{01DF3C8D-CBC4-4C17-A372-1BB7B90B6A2F}"/>
+                <a16:creationId xmlns:a16="http://schemas.microsoft.com/office/drawing/2014/main" id="{25A89D26-9714-4F0E-899C-B3DCD32F3C69}"/>
               </a:ext>
             </a:extLst>
           </p:cNvPr>
@@ -4732,10 +4965,10 @@
       </p:sp>
       <p:sp>
         <p:nvSpPr>
-          <p:cNvPr id="3" name="S04-disclosure">
+          <p:cNvPr id="2" name="S04-disclosure">
             <a:extLst>
               <a:ext uri="{FF2B5EF4-FFF2-40B4-BE49-F238E27FC236}">
-                <a16:creationId xmlns:a16="http://schemas.microsoft.com/office/drawing/2014/main" id="{ADB47203-11D5-4D1A-B437-07D14ECB7352}"/>
+                <a16:creationId xmlns:a16="http://schemas.microsoft.com/office/drawing/2014/main" id="{7194345A-DD90-409E-B7D2-BD2FA43FBC31}"/>
               </a:ext>
             </a:extLst>
           </p:cNvPr>
@@ -4789,10 +5022,10 @@
       </p:sp>
       <p:sp>
         <p:nvSpPr>
-          <p:cNvPr id="4" name="S04-number">
+          <p:cNvPr id="3" name="S04-number">
             <a:extLst>
               <a:ext uri="{FF2B5EF4-FFF2-40B4-BE49-F238E27FC236}">
-                <a16:creationId xmlns:a16="http://schemas.microsoft.com/office/drawing/2014/main" id="{6033E9C5-62E2-421A-A066-6873BCD5BD20}"/>
+                <a16:creationId xmlns:a16="http://schemas.microsoft.com/office/drawing/2014/main" id="{8C81FEEE-2569-4AEE-BA59-58874E4CC3F2}"/>
               </a:ext>
             </a:extLst>
           </p:cNvPr>
@@ -4846,10 +5079,10 @@
       </p:sp>
       <p:sp>
         <p:nvSpPr>
-          <p:cNvPr id="5" name="S04-chart-unit">
+          <p:cNvPr id="4" name="S04-chart-unit">
             <a:extLst>
               <a:ext uri="{FF2B5EF4-FFF2-40B4-BE49-F238E27FC236}">
-                <a16:creationId xmlns:a16="http://schemas.microsoft.com/office/drawing/2014/main" id="{FDF6A871-28E6-4F76-AAC5-FC66D7A7650B}"/>
+                <a16:creationId xmlns:a16="http://schemas.microsoft.com/office/drawing/2014/main" id="{3476E6C3-4DEE-43C3-8DE3-72C707C373F9}"/>
               </a:ext>
             </a:extLst>
           </p:cNvPr>
@@ -4860,8 +5093,8 @@
         </p:nvSpPr>
         <p:spPr>
           <a:xfrm>
-            <a:off x="685800" y="1828800"/>
-            <a:ext cx="6000750" cy="352425"/>
+            <a:off x="685800" y="1647825"/>
+            <a:ext cx="6762750" cy="361950"/>
           </a:xfrm>
           <a:prstGeom prst="rect">
             <a:avLst/>
@@ -4896,20 +5129,20 @@
                 <a:ea typeface="Noto Sans KR"/>
                 <a:cs typeface="Noto Sans KR"/>
               </a:rPr>
-              <a:t>지연 (ms)</a:t>
+              <a:t>F1 · 높을수록 좋음</a:t>
             </a:r>
           </a:p>
         </p:txBody>
       </p:sp>
       <p:graphicFrame>
         <p:nvGraphicFramePr>
-          <p:cNvPr id="22" name="Chart"/>
+          <p:cNvPr id="19" name="Chart"/>
           <p:cNvGraphicFramePr/>
           <p:nvPr/>
         </p:nvGraphicFramePr>
         <p:xfrm>
-          <a:off x="552450" y="2343150"/>
-          <a:ext cx="6810375" cy="2857500"/>
+          <a:off x="619125" y="2095500"/>
+          <a:ext cx="7191375" cy="3219450"/>
         </p:xfrm>
         <a:graphic>
           <a:graphicData uri="http://schemas.openxmlformats.org/drawingml/2006/chart">
@@ -4919,10 +5152,10 @@
       </p:graphicFrame>
       <p:sp>
         <p:nvSpPr>
-          <p:cNvPr id="7" name="S04-latency">
+          <p:cNvPr id="6" name="S04-x-unit">
             <a:extLst>
               <a:ext uri="{FF2B5EF4-FFF2-40B4-BE49-F238E27FC236}">
-                <a16:creationId xmlns:a16="http://schemas.microsoft.com/office/drawing/2014/main" id="{8EF5A9B4-099C-4EE7-BE2A-5BA19C0A1B21}"/>
+                <a16:creationId xmlns:a16="http://schemas.microsoft.com/office/drawing/2014/main" id="{8FE66CC3-0328-4D34-B7AE-49897BF48C40}"/>
               </a:ext>
             </a:extLst>
           </p:cNvPr>
@@ -4933,8 +5166,8 @@
         </p:nvSpPr>
         <p:spPr>
           <a:xfrm>
-            <a:off x="8058150" y="1885950"/>
-            <a:ext cx="3276600" cy="809625"/>
+            <a:off x="1428750" y="5181600"/>
+            <a:ext cx="6191250" cy="333375"/>
           </a:xfrm>
           <a:prstGeom prst="rect">
             <a:avLst/>
@@ -4951,9 +5184,9 @@
           <a:lstStyle/>
           <a:p>
             <a:pPr>
-              <a:defRPr sz="5325" b="0">
-                <a:solidFill>
-                  <a:srgbClr val="287D78"/>
+              <a:defRPr sz="1725" b="0">
+                <a:solidFill>
+                  <a:srgbClr val="586C68"/>
                 </a:solidFill>
                 <a:latin typeface="Noto Sans KR"/>
                 <a:ea typeface="Noto Sans KR"/>
@@ -4961,25 +5194,25 @@
               </a:defRPr>
             </a:pPr>
             <a:r>
-              <a:rPr sz="5325" b="0">
-                <a:solidFill>
-                  <a:srgbClr val="287D78"/>
+              <a:rPr sz="1725" b="0">
+                <a:solidFill>
+                  <a:srgbClr val="586C68"/>
                 </a:solidFill>
                 <a:latin typeface="Noto Sans KR"/>
                 <a:ea typeface="Noto Sans KR"/>
                 <a:cs typeface="Noto Sans KR"/>
               </a:rPr>
-              <a:t>55%</a:t>
+              <a:t>지연 (ms) · 낮을수록 좋음</a:t>
             </a:r>
           </a:p>
         </p:txBody>
       </p:sp>
       <p:sp>
         <p:nvSpPr>
-          <p:cNvPr id="8" name="S04-latency-label">
+          <p:cNvPr id="7" name="S04-basis">
             <a:extLst>
               <a:ext uri="{FF2B5EF4-FFF2-40B4-BE49-F238E27FC236}">
-                <a16:creationId xmlns:a16="http://schemas.microsoft.com/office/drawing/2014/main" id="{09D6CBEA-E9F5-4D60-930A-3B74471F42F7}"/>
+                <a16:creationId xmlns:a16="http://schemas.microsoft.com/office/drawing/2014/main" id="{E9F74EB1-8EC5-4C69-A69E-EE397C1B15F2}"/>
               </a:ext>
             </a:extLst>
           </p:cNvPr>
@@ -4990,8 +5223,8 @@
         </p:nvSpPr>
         <p:spPr>
           <a:xfrm>
-            <a:off x="8058150" y="2714625"/>
-            <a:ext cx="3448050" cy="342900"/>
+            <a:off x="8382000" y="1714500"/>
+            <a:ext cx="3124200" cy="333375"/>
           </a:xfrm>
           <a:prstGeom prst="rect">
             <a:avLst/>
@@ -5008,6 +5241,120 @@
           <a:lstStyle/>
           <a:p>
             <a:pPr>
+              <a:defRPr sz="1800" b="0">
+                <a:solidFill>
+                  <a:srgbClr val="586C68"/>
+                </a:solidFill>
+                <a:latin typeface="Noto Sans KR"/>
+                <a:ea typeface="Noto Sans KR"/>
+                <a:cs typeface="Noto Sans KR"/>
+              </a:defRPr>
+            </a:pPr>
+            <a:r>
+              <a:rPr sz="1800" b="0">
+                <a:solidFill>
+                  <a:srgbClr val="586C68"/>
+                </a:solidFill>
+                <a:latin typeface="Noto Sans KR"/>
+                <a:ea typeface="Noto Sans KR"/>
+                <a:cs typeface="Noto Sans KR"/>
+              </a:rPr>
+              <a:t>원본 대비 INT8</a:t>
+            </a:r>
+          </a:p>
+        </p:txBody>
+      </p:sp>
+      <p:sp>
+        <p:nvSpPr>
+          <p:cNvPr id="8" name="S04-latency">
+            <a:extLst>
+              <a:ext uri="{FF2B5EF4-FFF2-40B4-BE49-F238E27FC236}">
+                <a16:creationId xmlns:a16="http://schemas.microsoft.com/office/drawing/2014/main" id="{B21799A0-8608-4BCC-81CF-BD51BA2BCE89}"/>
+              </a:ext>
+            </a:extLst>
+          </p:cNvPr>
+          <p:cNvSpPr>
+            <a:spLocks noGrp="1"/>
+          </p:cNvSpPr>
+          <p:nvPr/>
+        </p:nvSpPr>
+        <p:spPr>
+          <a:xfrm>
+            <a:off x="8382000" y="2247900"/>
+            <a:ext cx="3048000" cy="628650"/>
+          </a:xfrm>
+          <a:prstGeom prst="rect">
+            <a:avLst/>
+          </a:prstGeom>
+          <a:noFill/>
+          <a:ln w="0">
+            <a:noFill/>
+          </a:ln>
+        </p:spPr>
+        <p:txBody>
+          <a:bodyPr wrap="none" lIns="0" tIns="0" rIns="0" bIns="0" anchor="ctr">
+            <a:noAutofit/>
+          </a:bodyPr>
+          <a:lstStyle/>
+          <a:p>
+            <a:pPr>
+              <a:defRPr sz="3450" b="0">
+                <a:solidFill>
+                  <a:srgbClr val="1E302F"/>
+                </a:solidFill>
+                <a:latin typeface="Noto Sans KR"/>
+                <a:ea typeface="Noto Sans KR"/>
+                <a:cs typeface="Noto Sans KR"/>
+              </a:defRPr>
+            </a:pPr>
+            <a:r>
+              <a:rPr sz="3450" b="0">
+                <a:solidFill>
+                  <a:srgbClr val="1E302F"/>
+                </a:solidFill>
+                <a:latin typeface="Noto Sans KR"/>
+                <a:ea typeface="Noto Sans KR"/>
+                <a:cs typeface="Noto Sans KR"/>
+              </a:rPr>
+              <a:t>−55%</a:t>
+            </a:r>
+          </a:p>
+        </p:txBody>
+      </p:sp>
+      <p:sp>
+        <p:nvSpPr>
+          <p:cNvPr id="9" name="S04-latency-label">
+            <a:extLst>
+              <a:ext uri="{FF2B5EF4-FFF2-40B4-BE49-F238E27FC236}">
+                <a16:creationId xmlns:a16="http://schemas.microsoft.com/office/drawing/2014/main" id="{395BC17C-9B37-4040-BA6F-9FDCE175910E}"/>
+              </a:ext>
+            </a:extLst>
+          </p:cNvPr>
+          <p:cNvSpPr>
+            <a:spLocks noGrp="1"/>
+          </p:cNvSpPr>
+          <p:nvPr/>
+        </p:nvSpPr>
+        <p:spPr>
+          <a:xfrm>
+            <a:off x="8382000" y="2876550"/>
+            <a:ext cx="3124200" cy="361950"/>
+          </a:xfrm>
+          <a:prstGeom prst="rect">
+            <a:avLst/>
+          </a:prstGeom>
+          <a:noFill/>
+          <a:ln w="0">
+            <a:noFill/>
+          </a:ln>
+        </p:spPr>
+        <p:txBody>
+          <a:bodyPr wrap="none" lIns="0" tIns="0" rIns="0" bIns="0" anchor="ctr">
+            <a:noAutofit/>
+          </a:bodyPr>
+          <a:lstStyle/>
+          <a:p>
+            <a:pPr>
               <a:defRPr sz="1725" b="0">
                 <a:solidFill>
                   <a:srgbClr val="586C68"/>
@@ -5026,17 +5373,17 @@
                 <a:ea typeface="Noto Sans KR"/>
                 <a:cs typeface="Noto Sans KR"/>
               </a:rPr>
-              <a:t>지연 감소 · 120 → 54 ms</a:t>
+              <a:t>지연 · 120 → 54 ms</a:t>
             </a:r>
           </a:p>
         </p:txBody>
       </p:sp>
       <p:sp>
         <p:nvSpPr>
-          <p:cNvPr id="9" name="S04-size">
+          <p:cNvPr id="10" name="S04-f1">
             <a:extLst>
               <a:ext uri="{FF2B5EF4-FFF2-40B4-BE49-F238E27FC236}">
-                <a16:creationId xmlns:a16="http://schemas.microsoft.com/office/drawing/2014/main" id="{F68D9B54-AB44-48F3-8FBB-D0A50EC55A5E}"/>
+                <a16:creationId xmlns:a16="http://schemas.microsoft.com/office/drawing/2014/main" id="{69464394-F990-4519-8FA0-1ADAA43C76F5}"/>
               </a:ext>
             </a:extLst>
           </p:cNvPr>
@@ -5047,8 +5394,8 @@
         </p:nvSpPr>
         <p:spPr>
           <a:xfrm>
-            <a:off x="8058150" y="3352800"/>
-            <a:ext cx="1524000" cy="647700"/>
+            <a:off x="8382000" y="3419475"/>
+            <a:ext cx="3048000" cy="628650"/>
           </a:xfrm>
           <a:prstGeom prst="rect">
             <a:avLst/>
@@ -5065,7 +5412,7 @@
           <a:lstStyle/>
           <a:p>
             <a:pPr>
-              <a:defRPr sz="3975" b="0">
+              <a:defRPr sz="3450" b="0">
                 <a:solidFill>
                   <a:srgbClr val="1E302F"/>
                 </a:solidFill>
@@ -5075,7 +5422,7 @@
               </a:defRPr>
             </a:pPr>
             <a:r>
-              <a:rPr sz="3975" b="0">
+              <a:rPr sz="3450" b="0">
                 <a:solidFill>
                   <a:srgbClr val="1E302F"/>
                 </a:solidFill>
@@ -5083,17 +5430,17 @@
                 <a:ea typeface="Noto Sans KR"/>
                 <a:cs typeface="Noto Sans KR"/>
               </a:rPr>
-              <a:t>75%</a:t>
+              <a:t>−0.014</a:t>
             </a:r>
           </a:p>
         </p:txBody>
       </p:sp>
       <p:sp>
         <p:nvSpPr>
-          <p:cNvPr id="10" name="S04-f1">
+          <p:cNvPr id="11" name="S04-f1-label">
             <a:extLst>
               <a:ext uri="{FF2B5EF4-FFF2-40B4-BE49-F238E27FC236}">
-                <a16:creationId xmlns:a16="http://schemas.microsoft.com/office/drawing/2014/main" id="{46ED6933-E2DD-4116-AE03-73C52FC0D02A}"/>
+                <a16:creationId xmlns:a16="http://schemas.microsoft.com/office/drawing/2014/main" id="{031A2F0C-DF36-4E8F-BB80-36B0DE5095E8}"/>
               </a:ext>
             </a:extLst>
           </p:cNvPr>
@@ -5104,8 +5451,8 @@
         </p:nvSpPr>
         <p:spPr>
           <a:xfrm>
-            <a:off x="9906000" y="3352800"/>
-            <a:ext cx="1657350" cy="647700"/>
+            <a:off x="8382000" y="4048125"/>
+            <a:ext cx="3124200" cy="361950"/>
           </a:xfrm>
           <a:prstGeom prst="rect">
             <a:avLst/>
@@ -5122,9 +5469,9 @@
           <a:lstStyle/>
           <a:p>
             <a:pPr>
-              <a:defRPr sz="3525" b="0">
-                <a:solidFill>
-                  <a:srgbClr val="A3563E"/>
+              <a:defRPr sz="1725" b="0">
+                <a:solidFill>
+                  <a:srgbClr val="586C68"/>
                 </a:solidFill>
                 <a:latin typeface="Noto Sans KR"/>
                 <a:ea typeface="Noto Sans KR"/>
@@ -5132,25 +5479,25 @@
               </a:defRPr>
             </a:pPr>
             <a:r>
-              <a:rPr sz="3525" b="0">
-                <a:solidFill>
-                  <a:srgbClr val="A3563E"/>
+              <a:rPr sz="1725" b="0">
+                <a:solidFill>
+                  <a:srgbClr val="586C68"/>
                 </a:solidFill>
                 <a:latin typeface="Noto Sans KR"/>
                 <a:ea typeface="Noto Sans KR"/>
                 <a:cs typeface="Noto Sans KR"/>
               </a:rPr>
-              <a:t>−0.014</a:t>
+              <a:t>F1 · 절대 차이</a:t>
             </a:r>
           </a:p>
         </p:txBody>
       </p:sp>
       <p:sp>
         <p:nvSpPr>
-          <p:cNvPr id="11" name="S04-size-label">
+          <p:cNvPr id="12" name="S04-size-values">
             <a:extLst>
               <a:ext uri="{FF2B5EF4-FFF2-40B4-BE49-F238E27FC236}">
-                <a16:creationId xmlns:a16="http://schemas.microsoft.com/office/drawing/2014/main" id="{B1A18398-2695-49B2-AEA1-932FB59F78CB}"/>
+                <a16:creationId xmlns:a16="http://schemas.microsoft.com/office/drawing/2014/main" id="{1D8035D4-AE13-4CFF-82AD-929826B7A139}"/>
               </a:ext>
             </a:extLst>
           </p:cNvPr>
@@ -5161,8 +5508,8 @@
         </p:nvSpPr>
         <p:spPr>
           <a:xfrm>
-            <a:off x="8058150" y="4076700"/>
-            <a:ext cx="1752600" cy="314325"/>
+            <a:off x="8382000" y="4772025"/>
+            <a:ext cx="3124200" cy="457200"/>
           </a:xfrm>
           <a:prstGeom prst="rect">
             <a:avLst/>
@@ -5179,123 +5526,9 @@
           <a:lstStyle/>
           <a:p>
             <a:pPr>
-              <a:defRPr sz="1575" b="0">
-                <a:solidFill>
-                  <a:srgbClr val="586C68"/>
-                </a:solidFill>
-                <a:latin typeface="Noto Sans KR"/>
-                <a:ea typeface="Noto Sans KR"/>
-                <a:cs typeface="Noto Sans KR"/>
-              </a:defRPr>
-            </a:pPr>
-            <a:r>
-              <a:rPr sz="1575" b="0">
-                <a:solidFill>
-                  <a:srgbClr val="586C68"/>
-                </a:solidFill>
-                <a:latin typeface="Noto Sans KR"/>
-                <a:ea typeface="Noto Sans KR"/>
-                <a:cs typeface="Noto Sans KR"/>
-              </a:rPr>
-              <a:t>모델 크기 감소</a:t>
-            </a:r>
-          </a:p>
-        </p:txBody>
-      </p:sp>
-      <p:sp>
-        <p:nvSpPr>
-          <p:cNvPr id="12" name="S04-f1-label">
-            <a:extLst>
-              <a:ext uri="{FF2B5EF4-FFF2-40B4-BE49-F238E27FC236}">
-                <a16:creationId xmlns:a16="http://schemas.microsoft.com/office/drawing/2014/main" id="{4283194A-65D9-48D4-B5EA-2299B4D0F0F3}"/>
-              </a:ext>
-            </a:extLst>
-          </p:cNvPr>
-          <p:cNvSpPr>
-            <a:spLocks noGrp="1"/>
-          </p:cNvSpPr>
-          <p:nvPr/>
-        </p:nvSpPr>
-        <p:spPr>
-          <a:xfrm>
-            <a:off x="9906000" y="4076700"/>
-            <a:ext cx="1657350" cy="314325"/>
-          </a:xfrm>
-          <a:prstGeom prst="rect">
-            <a:avLst/>
-          </a:prstGeom>
-          <a:noFill/>
-          <a:ln w="0">
-            <a:noFill/>
-          </a:ln>
-        </p:spPr>
-        <p:txBody>
-          <a:bodyPr wrap="none" lIns="0" tIns="0" rIns="0" bIns="0" anchor="ctr">
-            <a:noAutofit/>
-          </a:bodyPr>
-          <a:lstStyle/>
-          <a:p>
-            <a:pPr>
-              <a:defRPr sz="1575" b="0">
-                <a:solidFill>
-                  <a:srgbClr val="586C68"/>
-                </a:solidFill>
-                <a:latin typeface="Noto Sans KR"/>
-                <a:ea typeface="Noto Sans KR"/>
-                <a:cs typeface="Noto Sans KR"/>
-              </a:defRPr>
-            </a:pPr>
-            <a:r>
-              <a:rPr sz="1575" b="0">
-                <a:solidFill>
-                  <a:srgbClr val="586C68"/>
-                </a:solidFill>
-                <a:latin typeface="Noto Sans KR"/>
-                <a:ea typeface="Noto Sans KR"/>
-                <a:cs typeface="Noto Sans KR"/>
-              </a:rPr>
-              <a:t>F1 절대 차이</a:t>
-            </a:r>
-          </a:p>
-        </p:txBody>
-      </p:sp>
-      <p:sp>
-        <p:nvSpPr>
-          <p:cNvPr id="13" name="S04-size-values">
-            <a:extLst>
-              <a:ext uri="{FF2B5EF4-FFF2-40B4-BE49-F238E27FC236}">
-                <a16:creationId xmlns:a16="http://schemas.microsoft.com/office/drawing/2014/main" id="{711807CA-912D-40CF-9E5C-159205477147}"/>
-              </a:ext>
-            </a:extLst>
-          </p:cNvPr>
-          <p:cNvSpPr>
-            <a:spLocks noGrp="1"/>
-          </p:cNvSpPr>
-          <p:nvPr/>
-        </p:nvSpPr>
-        <p:spPr>
-          <a:xfrm>
-            <a:off x="8058150" y="4524375"/>
-            <a:ext cx="1762125" cy="323850"/>
-          </a:xfrm>
-          <a:prstGeom prst="rect">
-            <a:avLst/>
-          </a:prstGeom>
-          <a:noFill/>
-          <a:ln w="0">
-            <a:noFill/>
-          </a:ln>
-        </p:spPr>
-        <p:txBody>
-          <a:bodyPr wrap="none" lIns="0" tIns="0" rIns="0" bIns="0" anchor="ctr">
-            <a:noAutofit/>
-          </a:bodyPr>
-          <a:lstStyle/>
-          <a:p>
-            <a:pPr>
               <a:defRPr sz="1650" b="0">
                 <a:solidFill>
-                  <a:srgbClr val="1E302F"/>
+                  <a:srgbClr val="586C68"/>
                 </a:solidFill>
                 <a:latin typeface="Noto Sans KR"/>
                 <a:ea typeface="Noto Sans KR"/>
@@ -5305,80 +5538,23 @@
             <a:r>
               <a:rPr sz="1650" b="0">
                 <a:solidFill>
-                  <a:srgbClr val="1E302F"/>
+                  <a:srgbClr val="586C68"/>
                 </a:solidFill>
                 <a:latin typeface="Noto Sans KR"/>
                 <a:ea typeface="Noto Sans KR"/>
                 <a:cs typeface="Noto Sans KR"/>
               </a:rPr>
-              <a:t>48 → 12 MB</a:t>
+              <a:t>크기: 48 → 12 MB (−75%)</a:t>
             </a:r>
           </a:p>
         </p:txBody>
       </p:sp>
       <p:sp>
         <p:nvSpPr>
-          <p:cNvPr id="14" name="S04-f1-values">
+          <p:cNvPr id="13" name="S04-stage1">
             <a:extLst>
               <a:ext uri="{FF2B5EF4-FFF2-40B4-BE49-F238E27FC236}">
-                <a16:creationId xmlns:a16="http://schemas.microsoft.com/office/drawing/2014/main" id="{838B903E-1ED7-4096-8F97-D3A8A2CE3C51}"/>
-              </a:ext>
-            </a:extLst>
-          </p:cNvPr>
-          <p:cNvSpPr>
-            <a:spLocks noGrp="1"/>
-          </p:cNvSpPr>
-          <p:nvPr/>
-        </p:nvSpPr>
-        <p:spPr>
-          <a:xfrm>
-            <a:off x="9906000" y="4524375"/>
-            <a:ext cx="1657350" cy="323850"/>
-          </a:xfrm>
-          <a:prstGeom prst="rect">
-            <a:avLst/>
-          </a:prstGeom>
-          <a:noFill/>
-          <a:ln w="0">
-            <a:noFill/>
-          </a:ln>
-        </p:spPr>
-        <p:txBody>
-          <a:bodyPr wrap="none" lIns="0" tIns="0" rIns="0" bIns="0" anchor="ctr">
-            <a:noAutofit/>
-          </a:bodyPr>
-          <a:lstStyle/>
-          <a:p>
-            <a:pPr>
-              <a:defRPr sz="1575" b="0">
-                <a:solidFill>
-                  <a:srgbClr val="1E302F"/>
-                </a:solidFill>
-                <a:latin typeface="Noto Sans KR"/>
-                <a:ea typeface="Noto Sans KR"/>
-                <a:cs typeface="Noto Sans KR"/>
-              </a:defRPr>
-            </a:pPr>
-            <a:r>
-              <a:rPr sz="1575" b="0">
-                <a:solidFill>
-                  <a:srgbClr val="1E302F"/>
-                </a:solidFill>
-                <a:latin typeface="Noto Sans KR"/>
-                <a:ea typeface="Noto Sans KR"/>
-                <a:cs typeface="Noto Sans KR"/>
-              </a:rPr>
-              <a:t>0.910 → 0.896</a:t>
-            </a:r>
-          </a:p>
-        </p:txBody>
-      </p:sp>
-      <p:sp>
-        <p:nvSpPr>
-          <p:cNvPr id="15" name="S04-stage1">
-            <a:extLst>
-              <a:ext uri="{FF2B5EF4-FFF2-40B4-BE49-F238E27FC236}">
-                <a16:creationId xmlns:a16="http://schemas.microsoft.com/office/drawing/2014/main" id="{65A8E73D-5E69-41F3-AE05-2DC131139E5E}"/>
+                <a16:creationId xmlns:a16="http://schemas.microsoft.com/office/drawing/2014/main" id="{586C2BEF-64EF-4888-BBD7-763AB6753C14}"/>
               </a:ext>
             </a:extLst>
           </p:cNvPr>
@@ -5432,10 +5608,10 @@
       </p:sp>
       <p:sp>
         <p:nvSpPr>
-          <p:cNvPr id="16" name="S04-stage2">
+          <p:cNvPr id="14" name="S04-stage2">
             <a:extLst>
               <a:ext uri="{FF2B5EF4-FFF2-40B4-BE49-F238E27FC236}">
-                <a16:creationId xmlns:a16="http://schemas.microsoft.com/office/drawing/2014/main" id="{08403758-3D47-4C96-A8E1-5EEBEBAD0046}"/>
+                <a16:creationId xmlns:a16="http://schemas.microsoft.com/office/drawing/2014/main" id="{9DF67ADF-61F2-4493-9546-47594572DCEA}"/>
               </a:ext>
             </a:extLst>
           </p:cNvPr>
@@ -5490,7 +5666,7 @@
     </p:spTree>
     <p:extLst>
       <p:ext uri="{BB962C8B-B14F-4D97-AF65-F5344CB8AC3E}">
-        <p14:creationId xmlns:p14="http://schemas.microsoft.com/office/powerpoint/2010/main" val="1278212209"/>
+        <p14:creationId xmlns:p14="http://schemas.microsoft.com/office/powerpoint/2010/main" val="44023269"/>
       </p:ext>
     </p:extLst>
   </p:cSld>
@@ -5527,67 +5703,10 @@
       </p:grpSpPr>
       <p:sp>
         <p:nvSpPr>
-          <p:cNvPr id="15" name="S05-section">
+          <p:cNvPr id="14" name="S05-title">
             <a:extLst>
               <a:ext uri="{FF2B5EF4-FFF2-40B4-BE49-F238E27FC236}">
-                <a16:creationId xmlns:a16="http://schemas.microsoft.com/office/drawing/2014/main" id="{42D7F998-FF55-410F-BD42-814C71530E18}"/>
-              </a:ext>
-            </a:extLst>
-          </p:cNvPr>
-          <p:cNvSpPr>
-            <a:spLocks noGrp="1"/>
-          </p:cNvSpPr>
-          <p:nvPr/>
-        </p:nvSpPr>
-        <p:spPr>
-          <a:xfrm>
-            <a:off x="685800" y="400050"/>
-            <a:ext cx="10744200" cy="257175"/>
-          </a:xfrm>
-          <a:prstGeom prst="rect">
-            <a:avLst/>
-          </a:prstGeom>
-          <a:noFill/>
-          <a:ln w="0">
-            <a:noFill/>
-          </a:ln>
-        </p:spPr>
-        <p:txBody>
-          <a:bodyPr wrap="none" lIns="0" tIns="0" rIns="0" bIns="0" anchor="ctr">
-            <a:noAutofit/>
-          </a:bodyPr>
-          <a:lstStyle/>
-          <a:p>
-            <a:pPr>
-              <a:defRPr sz="1425" b="0">
-                <a:solidFill>
-                  <a:srgbClr val="287D78"/>
-                </a:solidFill>
-                <a:latin typeface="Noto Sans KR"/>
-                <a:ea typeface="Noto Sans KR"/>
-                <a:cs typeface="Noto Sans KR"/>
-              </a:defRPr>
-            </a:pPr>
-            <a:r>
-              <a:rPr sz="1425" b="0">
-                <a:solidFill>
-                  <a:srgbClr val="287D78"/>
-                </a:solidFill>
-                <a:latin typeface="Noto Sans KR"/>
-                <a:ea typeface="Noto Sans KR"/>
-                <a:cs typeface="Noto Sans KR"/>
-              </a:rPr>
-              <a:t>다음 / 허용할 성능 교환관계</a:t>
-            </a:r>
-          </a:p>
-        </p:txBody>
-      </p:sp>
-      <p:sp>
-        <p:nvSpPr>
-          <p:cNvPr id="2" name="S05-title">
-            <a:extLst>
-              <a:ext uri="{FF2B5EF4-FFF2-40B4-BE49-F238E27FC236}">
-                <a16:creationId xmlns:a16="http://schemas.microsoft.com/office/drawing/2014/main" id="{C6BEBF20-3320-409C-B961-791221FD798B}"/>
+                <a16:creationId xmlns:a16="http://schemas.microsoft.com/office/drawing/2014/main" id="{4737C698-4CD5-45D5-A0F0-08B9F4769C2A}"/>
               </a:ext>
             </a:extLst>
           </p:cNvPr>
@@ -5641,10 +5760,10 @@
       </p:sp>
       <p:sp>
         <p:nvSpPr>
-          <p:cNvPr id="3" name="S05-disclosure">
+          <p:cNvPr id="2" name="S05-disclosure">
             <a:extLst>
               <a:ext uri="{FF2B5EF4-FFF2-40B4-BE49-F238E27FC236}">
-                <a16:creationId xmlns:a16="http://schemas.microsoft.com/office/drawing/2014/main" id="{F6A842F9-7F84-4563-A02D-5D5E2D699178}"/>
+                <a16:creationId xmlns:a16="http://schemas.microsoft.com/office/drawing/2014/main" id="{42639841-CE3F-42F4-949D-BF2F8033C43C}"/>
               </a:ext>
             </a:extLst>
           </p:cNvPr>
@@ -5698,10 +5817,10 @@
       </p:sp>
       <p:sp>
         <p:nvSpPr>
-          <p:cNvPr id="4" name="S05-number">
+          <p:cNvPr id="3" name="S05-number">
             <a:extLst>
               <a:ext uri="{FF2B5EF4-FFF2-40B4-BE49-F238E27FC236}">
-                <a16:creationId xmlns:a16="http://schemas.microsoft.com/office/drawing/2014/main" id="{6A248280-4317-4916-A553-C473233BC3BD}"/>
+                <a16:creationId xmlns:a16="http://schemas.microsoft.com/office/drawing/2014/main" id="{7F9FAA97-72BE-4A4E-B53B-2FCD5772A653}"/>
               </a:ext>
             </a:extLst>
           </p:cNvPr>
@@ -5755,10 +5874,10 @@
       </p:sp>
       <p:sp>
         <p:nvSpPr>
-          <p:cNvPr id="5" name="S05-main">
+          <p:cNvPr id="4" name="S05-main">
             <a:extLst>
               <a:ext uri="{FF2B5EF4-FFF2-40B4-BE49-F238E27FC236}">
-                <a16:creationId xmlns:a16="http://schemas.microsoft.com/office/drawing/2014/main" id="{EA556279-94B2-48B1-A83F-52925F04EBC4}"/>
+                <a16:creationId xmlns:a16="http://schemas.microsoft.com/office/drawing/2014/main" id="{DC2100DC-2E95-4332-B2A6-3029477C105A}"/>
               </a:ext>
             </a:extLst>
           </p:cNvPr>
@@ -5812,10 +5931,10 @@
       </p:sp>
       <p:sp>
         <p:nvSpPr>
-          <p:cNvPr id="6" name="S05-rule-1">
+          <p:cNvPr id="5" name="S05-rule-1">
             <a:extLst>
               <a:ext uri="{FF2B5EF4-FFF2-40B4-BE49-F238E27FC236}">
-                <a16:creationId xmlns:a16="http://schemas.microsoft.com/office/drawing/2014/main" id="{E5F53197-433B-472F-8D82-C6B19CB332C8}"/>
+                <a16:creationId xmlns:a16="http://schemas.microsoft.com/office/drawing/2014/main" id="{E698A027-85A2-4EA9-BF8A-7E2544EAEFF4}"/>
               </a:ext>
             </a:extLst>
           </p:cNvPr>
@@ -5841,10 +5960,10 @@
       </p:sp>
       <p:sp>
         <p:nvSpPr>
-          <p:cNvPr id="7" name="S05-label1">
+          <p:cNvPr id="6" name="S05-label1">
             <a:extLst>
               <a:ext uri="{FF2B5EF4-FFF2-40B4-BE49-F238E27FC236}">
-                <a16:creationId xmlns:a16="http://schemas.microsoft.com/office/drawing/2014/main" id="{B807D6D0-063E-42FB-ABD6-E126C4F785E8}"/>
+                <a16:creationId xmlns:a16="http://schemas.microsoft.com/office/drawing/2014/main" id="{9D6977D7-6C65-42C3-9741-CB1C7DDDB054}"/>
               </a:ext>
             </a:extLst>
           </p:cNvPr>
@@ -5898,10 +6017,10 @@
       </p:sp>
       <p:sp>
         <p:nvSpPr>
-          <p:cNvPr id="8" name="S05-body1">
+          <p:cNvPr id="7" name="S05-body1">
             <a:extLst>
               <a:ext uri="{FF2B5EF4-FFF2-40B4-BE49-F238E27FC236}">
-                <a16:creationId xmlns:a16="http://schemas.microsoft.com/office/drawing/2014/main" id="{C4C337A0-BC8E-417F-81D2-BF9A93ACFD78}"/>
+                <a16:creationId xmlns:a16="http://schemas.microsoft.com/office/drawing/2014/main" id="{89842C62-B6C5-48A9-B4F9-68744343FF74}"/>
               </a:ext>
             </a:extLst>
           </p:cNvPr>
@@ -5955,10 +6074,10 @@
       </p:sp>
       <p:sp>
         <p:nvSpPr>
-          <p:cNvPr id="9" name="S05-rule-2">
+          <p:cNvPr id="8" name="S05-rule-2">
             <a:extLst>
               <a:ext uri="{FF2B5EF4-FFF2-40B4-BE49-F238E27FC236}">
-                <a16:creationId xmlns:a16="http://schemas.microsoft.com/office/drawing/2014/main" id="{42C9FD44-9EDC-4568-8C59-5B9E4737D8D9}"/>
+                <a16:creationId xmlns:a16="http://schemas.microsoft.com/office/drawing/2014/main" id="{50ED2E59-FBD9-49CE-A222-F071A2C1C335}"/>
               </a:ext>
             </a:extLst>
           </p:cNvPr>
@@ -5984,10 +6103,10 @@
       </p:sp>
       <p:sp>
         <p:nvSpPr>
-          <p:cNvPr id="10" name="S05-label2">
+          <p:cNvPr id="9" name="S05-label2">
             <a:extLst>
               <a:ext uri="{FF2B5EF4-FFF2-40B4-BE49-F238E27FC236}">
-                <a16:creationId xmlns:a16="http://schemas.microsoft.com/office/drawing/2014/main" id="{800E607F-00DE-476D-BA11-67246C4B34D4}"/>
+                <a16:creationId xmlns:a16="http://schemas.microsoft.com/office/drawing/2014/main" id="{2E44F1E7-3F37-4F6D-9BA9-8A10DD3586F6}"/>
               </a:ext>
             </a:extLst>
           </p:cNvPr>
@@ -6041,10 +6160,10 @@
       </p:sp>
       <p:sp>
         <p:nvSpPr>
-          <p:cNvPr id="11" name="S05-body2">
+          <p:cNvPr id="10" name="S05-body2">
             <a:extLst>
               <a:ext uri="{FF2B5EF4-FFF2-40B4-BE49-F238E27FC236}">
-                <a16:creationId xmlns:a16="http://schemas.microsoft.com/office/drawing/2014/main" id="{5BF0987A-01F3-4B68-A3AE-2B4B2D5CD26E}"/>
+                <a16:creationId xmlns:a16="http://schemas.microsoft.com/office/drawing/2014/main" id="{605E1C97-5A36-412E-ABEA-A69DA6BB455C}"/>
               </a:ext>
             </a:extLst>
           </p:cNvPr>
@@ -6098,10 +6217,10 @@
       </p:sp>
       <p:sp>
         <p:nvSpPr>
-          <p:cNvPr id="12" name="S05-rule-3">
+          <p:cNvPr id="11" name="S05-rule-3">
             <a:extLst>
               <a:ext uri="{FF2B5EF4-FFF2-40B4-BE49-F238E27FC236}">
-                <a16:creationId xmlns:a16="http://schemas.microsoft.com/office/drawing/2014/main" id="{8BA3B5F6-4279-486B-B4CB-017474A38E86}"/>
+                <a16:creationId xmlns:a16="http://schemas.microsoft.com/office/drawing/2014/main" id="{ADD61140-B570-4E07-A12B-810D670CF658}"/>
               </a:ext>
             </a:extLst>
           </p:cNvPr>
@@ -6127,10 +6246,10 @@
       </p:sp>
       <p:sp>
         <p:nvSpPr>
-          <p:cNvPr id="13" name="S05-label3">
+          <p:cNvPr id="12" name="S05-label3">
             <a:extLst>
               <a:ext uri="{FF2B5EF4-FFF2-40B4-BE49-F238E27FC236}">
-                <a16:creationId xmlns:a16="http://schemas.microsoft.com/office/drawing/2014/main" id="{44091A20-5CD4-48D5-AEC3-E26D5728F198}"/>
+                <a16:creationId xmlns:a16="http://schemas.microsoft.com/office/drawing/2014/main" id="{BE3AA318-48A1-4234-B7BE-05EFBFD78697}"/>
               </a:ext>
             </a:extLst>
           </p:cNvPr>
@@ -6184,10 +6303,10 @@
       </p:sp>
       <p:sp>
         <p:nvSpPr>
-          <p:cNvPr id="14" name="S05-body3">
+          <p:cNvPr id="13" name="S05-body3">
             <a:extLst>
               <a:ext uri="{FF2B5EF4-FFF2-40B4-BE49-F238E27FC236}">
-                <a16:creationId xmlns:a16="http://schemas.microsoft.com/office/drawing/2014/main" id="{FADB47FE-B030-4621-8B38-BFAA8F24BE5A}"/>
+                <a16:creationId xmlns:a16="http://schemas.microsoft.com/office/drawing/2014/main" id="{B7CA930B-B241-480F-9CC0-727D9BCFAE49}"/>
               </a:ext>
             </a:extLst>
           </p:cNvPr>
@@ -6242,7 +6361,7 @@
     </p:spTree>
     <p:extLst>
       <p:ext uri="{BB962C8B-B14F-4D97-AF65-F5344CB8AC3E}">
-        <p14:creationId xmlns:p14="http://schemas.microsoft.com/office/powerpoint/2010/main" val="898189524"/>
+        <p14:creationId xmlns:p14="http://schemas.microsoft.com/office/powerpoint/2010/main" val="907048644"/>
       </p:ext>
     </p:extLst>
   </p:cSld>

</xml_diff>

<commit_message>
Separate private brief metadata and strengthen slide composition
</commit_message>
<xml_diff>
--- a/examples/research-seminar/animated-ko.pptx
+++ b/examples/research-seminar/animated-ko.pptx
@@ -184,7 +184,7 @@
                   <c15:showDataLabelsRange val="0"/>
                 </c:ext>
                 <c:ext xmlns:c16="http://schemas.microsoft.com/office/drawing/2014/chart" uri="{C3380CC4-5D6E-409C-BE32-E72D297353CC}">
-                  <c16:uniqueId val="{00000000-DE7C-4D94-8E1B-0E6D337F9C00}"/>
+                  <c16:uniqueId val="{00000000-787B-4AE7-A3AD-B33B49151692}"/>
                 </c:ext>
               </c:extLst>
             </c:dLbl>
@@ -221,7 +221,7 @@
                   <c15:showDataLabelsRange val="0"/>
                 </c:ext>
                 <c:ext xmlns:c16="http://schemas.microsoft.com/office/drawing/2014/chart" uri="{C3380CC4-5D6E-409C-BE32-E72D297353CC}">
-                  <c16:uniqueId val="{00000001-DE7C-4D94-8E1B-0E6D337F9C00}"/>
+                  <c16:uniqueId val="{00000001-787B-4AE7-A3AD-B33B49151692}"/>
                 </c:ext>
               </c:extLst>
             </c:dLbl>
@@ -258,7 +258,7 @@
                   <c15:showDataLabelsRange val="0"/>
                 </c:ext>
                 <c:ext xmlns:c16="http://schemas.microsoft.com/office/drawing/2014/chart" uri="{C3380CC4-5D6E-409C-BE32-E72D297353CC}">
-                  <c16:uniqueId val="{00000002-DE7C-4D94-8E1B-0E6D337F9C00}"/>
+                  <c16:uniqueId val="{00000002-787B-4AE7-A3AD-B33B49151692}"/>
                 </c:ext>
               </c:extLst>
             </c:dLbl>
@@ -321,7 +321,7 @@
           <c:smooth val="1"/>
           <c:extLst>
             <c:ext xmlns:c16="http://schemas.microsoft.com/office/drawing/2014/chart" uri="{C3380CC4-5D6E-409C-BE32-E72D297353CC}">
-              <c16:uniqueId val="{00000003-DE7C-4D94-8E1B-0E6D337F9C00}"/>
+              <c16:uniqueId val="{00000003-787B-4AE7-A3AD-B33B49151692}"/>
             </c:ext>
           </c:extLst>
         </c:ser>
@@ -666,7 +666,7 @@
           <a:lstStyle/>
           <a:p>
             <a:r>
-              <a:t>30초. 센서 이상 탐지 모델의 경량화를 살펴본다. 원본 모델과 INT8의 지연, F1, 크기를 같은 비중으로 비교한다. 모든 수치는 사용자가 제공한 가상 예시이며 실험 결과가 아니다. 동일 장치와 데이터를 가정하지만 구체적인 조건과 허용 F1 저하 기준은 미제공이다.</a:t>
+              <a:t>센서 이상 탐지 모델의 경량화를 살펴본다. 원본 모델과 INT8의 지연, F1, 모델 크기를 비교한다. 모든 수치는 사용자가 제공한 가상 예시이며 실험 결과가 아니다. 동일 장치와 데이터를 가정하지만 구체적인 조건과 허용 F1 저하 기준은 미제공이다.</a:t>
             </a:r>
           </a:p>
         </p:txBody>
@@ -743,7 +743,7 @@
           <a:lstStyle/>
           <a:p>
             <a:r>
-              <a:t>90초. 교사의 예측을 학생 학습에 활용하는 지식 증류와 8비트 정수 표현을 개념적으로 설명한다. 모델 구조, 손실함수, 양자화 범위, PTQ/QAT는 미제공이다. 교사의 지식이 모두 보존된다고 주장하지 않는다. 애니메이션판은 첫 클릭에 증류, 둘째 클릭에 INT8 단계를 표시한다. 개념 출처: Hinton et al. (2015), https://arxiv.org/abs/1503.02531 ; Jacob et al. (2017), https://arxiv.org/abs/1712.05877 . 문헌의 성능 수치를 사용하지 않았다.</a:t>
+              <a:t>교사의 예측을 학생 학습에 활용하는 지식 증류와 8비트 정수 표현을 개념적으로 설명한다. 모델 구조, 손실함수, 양자화 범위, PTQ/QAT는 미제공이다. 교사의 지식이 모두 보존된다고 주장하지 않는다. 개념 출처: Hinton et al. (2015), https://arxiv.org/abs/1503.02531 ; Jacob et al. (2017), https://arxiv.org/abs/1712.05877 . 문헌의 성능 수치를 사용하지 않았다.</a:t>
             </a:r>
           </a:p>
         </p:txBody>
@@ -820,7 +820,7 @@
           <a:lstStyle/>
           <a:p>
             <a:r>
-              <a:t>60초. 가상 수치: baseline 120ms / F1 0.910 / 48MB; distilled 72ms / 0.902 / 18MB; int8 54ms / 0.896 / 12MB. 동일 장치와 데이터를 가정한다. 표본수, 분산, 데이터셋명, 데이터 분할, 장치 사양, 지연 통계량 정의, F1 집계 방법은 미제공이다. 산술 비교이며 통계적 유의성이나 일반화를 판단할 수 없다.</a:t>
+              <a:t>가상 수치: baseline 120ms / F1 0.910 / 48MB; distilled 72ms / 0.902 / 18MB; int8 54ms / 0.896 / 12MB. 동일 장치와 데이터를 가정한다. 표본수, 분산, 데이터셋명, 데이터 분할, 장치 사양, 지연 통계량 정의, F1 집계 방법은 미제공이다. 산술 비교이며 통계적 유의성이나 일반화를 판단할 수 없다.</a:t>
             </a:r>
           </a:p>
         </p:txBody>
@@ -897,7 +897,7 @@
           <a:lstStyle/>
           <a:p>
             <a:r>
-              <a:t>65초. 전체 지연 감소율 (120−54)/120 = 55%; 크기 감소율 (48−12)/48 = 75%; F1 절대 차이 0.896−0.910 = −0.014. 증류 지연 감소율 (120−72)/120 = 40%, F1 차이 −0.008. 추가 INT8 지연 감소율 (72−54)/72 = 25%, F1 차이 −0.006. 분모가 달라 40%와 25%를 더하지 않는다. 가상 요약값으로 통계적 판단을 할 수 없다.</a:t>
+              <a:t>전체 지연 감소율 (120−54)/120 = 55%; 크기 감소율 (48−12)/48 = 75%; F1 절대 차이 0.896−0.910 = −0.014. 증류 지연 감소율 (120−72)/120 = 40%, F1 차이 −0.008. 추가 INT8 지연 감소율 (72−54)/72 = 25%, F1 차이 −0.006. 분모가 달라 40%와 25%를 더하지 않는다. 가상 요약값으로 통계적 판단을 할 수 없다.</a:t>
             </a:r>
           </a:p>
         </p:txBody>
@@ -974,7 +974,7 @@
           <a:lstStyle/>
           <a:p>
             <a:r>
-              <a:t>55초. 이 가상 예시는 효율과 F1의 교환관계를 보여준다. 모든 환경에서 가장 좋은 모델을 정할 수는 없다. 사용 환경에 맞는 허용 F1 저하와 지연 한도를 먼저 정한다. 실제 데이터에서 반복 측정의 분산과 이상 유형별 실패 사례를 확인한다. 데이터셋명과 표본수가 없어 일반화 판단은 불가하다. 총 발표 시간 300초.</a:t>
+              <a:t>이 가상 예시는 효율과 F1의 교환관계를 보여준다. 모든 환경에서 가장 좋은 모델을 정할 수는 없다. 사용 환경에 맞는 허용 F1 저하와 지연 한도를 먼저 정한다. 실제 데이터에서 반복 측정의 분산과 이상 유형별 실패 사례를 확인한다. 데이터셋명과 표본수가 없어 일반화 판단은 불가하다.</a:t>
             </a:r>
           </a:p>
         </p:txBody>
@@ -1366,10 +1366,10 @@
       </p:grpSpPr>
       <p:sp>
         <p:nvSpPr>
-          <p:cNvPr id="13" name="S01-section">
+          <p:cNvPr id="20" name="S01-subject-field">
             <a:extLst>
               <a:ext uri="{FF2B5EF4-FFF2-40B4-BE49-F238E27FC236}">
-                <a16:creationId xmlns:a16="http://schemas.microsoft.com/office/drawing/2014/main" id="{420456A6-FCE9-4F6F-84C8-CF7264E539F3}"/>
+                <a16:creationId xmlns:a16="http://schemas.microsoft.com/office/drawing/2014/main" id="{746ADAD8-0A0A-42C3-9E30-426E7EC522FD}"/>
               </a:ext>
             </a:extLst>
           </p:cNvPr>
@@ -1380,8 +1380,38 @@
         </p:nvSpPr>
         <p:spPr>
           <a:xfrm>
-            <a:off x="685800" y="609600"/>
-            <a:ext cx="10820400" cy="333375"/>
+            <a:off x="0" y="0"/>
+            <a:ext cx="5638800" cy="6858000"/>
+          </a:xfrm>
+          <a:prstGeom prst="rect">
+            <a:avLst/>
+          </a:prstGeom>
+          <a:solidFill>
+            <a:srgbClr val="1E302F"/>
+          </a:solidFill>
+          <a:ln w="0">
+            <a:noFill/>
+          </a:ln>
+        </p:spPr>
+      </p:sp>
+      <p:sp>
+        <p:nvSpPr>
+          <p:cNvPr id="2" name="S01-title">
+            <a:extLst>
+              <a:ext uri="{FF2B5EF4-FFF2-40B4-BE49-F238E27FC236}">
+                <a16:creationId xmlns:a16="http://schemas.microsoft.com/office/drawing/2014/main" id="{B05C087C-A36B-4835-B418-125462CAABD1}"/>
+              </a:ext>
+            </a:extLst>
+          </p:cNvPr>
+          <p:cNvSpPr>
+            <a:spLocks noGrp="1"/>
+          </p:cNvSpPr>
+          <p:nvPr/>
+        </p:nvSpPr>
+        <p:spPr>
+          <a:xfrm>
+            <a:off x="609600" y="1266825"/>
+            <a:ext cx="4552950" cy="2209800"/>
           </a:xfrm>
           <a:prstGeom prst="rect">
             <a:avLst/>
@@ -1398,9 +1428,9 @@
           <a:lstStyle/>
           <a:p>
             <a:pPr>
-              <a:defRPr sz="1650" b="0">
-                <a:solidFill>
-                  <a:srgbClr val="586C68"/>
+              <a:defRPr sz="3675" b="0">
+                <a:solidFill>
+                  <a:srgbClr val="FFFFFF"/>
                 </a:solidFill>
                 <a:latin typeface="Noto Sans KR"/>
                 <a:ea typeface="Noto Sans KR"/>
@@ -1408,25 +1438,48 @@
               </a:defRPr>
             </a:pPr>
             <a:r>
-              <a:rPr sz="1650" b="0">
-                <a:solidFill>
-                  <a:srgbClr val="586C68"/>
+              <a:rPr sz="3675" b="0">
+                <a:solidFill>
+                  <a:srgbClr val="FFFFFF"/>
                 </a:solidFill>
                 <a:latin typeface="Noto Sans KR"/>
                 <a:ea typeface="Noto Sans KR"/>
                 <a:cs typeface="Noto Sans KR"/>
               </a:rPr>
-              <a:t>연구실 세미나 · 5분</a:t>
+              <a:t>센서 이상 탐지</a:t>
             </a:r>
           </a:p>
-        </p:txBody>
-      </p:sp>
-      <p:sp>
-        <p:nvSpPr>
-          <p:cNvPr id="2" name="S01-title">
+          <a:p>
+            <a:pPr>
+              <a:defRPr sz="3675" b="0">
+                <a:solidFill>
+                  <a:srgbClr val="FFFFFF"/>
+                </a:solidFill>
+                <a:latin typeface="Noto Sans KR"/>
+                <a:ea typeface="Noto Sans KR"/>
+                <a:cs typeface="Noto Sans KR"/>
+              </a:defRPr>
+            </a:pPr>
+            <a:r>
+              <a:rPr sz="3675" b="0">
+                <a:solidFill>
+                  <a:srgbClr val="FFFFFF"/>
+                </a:solidFill>
+                <a:latin typeface="Noto Sans KR"/>
+                <a:ea typeface="Noto Sans KR"/>
+                <a:cs typeface="Noto Sans KR"/>
+              </a:rPr>
+              <a:t>모델의 경량화</a:t>
+            </a:r>
+          </a:p>
+        </p:txBody>
+      </p:sp>
+      <p:sp>
+        <p:nvSpPr>
+          <p:cNvPr id="3" name="S01-subtitle">
             <a:extLst>
               <a:ext uri="{FF2B5EF4-FFF2-40B4-BE49-F238E27FC236}">
-                <a16:creationId xmlns:a16="http://schemas.microsoft.com/office/drawing/2014/main" id="{B9AFD74C-2672-413F-8675-C61FF1B8F984}"/>
+                <a16:creationId xmlns:a16="http://schemas.microsoft.com/office/drawing/2014/main" id="{3120C155-0FD1-4A4D-9FC6-90E448CC1487}"/>
               </a:ext>
             </a:extLst>
           </p:cNvPr>
@@ -1437,8 +1490,8 @@
         </p:nvSpPr>
         <p:spPr>
           <a:xfrm>
-            <a:off x="685800" y="1438275"/>
-            <a:ext cx="10820400" cy="1476375"/>
+            <a:off x="609600" y="3933825"/>
+            <a:ext cx="4381500" cy="990600"/>
           </a:xfrm>
           <a:prstGeom prst="rect">
             <a:avLst/>
@@ -1455,89 +1508,9 @@
           <a:lstStyle/>
           <a:p>
             <a:pPr>
-              <a:defRPr sz="4050" b="0">
-                <a:solidFill>
-                  <a:srgbClr val="1E302F"/>
-                </a:solidFill>
-                <a:latin typeface="Noto Sans KR"/>
-                <a:ea typeface="Noto Sans KR"/>
-                <a:cs typeface="Noto Sans KR"/>
-              </a:defRPr>
-            </a:pPr>
-            <a:r>
-              <a:rPr sz="4050" b="0">
-                <a:solidFill>
-                  <a:srgbClr val="1E302F"/>
-                </a:solidFill>
-                <a:latin typeface="Noto Sans KR"/>
-                <a:ea typeface="Noto Sans KR"/>
-                <a:cs typeface="Noto Sans KR"/>
-              </a:rPr>
-              <a:t>센서 이상 탐지 모델의</a:t>
-            </a:r>
-          </a:p>
-          <a:p>
-            <a:pPr>
-              <a:defRPr sz="4050" b="0">
-                <a:solidFill>
-                  <a:srgbClr val="1E302F"/>
-                </a:solidFill>
-                <a:latin typeface="Noto Sans KR"/>
-                <a:ea typeface="Noto Sans KR"/>
-                <a:cs typeface="Noto Sans KR"/>
-              </a:defRPr>
-            </a:pPr>
-            <a:r>
-              <a:rPr sz="4050" b="0">
-                <a:solidFill>
-                  <a:srgbClr val="1E302F"/>
-                </a:solidFill>
-                <a:latin typeface="Noto Sans KR"/>
-                <a:ea typeface="Noto Sans KR"/>
-                <a:cs typeface="Noto Sans KR"/>
-              </a:rPr>
-              <a:t>경량화와 성능 변화</a:t>
-            </a:r>
-          </a:p>
-        </p:txBody>
-      </p:sp>
-      <p:sp>
-        <p:nvSpPr>
-          <p:cNvPr id="3" name="S01-subtitle">
-            <a:extLst>
-              <a:ext uri="{FF2B5EF4-FFF2-40B4-BE49-F238E27FC236}">
-                <a16:creationId xmlns:a16="http://schemas.microsoft.com/office/drawing/2014/main" id="{6ECF9552-EC94-4D59-B398-6D7B8A23CAA8}"/>
-              </a:ext>
-            </a:extLst>
-          </p:cNvPr>
-          <p:cNvSpPr>
-            <a:spLocks noGrp="1"/>
-          </p:cNvSpPr>
-          <p:nvPr/>
-        </p:nvSpPr>
-        <p:spPr>
-          <a:xfrm>
-            <a:off x="685800" y="3133725"/>
-            <a:ext cx="10820400" cy="495300"/>
-          </a:xfrm>
-          <a:prstGeom prst="rect">
-            <a:avLst/>
-          </a:prstGeom>
-          <a:noFill/>
-          <a:ln w="0">
-            <a:noFill/>
-          </a:ln>
-        </p:spPr>
-        <p:txBody>
-          <a:bodyPr wrap="none" lIns="0" tIns="0" rIns="0" bIns="0" anchor="ctr">
-            <a:noAutofit/>
-          </a:bodyPr>
-          <a:lstStyle/>
-          <a:p>
-            <a:pPr>
               <a:defRPr sz="2175" b="0">
                 <a:solidFill>
-                  <a:srgbClr val="586C68"/>
+                  <a:srgbClr val="B9DDD0"/>
                 </a:solidFill>
                 <a:latin typeface="Noto Sans KR"/>
                 <a:ea typeface="Noto Sans KR"/>
@@ -1547,23 +1520,46 @@
             <a:r>
               <a:rPr sz="2175" b="0">
                 <a:solidFill>
-                  <a:srgbClr val="586C68"/>
+                  <a:srgbClr val="B9DDD0"/>
                 </a:solidFill>
                 <a:latin typeface="Noto Sans KR"/>
                 <a:ea typeface="Noto Sans KR"/>
                 <a:cs typeface="Noto Sans KR"/>
               </a:rPr>
-              <a:t>지식 증류와 INT8 양자화</a:t>
+              <a:t>지식 증류와</a:t>
             </a:r>
           </a:p>
-        </p:txBody>
-      </p:sp>
-      <p:sp>
-        <p:nvSpPr>
-          <p:cNvPr id="4" name="S01-basis">
+          <a:p>
+            <a:pPr>
+              <a:defRPr sz="2175" b="0">
+                <a:solidFill>
+                  <a:srgbClr val="B9DDD0"/>
+                </a:solidFill>
+                <a:latin typeface="Noto Sans KR"/>
+                <a:ea typeface="Noto Sans KR"/>
+                <a:cs typeface="Noto Sans KR"/>
+              </a:defRPr>
+            </a:pPr>
+            <a:r>
+              <a:rPr sz="2175" b="0">
+                <a:solidFill>
+                  <a:srgbClr val="B9DDD0"/>
+                </a:solidFill>
+                <a:latin typeface="Noto Sans KR"/>
+                <a:ea typeface="Noto Sans KR"/>
+                <a:cs typeface="Noto Sans KR"/>
+              </a:rPr>
+              <a:t>INT8 양자화</a:t>
+            </a:r>
+          </a:p>
+        </p:txBody>
+      </p:sp>
+      <p:sp>
+        <p:nvSpPr>
+          <p:cNvPr id="4" name="S01-comparison">
             <a:extLst>
               <a:ext uri="{FF2B5EF4-FFF2-40B4-BE49-F238E27FC236}">
-                <a16:creationId xmlns:a16="http://schemas.microsoft.com/office/drawing/2014/main" id="{B39041A1-C695-49C2-9A48-FF38407411D4}"/>
+                <a16:creationId xmlns:a16="http://schemas.microsoft.com/office/drawing/2014/main" id="{51CC5895-193D-49BD-A1D7-879EA49C3539}"/>
               </a:ext>
             </a:extLst>
           </p:cNvPr>
@@ -1574,8 +1570,65 @@
         </p:nvSpPr>
         <p:spPr>
           <a:xfrm>
-            <a:off x="685800" y="4105275"/>
-            <a:ext cx="10820400" cy="342900"/>
+            <a:off x="6210300" y="1009650"/>
+            <a:ext cx="5353050" cy="723900"/>
+          </a:xfrm>
+          <a:prstGeom prst="rect">
+            <a:avLst/>
+          </a:prstGeom>
+          <a:noFill/>
+          <a:ln w="0">
+            <a:noFill/>
+          </a:ln>
+        </p:spPr>
+        <p:txBody>
+          <a:bodyPr wrap="none" lIns="0" tIns="0" rIns="0" bIns="0" anchor="ctr">
+            <a:noAutofit/>
+          </a:bodyPr>
+          <a:lstStyle/>
+          <a:p>
+            <a:pPr>
+              <a:defRPr sz="2850" b="0">
+                <a:solidFill>
+                  <a:srgbClr val="1E302F"/>
+                </a:solidFill>
+                <a:latin typeface="Noto Sans KR"/>
+                <a:ea typeface="Noto Sans KR"/>
+                <a:cs typeface="Noto Sans KR"/>
+              </a:defRPr>
+            </a:pPr>
+            <a:r>
+              <a:rPr sz="2850" b="0">
+                <a:solidFill>
+                  <a:srgbClr val="1E302F"/>
+                </a:solidFill>
+                <a:latin typeface="Noto Sans KR"/>
+                <a:ea typeface="Noto Sans KR"/>
+                <a:cs typeface="Noto Sans KR"/>
+              </a:rPr>
+              <a:t>경량화에 따른 변화</a:t>
+            </a:r>
+          </a:p>
+        </p:txBody>
+      </p:sp>
+      <p:sp>
+        <p:nvSpPr>
+          <p:cNvPr id="5" name="S01-baseline">
+            <a:extLst>
+              <a:ext uri="{FF2B5EF4-FFF2-40B4-BE49-F238E27FC236}">
+                <a16:creationId xmlns:a16="http://schemas.microsoft.com/office/drawing/2014/main" id="{218C01A4-902C-41E9-B1A2-9722D27E7550}"/>
+              </a:ext>
+            </a:extLst>
+          </p:cNvPr>
+          <p:cNvSpPr>
+            <a:spLocks noGrp="1"/>
+          </p:cNvSpPr>
+          <p:nvPr/>
+        </p:nvSpPr>
+        <p:spPr>
+          <a:xfrm>
+            <a:off x="8258175" y="2076450"/>
+            <a:ext cx="1428750" cy="304800"/>
           </a:xfrm>
           <a:prstGeom prst="rect">
             <a:avLst/>
@@ -1610,17 +1663,17 @@
                 <a:ea typeface="Noto Sans KR"/>
                 <a:cs typeface="Noto Sans KR"/>
               </a:rPr>
-              <a:t>원본 모델과 INT8 비교</a:t>
+              <a:t>baseline</a:t>
             </a:r>
           </a:p>
         </p:txBody>
       </p:sp>
       <p:sp>
         <p:nvSpPr>
-          <p:cNvPr id="5" name="S01-value-1">
+          <p:cNvPr id="6" name="S01-int8">
             <a:extLst>
               <a:ext uri="{FF2B5EF4-FFF2-40B4-BE49-F238E27FC236}">
-                <a16:creationId xmlns:a16="http://schemas.microsoft.com/office/drawing/2014/main" id="{B2B09459-D43D-4E70-9665-D02E90A3FF5F}"/>
+                <a16:creationId xmlns:a16="http://schemas.microsoft.com/office/drawing/2014/main" id="{EB63A2B3-810A-465D-B07E-29C3498E6124}"/>
               </a:ext>
             </a:extLst>
           </p:cNvPr>
@@ -1631,8 +1684,8 @@
         </p:nvSpPr>
         <p:spPr>
           <a:xfrm>
-            <a:off x="685800" y="4619625"/>
-            <a:ext cx="2952750" cy="628650"/>
+            <a:off x="10382250" y="2076450"/>
+            <a:ext cx="1190625" cy="304800"/>
           </a:xfrm>
           <a:prstGeom prst="rect">
             <a:avLst/>
@@ -1649,9 +1702,9 @@
           <a:lstStyle/>
           <a:p>
             <a:pPr>
-              <a:defRPr sz="3225" b="0">
-                <a:solidFill>
-                  <a:srgbClr val="1E302F"/>
+              <a:defRPr sz="1725" b="0">
+                <a:solidFill>
+                  <a:srgbClr val="586C68"/>
                 </a:solidFill>
                 <a:latin typeface="Noto Sans KR"/>
                 <a:ea typeface="Noto Sans KR"/>
@@ -1659,25 +1712,25 @@
               </a:defRPr>
             </a:pPr>
             <a:r>
-              <a:rPr sz="3225" b="0">
-                <a:solidFill>
-                  <a:srgbClr val="1E302F"/>
+              <a:rPr sz="1725" b="0">
+                <a:solidFill>
+                  <a:srgbClr val="586C68"/>
                 </a:solidFill>
                 <a:latin typeface="Noto Sans KR"/>
                 <a:ea typeface="Noto Sans KR"/>
                 <a:cs typeface="Noto Sans KR"/>
               </a:rPr>
-              <a:t>120 → 54</a:t>
+              <a:t>int8</a:t>
             </a:r>
           </a:p>
         </p:txBody>
       </p:sp>
       <p:sp>
         <p:nvSpPr>
-          <p:cNvPr id="6" name="S01-label-1">
+          <p:cNvPr id="7" name="S01-rule-0">
             <a:extLst>
               <a:ext uri="{FF2B5EF4-FFF2-40B4-BE49-F238E27FC236}">
-                <a16:creationId xmlns:a16="http://schemas.microsoft.com/office/drawing/2014/main" id="{B98F8C9A-543B-4ED7-BED6-EFE72739E5EC}"/>
+                <a16:creationId xmlns:a16="http://schemas.microsoft.com/office/drawing/2014/main" id="{BF039235-0D75-447F-9A6F-E9DCFEF45893}"/>
               </a:ext>
             </a:extLst>
           </p:cNvPr>
@@ -1688,8 +1741,37 @@
         </p:nvSpPr>
         <p:spPr>
           <a:xfrm>
-            <a:off x="685800" y="5314950"/>
-            <a:ext cx="3143250" cy="361950"/>
+            <a:off x="6210300" y="2581275"/>
+            <a:ext cx="5372100" cy="0"/>
+          </a:xfrm>
+          <a:prstGeom prst="line">
+            <a:avLst/>
+          </a:prstGeom>
+          <a:ln w="9525">
+            <a:solidFill>
+              <a:srgbClr val="CFD8D1"/>
+            </a:solidFill>
+          </a:ln>
+        </p:spPr>
+      </p:sp>
+      <p:sp>
+        <p:nvSpPr>
+          <p:cNvPr id="8" name="S01-label-1">
+            <a:extLst>
+              <a:ext uri="{FF2B5EF4-FFF2-40B4-BE49-F238E27FC236}">
+                <a16:creationId xmlns:a16="http://schemas.microsoft.com/office/drawing/2014/main" id="{45E3E10B-E549-45FF-B799-B830B7E58081}"/>
+              </a:ext>
+            </a:extLst>
+          </p:cNvPr>
+          <p:cNvSpPr>
+            <a:spLocks noGrp="1"/>
+          </p:cNvSpPr>
+          <p:nvPr/>
+        </p:nvSpPr>
+        <p:spPr>
+          <a:xfrm>
+            <a:off x="6210300" y="2762250"/>
+            <a:ext cx="2000250" cy="523875"/>
           </a:xfrm>
           <a:prstGeom prst="rect">
             <a:avLst/>
@@ -1706,7 +1788,7 @@
           <a:lstStyle/>
           <a:p>
             <a:pPr>
-              <a:defRPr sz="1800" b="0">
+              <a:defRPr sz="1725" b="0">
                 <a:solidFill>
                   <a:srgbClr val="586C68"/>
                 </a:solidFill>
@@ -1716,7 +1798,7 @@
               </a:defRPr>
             </a:pPr>
             <a:r>
-              <a:rPr sz="1800" b="0">
+              <a:rPr sz="1725" b="0">
                 <a:solidFill>
                   <a:srgbClr val="586C68"/>
                 </a:solidFill>
@@ -1731,10 +1813,10 @@
       </p:sp>
       <p:sp>
         <p:nvSpPr>
-          <p:cNvPr id="7" name="S01-value-2">
+          <p:cNvPr id="9" name="S01-value-base-1">
             <a:extLst>
               <a:ext uri="{FF2B5EF4-FFF2-40B4-BE49-F238E27FC236}">
-                <a16:creationId xmlns:a16="http://schemas.microsoft.com/office/drawing/2014/main" id="{4DB64A30-8BA9-4D49-918B-5BEADF5DBD5A}"/>
+                <a16:creationId xmlns:a16="http://schemas.microsoft.com/office/drawing/2014/main" id="{74E6EC8D-4550-4034-A07F-4E320B5163B8}"/>
               </a:ext>
             </a:extLst>
           </p:cNvPr>
@@ -1745,8 +1827,8 @@
         </p:nvSpPr>
         <p:spPr>
           <a:xfrm>
-            <a:off x="4419600" y="4619625"/>
-            <a:ext cx="3810000" cy="628650"/>
+            <a:off x="8258175" y="2762250"/>
+            <a:ext cx="1524000" cy="523875"/>
           </a:xfrm>
           <a:prstGeom prst="rect">
             <a:avLst/>
@@ -1763,7 +1845,7 @@
           <a:lstStyle/>
           <a:p>
             <a:pPr>
-              <a:defRPr sz="3225" b="0">
+              <a:defRPr sz="2850" b="0">
                 <a:solidFill>
                   <a:srgbClr val="1E302F"/>
                 </a:solidFill>
@@ -1773,7 +1855,7 @@
               </a:defRPr>
             </a:pPr>
             <a:r>
-              <a:rPr sz="3225" b="0">
+              <a:rPr sz="2850" b="0">
                 <a:solidFill>
                   <a:srgbClr val="1E302F"/>
                 </a:solidFill>
@@ -1781,17 +1863,17 @@
                 <a:ea typeface="Noto Sans KR"/>
                 <a:cs typeface="Noto Sans KR"/>
               </a:rPr>
-              <a:t>0.910 → 0.896</a:t>
+              <a:t>120</a:t>
             </a:r>
           </a:p>
         </p:txBody>
       </p:sp>
       <p:sp>
         <p:nvSpPr>
-          <p:cNvPr id="8" name="S01-label-2">
+          <p:cNvPr id="10" name="S01-value-int8-1">
             <a:extLst>
               <a:ext uri="{FF2B5EF4-FFF2-40B4-BE49-F238E27FC236}">
-                <a16:creationId xmlns:a16="http://schemas.microsoft.com/office/drawing/2014/main" id="{B900C037-6942-44D1-A0F7-B92FF7473D2F}"/>
+                <a16:creationId xmlns:a16="http://schemas.microsoft.com/office/drawing/2014/main" id="{26149F20-24F3-4DAC-A6ED-51C51909EE0D}"/>
               </a:ext>
             </a:extLst>
           </p:cNvPr>
@@ -1802,8 +1884,8 @@
         </p:nvSpPr>
         <p:spPr>
           <a:xfrm>
-            <a:off x="4419600" y="5314950"/>
-            <a:ext cx="3143250" cy="361950"/>
+            <a:off x="10382250" y="2762250"/>
+            <a:ext cx="1428750" cy="523875"/>
           </a:xfrm>
           <a:prstGeom prst="rect">
             <a:avLst/>
@@ -1820,9 +1902,9 @@
           <a:lstStyle/>
           <a:p>
             <a:pPr>
-              <a:defRPr sz="1800" b="0">
-                <a:solidFill>
-                  <a:srgbClr val="586C68"/>
+              <a:defRPr sz="2850" b="0">
+                <a:solidFill>
+                  <a:srgbClr val="1E302F"/>
                 </a:solidFill>
                 <a:latin typeface="Noto Sans KR"/>
                 <a:ea typeface="Noto Sans KR"/>
@@ -1830,7 +1912,93 @@
               </a:defRPr>
             </a:pPr>
             <a:r>
-              <a:rPr sz="1800" b="0">
+              <a:rPr sz="2850" b="0">
+                <a:solidFill>
+                  <a:srgbClr val="1E302F"/>
+                </a:solidFill>
+                <a:latin typeface="Noto Sans KR"/>
+                <a:ea typeface="Noto Sans KR"/>
+                <a:cs typeface="Noto Sans KR"/>
+              </a:rPr>
+              <a:t>54</a:t>
+            </a:r>
+          </a:p>
+        </p:txBody>
+      </p:sp>
+      <p:sp>
+        <p:nvSpPr>
+          <p:cNvPr id="11" name="S01-rule-1">
+            <a:extLst>
+              <a:ext uri="{FF2B5EF4-FFF2-40B4-BE49-F238E27FC236}">
+                <a16:creationId xmlns:a16="http://schemas.microsoft.com/office/drawing/2014/main" id="{80BDCC95-E5FA-4A01-821F-97507A8949DB}"/>
+              </a:ext>
+            </a:extLst>
+          </p:cNvPr>
+          <p:cNvSpPr>
+            <a:spLocks noGrp="1"/>
+          </p:cNvSpPr>
+          <p:nvPr/>
+        </p:nvSpPr>
+        <p:spPr>
+          <a:xfrm>
+            <a:off x="6210300" y="3648075"/>
+            <a:ext cx="5372100" cy="0"/>
+          </a:xfrm>
+          <a:prstGeom prst="line">
+            <a:avLst/>
+          </a:prstGeom>
+          <a:ln w="9525">
+            <a:solidFill>
+              <a:srgbClr val="CFD8D1"/>
+            </a:solidFill>
+          </a:ln>
+        </p:spPr>
+      </p:sp>
+      <p:sp>
+        <p:nvSpPr>
+          <p:cNvPr id="12" name="S01-label-2">
+            <a:extLst>
+              <a:ext uri="{FF2B5EF4-FFF2-40B4-BE49-F238E27FC236}">
+                <a16:creationId xmlns:a16="http://schemas.microsoft.com/office/drawing/2014/main" id="{2B2D0290-4108-48BA-A598-2BEFF4B8EF6F}"/>
+              </a:ext>
+            </a:extLst>
+          </p:cNvPr>
+          <p:cNvSpPr>
+            <a:spLocks noGrp="1"/>
+          </p:cNvSpPr>
+          <p:nvPr/>
+        </p:nvSpPr>
+        <p:spPr>
+          <a:xfrm>
+            <a:off x="6210300" y="3829050"/>
+            <a:ext cx="2000250" cy="523875"/>
+          </a:xfrm>
+          <a:prstGeom prst="rect">
+            <a:avLst/>
+          </a:prstGeom>
+          <a:noFill/>
+          <a:ln w="0">
+            <a:noFill/>
+          </a:ln>
+        </p:spPr>
+        <p:txBody>
+          <a:bodyPr wrap="none" lIns="0" tIns="0" rIns="0" bIns="0" anchor="ctr">
+            <a:noAutofit/>
+          </a:bodyPr>
+          <a:lstStyle/>
+          <a:p>
+            <a:pPr>
+              <a:defRPr sz="1725" b="0">
+                <a:solidFill>
+                  <a:srgbClr val="586C68"/>
+                </a:solidFill>
+                <a:latin typeface="Noto Sans KR"/>
+                <a:ea typeface="Noto Sans KR"/>
+                <a:cs typeface="Noto Sans KR"/>
+              </a:defRPr>
+            </a:pPr>
+            <a:r>
+              <a:rPr sz="1725" b="0">
                 <a:solidFill>
                   <a:srgbClr val="586C68"/>
                 </a:solidFill>
@@ -1845,10 +2013,10 @@
       </p:sp>
       <p:sp>
         <p:nvSpPr>
-          <p:cNvPr id="9" name="S01-value-3">
+          <p:cNvPr id="13" name="S01-value-base-2">
             <a:extLst>
               <a:ext uri="{FF2B5EF4-FFF2-40B4-BE49-F238E27FC236}">
-                <a16:creationId xmlns:a16="http://schemas.microsoft.com/office/drawing/2014/main" id="{A2B3E276-77D2-4999-8780-60E24892F8EC}"/>
+                <a16:creationId xmlns:a16="http://schemas.microsoft.com/office/drawing/2014/main" id="{C764B51C-EC38-48B5-A7A0-EA7CFFAD3AA8}"/>
               </a:ext>
             </a:extLst>
           </p:cNvPr>
@@ -1859,8 +2027,8 @@
         </p:nvSpPr>
         <p:spPr>
           <a:xfrm>
-            <a:off x="8572500" y="4619625"/>
-            <a:ext cx="2952750" cy="628650"/>
+            <a:off x="8258175" y="3829050"/>
+            <a:ext cx="1524000" cy="523875"/>
           </a:xfrm>
           <a:prstGeom prst="rect">
             <a:avLst/>
@@ -1877,7 +2045,7 @@
           <a:lstStyle/>
           <a:p>
             <a:pPr>
-              <a:defRPr sz="3225" b="0">
+              <a:defRPr sz="2850" b="0">
                 <a:solidFill>
                   <a:srgbClr val="1E302F"/>
                 </a:solidFill>
@@ -1887,7 +2055,7 @@
               </a:defRPr>
             </a:pPr>
             <a:r>
-              <a:rPr sz="3225" b="0">
+              <a:rPr sz="2850" b="0">
                 <a:solidFill>
                   <a:srgbClr val="1E302F"/>
                 </a:solidFill>
@@ -1895,17 +2063,17 @@
                 <a:ea typeface="Noto Sans KR"/>
                 <a:cs typeface="Noto Sans KR"/>
               </a:rPr>
-              <a:t>48 → 12</a:t>
+              <a:t>0.910</a:t>
             </a:r>
           </a:p>
         </p:txBody>
       </p:sp>
       <p:sp>
         <p:nvSpPr>
-          <p:cNvPr id="10" name="S01-label-3">
+          <p:cNvPr id="14" name="S01-value-int8-2">
             <a:extLst>
               <a:ext uri="{FF2B5EF4-FFF2-40B4-BE49-F238E27FC236}">
-                <a16:creationId xmlns:a16="http://schemas.microsoft.com/office/drawing/2014/main" id="{4E6EA8CD-99F8-4802-8730-F57527EF34AD}"/>
+                <a16:creationId xmlns:a16="http://schemas.microsoft.com/office/drawing/2014/main" id="{6E96A88D-11F9-432C-85F1-F0A99C4706D3}"/>
               </a:ext>
             </a:extLst>
           </p:cNvPr>
@@ -1916,8 +2084,8 @@
         </p:nvSpPr>
         <p:spPr>
           <a:xfrm>
-            <a:off x="8572500" y="5314950"/>
-            <a:ext cx="3143250" cy="361950"/>
+            <a:off x="10382250" y="3829050"/>
+            <a:ext cx="1428750" cy="523875"/>
           </a:xfrm>
           <a:prstGeom prst="rect">
             <a:avLst/>
@@ -1934,9 +2102,9 @@
           <a:lstStyle/>
           <a:p>
             <a:pPr>
-              <a:defRPr sz="1800" b="0">
-                <a:solidFill>
-                  <a:srgbClr val="586C68"/>
+              <a:defRPr sz="2850" b="0">
+                <a:solidFill>
+                  <a:srgbClr val="1E302F"/>
                 </a:solidFill>
                 <a:latin typeface="Noto Sans KR"/>
                 <a:ea typeface="Noto Sans KR"/>
@@ -1944,7 +2112,93 @@
               </a:defRPr>
             </a:pPr>
             <a:r>
-              <a:rPr sz="1800" b="0">
+              <a:rPr sz="2850" b="0">
+                <a:solidFill>
+                  <a:srgbClr val="1E302F"/>
+                </a:solidFill>
+                <a:latin typeface="Noto Sans KR"/>
+                <a:ea typeface="Noto Sans KR"/>
+                <a:cs typeface="Noto Sans KR"/>
+              </a:rPr>
+              <a:t>0.896</a:t>
+            </a:r>
+          </a:p>
+        </p:txBody>
+      </p:sp>
+      <p:sp>
+        <p:nvSpPr>
+          <p:cNvPr id="15" name="S01-rule-2">
+            <a:extLst>
+              <a:ext uri="{FF2B5EF4-FFF2-40B4-BE49-F238E27FC236}">
+                <a16:creationId xmlns:a16="http://schemas.microsoft.com/office/drawing/2014/main" id="{B53B1632-7D20-4231-BDE6-17CEF74C1CC4}"/>
+              </a:ext>
+            </a:extLst>
+          </p:cNvPr>
+          <p:cNvSpPr>
+            <a:spLocks noGrp="1"/>
+          </p:cNvSpPr>
+          <p:nvPr/>
+        </p:nvSpPr>
+        <p:spPr>
+          <a:xfrm>
+            <a:off x="6210300" y="4714875"/>
+            <a:ext cx="5372100" cy="0"/>
+          </a:xfrm>
+          <a:prstGeom prst="line">
+            <a:avLst/>
+          </a:prstGeom>
+          <a:ln w="9525">
+            <a:solidFill>
+              <a:srgbClr val="CFD8D1"/>
+            </a:solidFill>
+          </a:ln>
+        </p:spPr>
+      </p:sp>
+      <p:sp>
+        <p:nvSpPr>
+          <p:cNvPr id="16" name="S01-label-3">
+            <a:extLst>
+              <a:ext uri="{FF2B5EF4-FFF2-40B4-BE49-F238E27FC236}">
+                <a16:creationId xmlns:a16="http://schemas.microsoft.com/office/drawing/2014/main" id="{E67A4E41-02A8-4624-BDA6-5E44FDE3D74F}"/>
+              </a:ext>
+            </a:extLst>
+          </p:cNvPr>
+          <p:cNvSpPr>
+            <a:spLocks noGrp="1"/>
+          </p:cNvSpPr>
+          <p:nvPr/>
+        </p:nvSpPr>
+        <p:spPr>
+          <a:xfrm>
+            <a:off x="6210300" y="4895850"/>
+            <a:ext cx="2000250" cy="523875"/>
+          </a:xfrm>
+          <a:prstGeom prst="rect">
+            <a:avLst/>
+          </a:prstGeom>
+          <a:noFill/>
+          <a:ln w="0">
+            <a:noFill/>
+          </a:ln>
+        </p:spPr>
+        <p:txBody>
+          <a:bodyPr wrap="none" lIns="0" tIns="0" rIns="0" bIns="0" anchor="ctr">
+            <a:noAutofit/>
+          </a:bodyPr>
+          <a:lstStyle/>
+          <a:p>
+            <a:pPr>
+              <a:defRPr sz="1725" b="0">
+                <a:solidFill>
+                  <a:srgbClr val="586C68"/>
+                </a:solidFill>
+                <a:latin typeface="Noto Sans KR"/>
+                <a:ea typeface="Noto Sans KR"/>
+                <a:cs typeface="Noto Sans KR"/>
+              </a:defRPr>
+            </a:pPr>
+            <a:r>
+              <a:rPr sz="1725" b="0">
                 <a:solidFill>
                   <a:srgbClr val="586C68"/>
                 </a:solidFill>
@@ -1959,10 +2213,10 @@
       </p:sp>
       <p:sp>
         <p:nvSpPr>
-          <p:cNvPr id="11" name="S01-disclosure">
+          <p:cNvPr id="17" name="S01-value-base-3">
             <a:extLst>
               <a:ext uri="{FF2B5EF4-FFF2-40B4-BE49-F238E27FC236}">
-                <a16:creationId xmlns:a16="http://schemas.microsoft.com/office/drawing/2014/main" id="{5BA00A58-6419-4154-8F11-0C1C8EDA1169}"/>
+                <a16:creationId xmlns:a16="http://schemas.microsoft.com/office/drawing/2014/main" id="{C745DB92-3669-462A-ACDE-9AD59CC5A81B}"/>
               </a:ext>
             </a:extLst>
           </p:cNvPr>
@@ -1973,8 +2227,8 @@
         </p:nvSpPr>
         <p:spPr>
           <a:xfrm>
-            <a:off x="685800" y="6372225"/>
-            <a:ext cx="9525000" cy="219075"/>
+            <a:off x="8258175" y="4895850"/>
+            <a:ext cx="1524000" cy="523875"/>
           </a:xfrm>
           <a:prstGeom prst="rect">
             <a:avLst/>
@@ -1991,9 +2245,123 @@
           <a:lstStyle/>
           <a:p>
             <a:pPr>
+              <a:defRPr sz="2850" b="0">
+                <a:solidFill>
+                  <a:srgbClr val="1E302F"/>
+                </a:solidFill>
+                <a:latin typeface="Noto Sans KR"/>
+                <a:ea typeface="Noto Sans KR"/>
+                <a:cs typeface="Noto Sans KR"/>
+              </a:defRPr>
+            </a:pPr>
+            <a:r>
+              <a:rPr sz="2850" b="0">
+                <a:solidFill>
+                  <a:srgbClr val="1E302F"/>
+                </a:solidFill>
+                <a:latin typeface="Noto Sans KR"/>
+                <a:ea typeface="Noto Sans KR"/>
+                <a:cs typeface="Noto Sans KR"/>
+              </a:rPr>
+              <a:t>48</a:t>
+            </a:r>
+          </a:p>
+        </p:txBody>
+      </p:sp>
+      <p:sp>
+        <p:nvSpPr>
+          <p:cNvPr id="18" name="S01-value-int8-3">
+            <a:extLst>
+              <a:ext uri="{FF2B5EF4-FFF2-40B4-BE49-F238E27FC236}">
+                <a16:creationId xmlns:a16="http://schemas.microsoft.com/office/drawing/2014/main" id="{9118243B-031F-4971-9948-0DA8F577A0F3}"/>
+              </a:ext>
+            </a:extLst>
+          </p:cNvPr>
+          <p:cNvSpPr>
+            <a:spLocks noGrp="1"/>
+          </p:cNvSpPr>
+          <p:nvPr/>
+        </p:nvSpPr>
+        <p:spPr>
+          <a:xfrm>
+            <a:off x="10382250" y="4895850"/>
+            <a:ext cx="1428750" cy="523875"/>
+          </a:xfrm>
+          <a:prstGeom prst="rect">
+            <a:avLst/>
+          </a:prstGeom>
+          <a:noFill/>
+          <a:ln w="0">
+            <a:noFill/>
+          </a:ln>
+        </p:spPr>
+        <p:txBody>
+          <a:bodyPr wrap="none" lIns="0" tIns="0" rIns="0" bIns="0" anchor="ctr">
+            <a:noAutofit/>
+          </a:bodyPr>
+          <a:lstStyle/>
+          <a:p>
+            <a:pPr>
+              <a:defRPr sz="2850" b="0">
+                <a:solidFill>
+                  <a:srgbClr val="1E302F"/>
+                </a:solidFill>
+                <a:latin typeface="Noto Sans KR"/>
+                <a:ea typeface="Noto Sans KR"/>
+                <a:cs typeface="Noto Sans KR"/>
+              </a:defRPr>
+            </a:pPr>
+            <a:r>
+              <a:rPr sz="2850" b="0">
+                <a:solidFill>
+                  <a:srgbClr val="1E302F"/>
+                </a:solidFill>
+                <a:latin typeface="Noto Sans KR"/>
+                <a:ea typeface="Noto Sans KR"/>
+                <a:cs typeface="Noto Sans KR"/>
+              </a:rPr>
+              <a:t>12</a:t>
+            </a:r>
+          </a:p>
+        </p:txBody>
+      </p:sp>
+      <p:sp>
+        <p:nvSpPr>
+          <p:cNvPr id="19" name="S01-disclosure">
+            <a:extLst>
+              <a:ext uri="{FF2B5EF4-FFF2-40B4-BE49-F238E27FC236}">
+                <a16:creationId xmlns:a16="http://schemas.microsoft.com/office/drawing/2014/main" id="{F1963806-6430-4657-AA19-3DB7DEA9D695}"/>
+              </a:ext>
+            </a:extLst>
+          </p:cNvPr>
+          <p:cNvSpPr>
+            <a:spLocks noGrp="1"/>
+          </p:cNvSpPr>
+          <p:nvPr/>
+        </p:nvSpPr>
+        <p:spPr>
+          <a:xfrm>
+            <a:off x="609600" y="6372225"/>
+            <a:ext cx="4572000" cy="219075"/>
+          </a:xfrm>
+          <a:prstGeom prst="rect">
+            <a:avLst/>
+          </a:prstGeom>
+          <a:noFill/>
+          <a:ln w="0">
+            <a:noFill/>
+          </a:ln>
+        </p:spPr>
+        <p:txBody>
+          <a:bodyPr wrap="none" lIns="0" tIns="0" rIns="0" bIns="0" anchor="ctr">
+            <a:noAutofit/>
+          </a:bodyPr>
+          <a:lstStyle/>
+          <a:p>
+            <a:pPr>
               <a:defRPr sz="1275" b="0">
                 <a:solidFill>
-                  <a:srgbClr val="586C68"/>
+                  <a:srgbClr val="B9DDD0"/>
                 </a:solidFill>
                 <a:latin typeface="Noto Sans KR"/>
                 <a:ea typeface="Noto Sans KR"/>
@@ -2003,70 +2371,13 @@
             <a:r>
               <a:rPr sz="1275" b="0">
                 <a:solidFill>
-                  <a:srgbClr val="586C68"/>
+                  <a:srgbClr val="B9DDD0"/>
                 </a:solidFill>
                 <a:latin typeface="Noto Sans KR"/>
                 <a:ea typeface="Noto Sans KR"/>
                 <a:cs typeface="Noto Sans KR"/>
               </a:rPr>
-              <a:t>가상 데이터 · 실제 실험 결과가 아닙니다</a:t>
-            </a:r>
-          </a:p>
-        </p:txBody>
-      </p:sp>
-      <p:sp>
-        <p:nvSpPr>
-          <p:cNvPr id="12" name="S01-number">
-            <a:extLst>
-              <a:ext uri="{FF2B5EF4-FFF2-40B4-BE49-F238E27FC236}">
-                <a16:creationId xmlns:a16="http://schemas.microsoft.com/office/drawing/2014/main" id="{E415156A-AD7E-4EFA-A4EA-0B630654AD8D}"/>
-              </a:ext>
-            </a:extLst>
-          </p:cNvPr>
-          <p:cNvSpPr>
-            <a:spLocks noGrp="1"/>
-          </p:cNvSpPr>
-          <p:nvPr/>
-        </p:nvSpPr>
-        <p:spPr>
-          <a:xfrm>
-            <a:off x="11144250" y="6372225"/>
-            <a:ext cx="361950" cy="219075"/>
-          </a:xfrm>
-          <a:prstGeom prst="rect">
-            <a:avLst/>
-          </a:prstGeom>
-          <a:noFill/>
-          <a:ln w="0">
-            <a:noFill/>
-          </a:ln>
-        </p:spPr>
-        <p:txBody>
-          <a:bodyPr wrap="none" lIns="0" tIns="0" rIns="0" bIns="0" anchor="ctr">
-            <a:noAutofit/>
-          </a:bodyPr>
-          <a:lstStyle/>
-          <a:p>
-            <a:pPr>
-              <a:defRPr sz="1275" b="0">
-                <a:solidFill>
-                  <a:srgbClr val="586C68"/>
-                </a:solidFill>
-                <a:latin typeface="Noto Sans KR"/>
-                <a:ea typeface="Noto Sans KR"/>
-                <a:cs typeface="Noto Sans KR"/>
-              </a:defRPr>
-            </a:pPr>
-            <a:r>
-              <a:rPr sz="1275" b="0">
-                <a:solidFill>
-                  <a:srgbClr val="586C68"/>
-                </a:solidFill>
-                <a:latin typeface="Noto Sans KR"/>
-                <a:ea typeface="Noto Sans KR"/>
-                <a:cs typeface="Noto Sans KR"/>
-              </a:rPr>
-              <a:t>01</a:t>
+              <a:t>가상 데이터</a:t>
             </a:r>
           </a:p>
         </p:txBody>
@@ -2074,7 +2385,7 @@
     </p:spTree>
     <p:extLst>
       <p:ext uri="{BB962C8B-B14F-4D97-AF65-F5344CB8AC3E}">
-        <p14:creationId xmlns:p14="http://schemas.microsoft.com/office/powerpoint/2010/main" val="626593417"/>
+        <p14:creationId xmlns:p14="http://schemas.microsoft.com/office/powerpoint/2010/main" val="1297296397"/>
       </p:ext>
     </p:extLst>
   </p:cSld>
@@ -2111,10 +2422,10 @@
       </p:grpSpPr>
       <p:sp>
         <p:nvSpPr>
-          <p:cNvPr id="21" name="S02-title">
+          <p:cNvPr id="22" name="S02-title">
             <a:extLst>
               <a:ext uri="{FF2B5EF4-FFF2-40B4-BE49-F238E27FC236}">
-                <a16:creationId xmlns:a16="http://schemas.microsoft.com/office/drawing/2014/main" id="{6BD0F392-7E29-44F0-8FE9-1D5672BE93AF}"/>
+                <a16:creationId xmlns:a16="http://schemas.microsoft.com/office/drawing/2014/main" id="{786A9605-410C-4A7E-B424-A686CEC00249}"/>
               </a:ext>
             </a:extLst>
           </p:cNvPr>
@@ -2171,7 +2482,7 @@
           <p:cNvPr id="2" name="S02-disclosure">
             <a:extLst>
               <a:ext uri="{FF2B5EF4-FFF2-40B4-BE49-F238E27FC236}">
-                <a16:creationId xmlns:a16="http://schemas.microsoft.com/office/drawing/2014/main" id="{6EFE154F-3F7E-45BF-A3E5-BE8FF3038D35}"/>
+                <a16:creationId xmlns:a16="http://schemas.microsoft.com/office/drawing/2014/main" id="{96EB7DA5-7903-4B33-BB88-8D40015B52E7}"/>
               </a:ext>
             </a:extLst>
           </p:cNvPr>
@@ -2218,7 +2529,7 @@
                 <a:ea typeface="Noto Sans KR"/>
                 <a:cs typeface="Noto Sans KR"/>
               </a:rPr>
-              <a:t>가상 데이터 · 실제 실험 결과가 아닙니다</a:t>
+              <a:t>가상 데이터</a:t>
             </a:r>
           </a:p>
         </p:txBody>
@@ -2228,7 +2539,7 @@
           <p:cNvPr id="3" name="S02-number">
             <a:extLst>
               <a:ext uri="{FF2B5EF4-FFF2-40B4-BE49-F238E27FC236}">
-                <a16:creationId xmlns:a16="http://schemas.microsoft.com/office/drawing/2014/main" id="{289D943D-7D98-4F28-BC46-07F21B389451}"/>
+                <a16:creationId xmlns:a16="http://schemas.microsoft.com/office/drawing/2014/main" id="{9521993F-D3BF-4C92-A6E3-28D3DADFD1B1}"/>
               </a:ext>
             </a:extLst>
           </p:cNvPr>
@@ -2282,10 +2593,10 @@
       </p:sp>
       <p:sp>
         <p:nvSpPr>
-          <p:cNvPr id="4" name="S02-marker-1">
+          <p:cNvPr id="4" name="S02-method-field">
             <a:extLst>
               <a:ext uri="{FF2B5EF4-FFF2-40B4-BE49-F238E27FC236}">
-                <a16:creationId xmlns:a16="http://schemas.microsoft.com/office/drawing/2014/main" id="{96F4F6E2-1A66-47D3-ACEF-D193B4436C57}"/>
+                <a16:creationId xmlns:a16="http://schemas.microsoft.com/office/drawing/2014/main" id="{C24E8D75-3B46-4588-B2F2-E45976467EEB}"/>
               </a:ext>
             </a:extLst>
           </p:cNvPr>
@@ -2296,10 +2607,10 @@
         </p:nvSpPr>
         <p:spPr>
           <a:xfrm>
-            <a:off x="685800" y="2333625"/>
-            <a:ext cx="533400" cy="533400"/>
+            <a:off x="457200" y="1866900"/>
+            <a:ext cx="11277600" cy="3467100"/>
           </a:xfrm>
-          <a:prstGeom prst="ellipse">
+          <a:prstGeom prst="rect">
             <a:avLst/>
           </a:prstGeom>
           <a:solidFill>
@@ -2309,40 +2620,13 @@
             <a:noFill/>
           </a:ln>
         </p:spPr>
-        <p:txBody>
-          <a:bodyPr lIns="0" tIns="0" rIns="0" bIns="0" anchor="ctr"/>
-          <a:lstStyle/>
-          <a:p>
-            <a:pPr algn="ctr">
-              <a:defRPr sz="1650">
-                <a:solidFill>
-                  <a:srgbClr val="287D78"/>
-                </a:solidFill>
-                <a:latin typeface="Noto Sans KR"/>
-                <a:ea typeface="Noto Sans KR"/>
-                <a:cs typeface="Noto Sans KR"/>
-              </a:defRPr>
-            </a:pPr>
-            <a:r>
-              <a:rPr sz="1650">
-                <a:solidFill>
-                  <a:srgbClr val="287D78"/>
-                </a:solidFill>
-                <a:latin typeface="Noto Sans KR"/>
-                <a:ea typeface="Noto Sans KR"/>
-                <a:cs typeface="Noto Sans KR"/>
-              </a:rPr>
-              <a:t>01</a:t>
-            </a:r>
-          </a:p>
-        </p:txBody>
-      </p:sp>
-      <p:sp>
-        <p:nvSpPr>
-          <p:cNvPr id="5" name="S02-marker-2">
+      </p:sp>
+      <p:sp>
+        <p:nvSpPr>
+          <p:cNvPr id="5" name="S02-marker-1">
             <a:extLst>
               <a:ext uri="{FF2B5EF4-FFF2-40B4-BE49-F238E27FC236}">
-                <a16:creationId xmlns:a16="http://schemas.microsoft.com/office/drawing/2014/main" id="{F6496AC7-EA7C-4FC3-8A3F-2D911782723D}"/>
+                <a16:creationId xmlns:a16="http://schemas.microsoft.com/office/drawing/2014/main" id="{CB7B1038-9CA5-4DD4-8785-9A82BC813037}"/>
               </a:ext>
             </a:extLst>
           </p:cNvPr>
@@ -2353,65 +2637,8 @@
         </p:nvSpPr>
         <p:spPr>
           <a:xfrm>
-            <a:off x="4648200" y="2333625"/>
-            <a:ext cx="533400" cy="533400"/>
-          </a:xfrm>
-          <a:prstGeom prst="ellipse">
-            <a:avLst/>
-          </a:prstGeom>
-          <a:solidFill>
-            <a:srgbClr val="E8EDE5"/>
-          </a:solidFill>
-          <a:ln w="0">
-            <a:noFill/>
-          </a:ln>
-        </p:spPr>
-        <p:txBody>
-          <a:bodyPr lIns="0" tIns="0" rIns="0" bIns="0" anchor="ctr"/>
-          <a:lstStyle/>
-          <a:p>
-            <a:pPr algn="ctr">
-              <a:defRPr sz="1650">
-                <a:solidFill>
-                  <a:srgbClr val="287D78"/>
-                </a:solidFill>
-                <a:latin typeface="Noto Sans KR"/>
-                <a:ea typeface="Noto Sans KR"/>
-                <a:cs typeface="Noto Sans KR"/>
-              </a:defRPr>
-            </a:pPr>
-            <a:r>
-              <a:rPr sz="1650">
-                <a:solidFill>
-                  <a:srgbClr val="287D78"/>
-                </a:solidFill>
-                <a:latin typeface="Noto Sans KR"/>
-                <a:ea typeface="Noto Sans KR"/>
-                <a:cs typeface="Noto Sans KR"/>
-              </a:rPr>
-              <a:t>02</a:t>
-            </a:r>
-          </a:p>
-        </p:txBody>
-      </p:sp>
-      <p:sp>
-        <p:nvSpPr>
-          <p:cNvPr id="6" name="S02-marker-3">
-            <a:extLst>
-              <a:ext uri="{FF2B5EF4-FFF2-40B4-BE49-F238E27FC236}">
-                <a16:creationId xmlns:a16="http://schemas.microsoft.com/office/drawing/2014/main" id="{0A9B6237-08C8-422B-8350-9D20D6A4E836}"/>
-              </a:ext>
-            </a:extLst>
-          </p:cNvPr>
-          <p:cNvSpPr>
-            <a:spLocks noGrp="1"/>
-          </p:cNvSpPr>
-          <p:nvPr/>
-        </p:nvSpPr>
-        <p:spPr>
-          <a:xfrm>
-            <a:off x="8610600" y="2333625"/>
-            <a:ext cx="533400" cy="533400"/>
+            <a:off x="685800" y="2524125"/>
+            <a:ext cx="609600" cy="609600"/>
           </a:xfrm>
           <a:prstGeom prst="ellipse">
             <a:avLst/>
@@ -2446,6 +2673,120 @@
                 <a:ea typeface="Noto Sans KR"/>
                 <a:cs typeface="Noto Sans KR"/>
               </a:rPr>
+              <a:t>01</a:t>
+            </a:r>
+          </a:p>
+        </p:txBody>
+      </p:sp>
+      <p:sp>
+        <p:nvSpPr>
+          <p:cNvPr id="6" name="S02-marker-2">
+            <a:extLst>
+              <a:ext uri="{FF2B5EF4-FFF2-40B4-BE49-F238E27FC236}">
+                <a16:creationId xmlns:a16="http://schemas.microsoft.com/office/drawing/2014/main" id="{C6A6CBFF-31A5-4A08-87FF-72DCF042AFE1}"/>
+              </a:ext>
+            </a:extLst>
+          </p:cNvPr>
+          <p:cNvSpPr>
+            <a:spLocks noGrp="1"/>
+          </p:cNvSpPr>
+          <p:nvPr/>
+        </p:nvSpPr>
+        <p:spPr>
+          <a:xfrm>
+            <a:off x="4648200" y="2524125"/>
+            <a:ext cx="609600" cy="609600"/>
+          </a:xfrm>
+          <a:prstGeom prst="ellipse">
+            <a:avLst/>
+          </a:prstGeom>
+          <a:solidFill>
+            <a:srgbClr val="287D78"/>
+          </a:solidFill>
+          <a:ln w="0">
+            <a:noFill/>
+          </a:ln>
+        </p:spPr>
+        <p:txBody>
+          <a:bodyPr lIns="0" tIns="0" rIns="0" bIns="0" anchor="ctr"/>
+          <a:lstStyle/>
+          <a:p>
+            <a:pPr algn="ctr">
+              <a:defRPr sz="1650">
+                <a:solidFill>
+                  <a:srgbClr val="FFFFFF"/>
+                </a:solidFill>
+                <a:latin typeface="Noto Sans KR"/>
+                <a:ea typeface="Noto Sans KR"/>
+                <a:cs typeface="Noto Sans KR"/>
+              </a:defRPr>
+            </a:pPr>
+            <a:r>
+              <a:rPr sz="1650">
+                <a:solidFill>
+                  <a:srgbClr val="FFFFFF"/>
+                </a:solidFill>
+                <a:latin typeface="Noto Sans KR"/>
+                <a:ea typeface="Noto Sans KR"/>
+                <a:cs typeface="Noto Sans KR"/>
+              </a:rPr>
+              <a:t>02</a:t>
+            </a:r>
+          </a:p>
+        </p:txBody>
+      </p:sp>
+      <p:sp>
+        <p:nvSpPr>
+          <p:cNvPr id="7" name="S02-marker-3">
+            <a:extLst>
+              <a:ext uri="{FF2B5EF4-FFF2-40B4-BE49-F238E27FC236}">
+                <a16:creationId xmlns:a16="http://schemas.microsoft.com/office/drawing/2014/main" id="{B79B1A7A-4BFA-45BE-A3A7-D5E23D3986E1}"/>
+              </a:ext>
+            </a:extLst>
+          </p:cNvPr>
+          <p:cNvSpPr>
+            <a:spLocks noGrp="1"/>
+          </p:cNvSpPr>
+          <p:nvPr/>
+        </p:nvSpPr>
+        <p:spPr>
+          <a:xfrm>
+            <a:off x="8610600" y="2524125"/>
+            <a:ext cx="609600" cy="609600"/>
+          </a:xfrm>
+          <a:prstGeom prst="ellipse">
+            <a:avLst/>
+          </a:prstGeom>
+          <a:solidFill>
+            <a:srgbClr val="287D78"/>
+          </a:solidFill>
+          <a:ln w="0">
+            <a:noFill/>
+          </a:ln>
+        </p:spPr>
+        <p:txBody>
+          <a:bodyPr lIns="0" tIns="0" rIns="0" bIns="0" anchor="ctr"/>
+          <a:lstStyle/>
+          <a:p>
+            <a:pPr algn="ctr">
+              <a:defRPr sz="1650">
+                <a:solidFill>
+                  <a:srgbClr val="FFFFFF"/>
+                </a:solidFill>
+                <a:latin typeface="Noto Sans KR"/>
+                <a:ea typeface="Noto Sans KR"/>
+                <a:cs typeface="Noto Sans KR"/>
+              </a:defRPr>
+            </a:pPr>
+            <a:r>
+              <a:rPr sz="1650">
+                <a:solidFill>
+                  <a:srgbClr val="FFFFFF"/>
+                </a:solidFill>
+                <a:latin typeface="Noto Sans KR"/>
+                <a:ea typeface="Noto Sans KR"/>
+                <a:cs typeface="Noto Sans KR"/>
+              </a:rPr>
               <a:t>03</a:t>
             </a:r>
           </a:p>
@@ -2453,17 +2794,17 @@
       </p:sp>
       <p:cxnSp>
         <p:nvCxnSpPr>
-          <p:cNvPr id="27" name="S02-link-2"/>
+          <p:cNvPr id="29" name="S02-link-2"/>
           <p:cNvCxnSpPr>
-            <a:stCxn id="4" idx="6"/>
-            <a:endCxn id="5" idx="2"/>
+            <a:stCxn id="5" idx="6"/>
+            <a:endCxn id="6" idx="2"/>
           </p:cNvCxnSpPr>
           <p:nvPr/>
         </p:nvCxnSpPr>
         <p:spPr>
           <a:xfrm>
-            <a:off x="1219200" y="2600325"/>
-            <a:ext cx="3429000" cy="0"/>
+            <a:off x="1295400" y="2828925"/>
+            <a:ext cx="3352800" cy="0"/>
           </a:xfrm>
           <a:prstGeom prst="straightConnector1">
             <a:avLst/>
@@ -2478,17 +2819,17 @@
       </p:cxnSp>
       <p:cxnSp>
         <p:nvCxnSpPr>
-          <p:cNvPr id="28" name="S02-link-3"/>
+          <p:cNvPr id="30" name="S02-link-3"/>
           <p:cNvCxnSpPr>
-            <a:stCxn id="5" idx="6"/>
-            <a:endCxn id="6" idx="2"/>
+            <a:stCxn id="6" idx="6"/>
+            <a:endCxn id="7" idx="2"/>
           </p:cNvCxnSpPr>
           <p:nvPr/>
         </p:nvCxnSpPr>
         <p:spPr>
           <a:xfrm>
-            <a:off x="5181600" y="2600325"/>
-            <a:ext cx="3429000" cy="0"/>
+            <a:off x="5257800" y="2828925"/>
+            <a:ext cx="3352800" cy="0"/>
           </a:xfrm>
           <a:prstGeom prst="straightConnector1">
             <a:avLst/>
@@ -2503,10 +2844,10 @@
       </p:cxnSp>
       <p:sp>
         <p:nvSpPr>
-          <p:cNvPr id="9" name="S02-flow-2">
+          <p:cNvPr id="10" name="S02-flow-2">
             <a:extLst>
               <a:ext uri="{FF2B5EF4-FFF2-40B4-BE49-F238E27FC236}">
-                <a16:creationId xmlns:a16="http://schemas.microsoft.com/office/drawing/2014/main" id="{5CD9262E-1877-45DF-8C35-1383DB28BD36}"/>
+                <a16:creationId xmlns:a16="http://schemas.microsoft.com/office/drawing/2014/main" id="{FE14EF2D-5A51-4CBD-B333-CDBC0A874E7A}"/>
               </a:ext>
             </a:extLst>
           </p:cNvPr>
@@ -2517,8 +2858,8 @@
         </p:nvSpPr>
         <p:spPr>
           <a:xfrm>
-            <a:off x="1466850" y="2076450"/>
-            <a:ext cx="2971800" cy="352425"/>
+            <a:off x="1524000" y="2057400"/>
+            <a:ext cx="3048000" cy="381000"/>
           </a:xfrm>
           <a:prstGeom prst="rect">
             <a:avLst/>
@@ -2560,10 +2901,10 @@
       </p:sp>
       <p:sp>
         <p:nvSpPr>
-          <p:cNvPr id="10" name="S02-flow-3">
+          <p:cNvPr id="11" name="S02-flow-3">
             <a:extLst>
               <a:ext uri="{FF2B5EF4-FFF2-40B4-BE49-F238E27FC236}">
-                <a16:creationId xmlns:a16="http://schemas.microsoft.com/office/drawing/2014/main" id="{216D3EC5-F0D5-4E19-9E29-F8030FDCCC2B}"/>
+                <a16:creationId xmlns:a16="http://schemas.microsoft.com/office/drawing/2014/main" id="{3532FF58-1A19-435E-B937-B797FA1501C4}"/>
               </a:ext>
             </a:extLst>
           </p:cNvPr>
@@ -2574,8 +2915,8 @@
         </p:nvSpPr>
         <p:spPr>
           <a:xfrm>
-            <a:off x="5429250" y="2076450"/>
-            <a:ext cx="2971800" cy="352425"/>
+            <a:off x="5486400" y="2057400"/>
+            <a:ext cx="3048000" cy="381000"/>
           </a:xfrm>
           <a:prstGeom prst="rect">
             <a:avLst/>
@@ -2617,10 +2958,10 @@
       </p:sp>
       <p:sp>
         <p:nvSpPr>
-          <p:cNvPr id="11" name="S02-stage-1">
+          <p:cNvPr id="12" name="S02-stage-1">
             <a:extLst>
               <a:ext uri="{FF2B5EF4-FFF2-40B4-BE49-F238E27FC236}">
-                <a16:creationId xmlns:a16="http://schemas.microsoft.com/office/drawing/2014/main" id="{E9DFB455-BDD4-4253-894D-655A4272A29D}"/>
+                <a16:creationId xmlns:a16="http://schemas.microsoft.com/office/drawing/2014/main" id="{86CDB8D6-6FBC-4BC8-816A-7922FB0FE782}"/>
               </a:ext>
             </a:extLst>
           </p:cNvPr>
@@ -2631,7 +2972,7 @@
         </p:nvSpPr>
         <p:spPr>
           <a:xfrm>
-            <a:off x="685800" y="3152775"/>
+            <a:off x="685800" y="3343275"/>
             <a:ext cx="3181350" cy="457200"/>
           </a:xfrm>
           <a:prstGeom prst="rect">
@@ -2674,10 +3015,10 @@
       </p:sp>
       <p:sp>
         <p:nvSpPr>
-          <p:cNvPr id="12" name="S02-name-1">
+          <p:cNvPr id="13" name="S02-name-1">
             <a:extLst>
               <a:ext uri="{FF2B5EF4-FFF2-40B4-BE49-F238E27FC236}">
-                <a16:creationId xmlns:a16="http://schemas.microsoft.com/office/drawing/2014/main" id="{9A89A7D0-CB6D-447A-A7BD-E95593B1F691}"/>
+                <a16:creationId xmlns:a16="http://schemas.microsoft.com/office/drawing/2014/main" id="{640D8BA7-89D2-4A30-9DC4-C5E9E32B62AB}"/>
               </a:ext>
             </a:extLst>
           </p:cNvPr>
@@ -2688,7 +3029,7 @@
         </p:nvSpPr>
         <p:spPr>
           <a:xfrm>
-            <a:off x="685800" y="3724275"/>
+            <a:off x="685800" y="3876675"/>
             <a:ext cx="3095625" cy="304800"/>
           </a:xfrm>
           <a:prstGeom prst="rect">
@@ -2708,7 +3049,7 @@
             <a:pPr>
               <a:defRPr sz="1575" b="0">
                 <a:solidFill>
-                  <a:srgbClr val="287D78"/>
+                  <a:srgbClr val="246E69"/>
                 </a:solidFill>
                 <a:latin typeface="Noto Sans KR"/>
                 <a:ea typeface="Noto Sans KR"/>
@@ -2718,7 +3059,7 @@
             <a:r>
               <a:rPr sz="1575" b="0">
                 <a:solidFill>
-                  <a:srgbClr val="287D78"/>
+                  <a:srgbClr val="246E69"/>
                 </a:solidFill>
                 <a:latin typeface="Noto Sans KR"/>
                 <a:ea typeface="Noto Sans KR"/>
@@ -2731,10 +3072,10 @@
       </p:sp>
       <p:sp>
         <p:nvSpPr>
-          <p:cNvPr id="13" name="S02-detail-1">
+          <p:cNvPr id="14" name="S02-detail-1">
             <a:extLst>
               <a:ext uri="{FF2B5EF4-FFF2-40B4-BE49-F238E27FC236}">
-                <a16:creationId xmlns:a16="http://schemas.microsoft.com/office/drawing/2014/main" id="{6FA47F22-2A7B-4B45-AAD1-C50EEB9ADC3C}"/>
+                <a16:creationId xmlns:a16="http://schemas.microsoft.com/office/drawing/2014/main" id="{FA129D6F-2804-4137-AE49-4FA026B61160}"/>
               </a:ext>
             </a:extLst>
           </p:cNvPr>
@@ -2745,8 +3086,8 @@
         </p:nvSpPr>
         <p:spPr>
           <a:xfrm>
-            <a:off x="685800" y="4295775"/>
-            <a:ext cx="3181350" cy="771525"/>
+            <a:off x="685800" y="4438650"/>
+            <a:ext cx="3181350" cy="704850"/>
           </a:xfrm>
           <a:prstGeom prst="rect">
             <a:avLst/>
@@ -2811,10 +3152,10 @@
       </p:sp>
       <p:sp>
         <p:nvSpPr>
-          <p:cNvPr id="14" name="S02-stage-2">
+          <p:cNvPr id="15" name="S02-stage-2">
             <a:extLst>
               <a:ext uri="{FF2B5EF4-FFF2-40B4-BE49-F238E27FC236}">
-                <a16:creationId xmlns:a16="http://schemas.microsoft.com/office/drawing/2014/main" id="{7B08D215-FA56-4B33-9119-7F2EEA786251}"/>
+                <a16:creationId xmlns:a16="http://schemas.microsoft.com/office/drawing/2014/main" id="{1B11E811-0150-4EB2-9BAB-C60189477309}"/>
               </a:ext>
             </a:extLst>
           </p:cNvPr>
@@ -2825,7 +3166,7 @@
         </p:nvSpPr>
         <p:spPr>
           <a:xfrm>
-            <a:off x="4648200" y="3152775"/>
+            <a:off x="4648200" y="3343275"/>
             <a:ext cx="3181350" cy="457200"/>
           </a:xfrm>
           <a:prstGeom prst="rect">
@@ -2868,10 +3209,10 @@
       </p:sp>
       <p:sp>
         <p:nvSpPr>
-          <p:cNvPr id="15" name="S02-name-2">
+          <p:cNvPr id="16" name="S02-name-2">
             <a:extLst>
               <a:ext uri="{FF2B5EF4-FFF2-40B4-BE49-F238E27FC236}">
-                <a16:creationId xmlns:a16="http://schemas.microsoft.com/office/drawing/2014/main" id="{E76094DB-3A7D-4526-9A34-02B28F700684}"/>
+                <a16:creationId xmlns:a16="http://schemas.microsoft.com/office/drawing/2014/main" id="{F29D79EE-1418-435F-B0D0-981626934636}"/>
               </a:ext>
             </a:extLst>
           </p:cNvPr>
@@ -2882,7 +3223,7 @@
         </p:nvSpPr>
         <p:spPr>
           <a:xfrm>
-            <a:off x="4648200" y="3724275"/>
+            <a:off x="4648200" y="3876675"/>
             <a:ext cx="3095625" cy="304800"/>
           </a:xfrm>
           <a:prstGeom prst="rect">
@@ -2902,7 +3243,7 @@
             <a:pPr>
               <a:defRPr sz="1575" b="0">
                 <a:solidFill>
-                  <a:srgbClr val="287D78"/>
+                  <a:srgbClr val="246E69"/>
                 </a:solidFill>
                 <a:latin typeface="Noto Sans KR"/>
                 <a:ea typeface="Noto Sans KR"/>
@@ -2912,7 +3253,7 @@
             <a:r>
               <a:rPr sz="1575" b="0">
                 <a:solidFill>
-                  <a:srgbClr val="287D78"/>
+                  <a:srgbClr val="246E69"/>
                 </a:solidFill>
                 <a:latin typeface="Noto Sans KR"/>
                 <a:ea typeface="Noto Sans KR"/>
@@ -2925,10 +3266,10 @@
       </p:sp>
       <p:sp>
         <p:nvSpPr>
-          <p:cNvPr id="16" name="S02-detail-2">
+          <p:cNvPr id="17" name="S02-detail-2">
             <a:extLst>
               <a:ext uri="{FF2B5EF4-FFF2-40B4-BE49-F238E27FC236}">
-                <a16:creationId xmlns:a16="http://schemas.microsoft.com/office/drawing/2014/main" id="{AD69CC82-A32F-4BCC-A3CF-2A2D8573CFB3}"/>
+                <a16:creationId xmlns:a16="http://schemas.microsoft.com/office/drawing/2014/main" id="{1473EC92-A837-4D39-8D2D-8A2A3F6B6FE2}"/>
               </a:ext>
             </a:extLst>
           </p:cNvPr>
@@ -2939,8 +3280,8 @@
         </p:nvSpPr>
         <p:spPr>
           <a:xfrm>
-            <a:off x="4648200" y="4295775"/>
-            <a:ext cx="3181350" cy="771525"/>
+            <a:off x="4648200" y="4438650"/>
+            <a:ext cx="3181350" cy="704850"/>
           </a:xfrm>
           <a:prstGeom prst="rect">
             <a:avLst/>
@@ -3005,10 +3346,10 @@
       </p:sp>
       <p:sp>
         <p:nvSpPr>
-          <p:cNvPr id="17" name="S02-stage-3">
+          <p:cNvPr id="18" name="S02-stage-3">
             <a:extLst>
               <a:ext uri="{FF2B5EF4-FFF2-40B4-BE49-F238E27FC236}">
-                <a16:creationId xmlns:a16="http://schemas.microsoft.com/office/drawing/2014/main" id="{9666B0E2-C118-494B-89F5-479A395266C6}"/>
+                <a16:creationId xmlns:a16="http://schemas.microsoft.com/office/drawing/2014/main" id="{0FCDA664-8011-4580-802F-B6CC8D8A128C}"/>
               </a:ext>
             </a:extLst>
           </p:cNvPr>
@@ -3019,7 +3360,7 @@
         </p:nvSpPr>
         <p:spPr>
           <a:xfrm>
-            <a:off x="8610600" y="3152775"/>
+            <a:off x="8610600" y="3343275"/>
             <a:ext cx="3181350" cy="457200"/>
           </a:xfrm>
           <a:prstGeom prst="rect">
@@ -3062,10 +3403,10 @@
       </p:sp>
       <p:sp>
         <p:nvSpPr>
-          <p:cNvPr id="18" name="S02-name-3">
+          <p:cNvPr id="19" name="S02-name-3">
             <a:extLst>
               <a:ext uri="{FF2B5EF4-FFF2-40B4-BE49-F238E27FC236}">
-                <a16:creationId xmlns:a16="http://schemas.microsoft.com/office/drawing/2014/main" id="{5EC11778-7709-4CE8-B12B-26A41AED01AA}"/>
+                <a16:creationId xmlns:a16="http://schemas.microsoft.com/office/drawing/2014/main" id="{4BB01D62-A7CD-4788-A077-9AE76D7AFEFA}"/>
               </a:ext>
             </a:extLst>
           </p:cNvPr>
@@ -3076,7 +3417,7 @@
         </p:nvSpPr>
         <p:spPr>
           <a:xfrm>
-            <a:off x="8610600" y="3724275"/>
+            <a:off x="8610600" y="3876675"/>
             <a:ext cx="3095625" cy="304800"/>
           </a:xfrm>
           <a:prstGeom prst="rect">
@@ -3096,7 +3437,7 @@
             <a:pPr>
               <a:defRPr sz="1575" b="0">
                 <a:solidFill>
-                  <a:srgbClr val="287D78"/>
+                  <a:srgbClr val="246E69"/>
                 </a:solidFill>
                 <a:latin typeface="Noto Sans KR"/>
                 <a:ea typeface="Noto Sans KR"/>
@@ -3106,7 +3447,7 @@
             <a:r>
               <a:rPr sz="1575" b="0">
                 <a:solidFill>
-                  <a:srgbClr val="287D78"/>
+                  <a:srgbClr val="246E69"/>
                 </a:solidFill>
                 <a:latin typeface="Noto Sans KR"/>
                 <a:ea typeface="Noto Sans KR"/>
@@ -3119,10 +3460,10 @@
       </p:sp>
       <p:sp>
         <p:nvSpPr>
-          <p:cNvPr id="19" name="S02-detail-3">
+          <p:cNvPr id="20" name="S02-detail-3">
             <a:extLst>
               <a:ext uri="{FF2B5EF4-FFF2-40B4-BE49-F238E27FC236}">
-                <a16:creationId xmlns:a16="http://schemas.microsoft.com/office/drawing/2014/main" id="{D8BA29F8-EBAB-4E42-A3B7-882A8D8F600B}"/>
+                <a16:creationId xmlns:a16="http://schemas.microsoft.com/office/drawing/2014/main" id="{E1186B7D-4F7C-4573-ADD9-0C4FE2E45303}"/>
               </a:ext>
             </a:extLst>
           </p:cNvPr>
@@ -3133,8 +3474,8 @@
         </p:nvSpPr>
         <p:spPr>
           <a:xfrm>
-            <a:off x="8610600" y="4295775"/>
-            <a:ext cx="3181350" cy="771525"/>
+            <a:off x="8610600" y="4438650"/>
+            <a:ext cx="3181350" cy="704850"/>
           </a:xfrm>
           <a:prstGeom prst="rect">
             <a:avLst/>
@@ -3199,10 +3540,10 @@
       </p:sp>
       <p:sp>
         <p:nvSpPr>
-          <p:cNvPr id="20" name="S02-caveat">
+          <p:cNvPr id="21" name="S02-caveat">
             <a:extLst>
               <a:ext uri="{FF2B5EF4-FFF2-40B4-BE49-F238E27FC236}">
-                <a16:creationId xmlns:a16="http://schemas.microsoft.com/office/drawing/2014/main" id="{DA2C80E0-00AB-4235-9AD2-B49031C1CCA1}"/>
+                <a16:creationId xmlns:a16="http://schemas.microsoft.com/office/drawing/2014/main" id="{9153CEBA-02D6-4537-8A28-8448123C7E3C}"/>
               </a:ext>
             </a:extLst>
           </p:cNvPr>
@@ -3249,7 +3590,7 @@
                 <a:ea typeface="Noto Sans KR"/>
                 <a:cs typeface="Noto Sans KR"/>
               </a:rPr>
-              <a:t>개념도입니다. 모델 구조와 구체적인 양자화 범위는 미제공입니다.</a:t>
+              <a:t>경량화 과정을 설명하기 위한 개념도입니다.</a:t>
             </a:r>
           </a:p>
         </p:txBody>
@@ -3257,7 +3598,7 @@
     </p:spTree>
     <p:extLst>
       <p:ext uri="{BB962C8B-B14F-4D97-AF65-F5344CB8AC3E}">
-        <p14:creationId xmlns:p14="http://schemas.microsoft.com/office/powerpoint/2010/main" val="649119494"/>
+        <p14:creationId xmlns:p14="http://schemas.microsoft.com/office/powerpoint/2010/main" val="285713905"/>
       </p:ext>
     </p:extLst>
   </p:cSld>
@@ -3298,7 +3639,7 @@
                                           </p:stCondLst>
                                         </p:cTn>
                                         <p:tgtEl>
-                                          <p:spTgt spid="5"/>
+                                          <p:spTgt spid="6"/>
                                         </p:tgtEl>
                                         <p:attrNameLst>
                                           <p:attrName>style.visibility</p:attrName>
@@ -3312,7 +3653,7 @@
                                       <p:cBhvr>
                                         <p:cTn id="7" dur="350"/>
                                         <p:tgtEl>
-                                          <p:spTgt spid="5"/>
+                                          <p:spTgt spid="6"/>
                                         </p:tgtEl>
                                       </p:cBhvr>
                                     </p:animEffect>
@@ -3333,7 +3674,7 @@
                                           </p:stCondLst>
                                         </p:cTn>
                                         <p:tgtEl>
-                                          <p:spTgt spid="27"/>
+                                          <p:spTgt spid="29"/>
                                         </p:tgtEl>
                                         <p:attrNameLst>
                                           <p:attrName>style.visibility</p:attrName>
@@ -3347,7 +3688,7 @@
                                       <p:cBhvr>
                                         <p:cTn id="10" dur="350"/>
                                         <p:tgtEl>
-                                          <p:spTgt spid="27"/>
+                                          <p:spTgt spid="29"/>
                                         </p:tgtEl>
                                       </p:cBhvr>
                                     </p:animEffect>
@@ -3368,7 +3709,7 @@
                                           </p:stCondLst>
                                         </p:cTn>
                                         <p:tgtEl>
-                                          <p:spTgt spid="9"/>
+                                          <p:spTgt spid="10"/>
                                         </p:tgtEl>
                                         <p:attrNameLst>
                                           <p:attrName>style.visibility</p:attrName>
@@ -3382,7 +3723,7 @@
                                       <p:cBhvr>
                                         <p:cTn id="13" dur="350"/>
                                         <p:tgtEl>
-                                          <p:spTgt spid="9"/>
+                                          <p:spTgt spid="10"/>
                                         </p:tgtEl>
                                       </p:cBhvr>
                                     </p:animEffect>
@@ -3403,7 +3744,7 @@
                                           </p:stCondLst>
                                         </p:cTn>
                                         <p:tgtEl>
-                                          <p:spTgt spid="14"/>
+                                          <p:spTgt spid="15"/>
                                         </p:tgtEl>
                                         <p:attrNameLst>
                                           <p:attrName>style.visibility</p:attrName>
@@ -3417,7 +3758,7 @@
                                       <p:cBhvr>
                                         <p:cTn id="16" dur="350"/>
                                         <p:tgtEl>
-                                          <p:spTgt spid="14"/>
+                                          <p:spTgt spid="15"/>
                                         </p:tgtEl>
                                       </p:cBhvr>
                                     </p:animEffect>
@@ -3438,7 +3779,7 @@
                                           </p:stCondLst>
                                         </p:cTn>
                                         <p:tgtEl>
-                                          <p:spTgt spid="15"/>
+                                          <p:spTgt spid="16"/>
                                         </p:tgtEl>
                                         <p:attrNameLst>
                                           <p:attrName>style.visibility</p:attrName>
@@ -3452,7 +3793,7 @@
                                       <p:cBhvr>
                                         <p:cTn id="19" dur="350"/>
                                         <p:tgtEl>
-                                          <p:spTgt spid="15"/>
+                                          <p:spTgt spid="16"/>
                                         </p:tgtEl>
                                       </p:cBhvr>
                                     </p:animEffect>
@@ -3473,7 +3814,7 @@
                                           </p:stCondLst>
                                         </p:cTn>
                                         <p:tgtEl>
-                                          <p:spTgt spid="16"/>
+                                          <p:spTgt spid="17"/>
                                         </p:tgtEl>
                                         <p:attrNameLst>
                                           <p:attrName>style.visibility</p:attrName>
@@ -3487,7 +3828,7 @@
                                       <p:cBhvr>
                                         <p:cTn id="22" dur="350"/>
                                         <p:tgtEl>
-                                          <p:spTgt spid="16"/>
+                                          <p:spTgt spid="17"/>
                                         </p:tgtEl>
                                       </p:cBhvr>
                                     </p:animEffect>
@@ -3526,7 +3867,7 @@
                                           </p:stCondLst>
                                         </p:cTn>
                                         <p:tgtEl>
-                                          <p:spTgt spid="6"/>
+                                          <p:spTgt spid="7"/>
                                         </p:tgtEl>
                                         <p:attrNameLst>
                                           <p:attrName>style.visibility</p:attrName>
@@ -3540,7 +3881,7 @@
                                       <p:cBhvr>
                                         <p:cTn id="27" dur="350"/>
                                         <p:tgtEl>
-                                          <p:spTgt spid="6"/>
+                                          <p:spTgt spid="7"/>
                                         </p:tgtEl>
                                       </p:cBhvr>
                                     </p:animEffect>
@@ -3561,7 +3902,7 @@
                                           </p:stCondLst>
                                         </p:cTn>
                                         <p:tgtEl>
-                                          <p:spTgt spid="28"/>
+                                          <p:spTgt spid="30"/>
                                         </p:tgtEl>
                                         <p:attrNameLst>
                                           <p:attrName>style.visibility</p:attrName>
@@ -3575,7 +3916,7 @@
                                       <p:cBhvr>
                                         <p:cTn id="30" dur="350"/>
                                         <p:tgtEl>
-                                          <p:spTgt spid="28"/>
+                                          <p:spTgt spid="30"/>
                                         </p:tgtEl>
                                       </p:cBhvr>
                                     </p:animEffect>
@@ -3596,7 +3937,7 @@
                                           </p:stCondLst>
                                         </p:cTn>
                                         <p:tgtEl>
-                                          <p:spTgt spid="10"/>
+                                          <p:spTgt spid="11"/>
                                         </p:tgtEl>
                                         <p:attrNameLst>
                                           <p:attrName>style.visibility</p:attrName>
@@ -3610,7 +3951,7 @@
                                       <p:cBhvr>
                                         <p:cTn id="33" dur="350"/>
                                         <p:tgtEl>
-                                          <p:spTgt spid="10"/>
+                                          <p:spTgt spid="11"/>
                                         </p:tgtEl>
                                       </p:cBhvr>
                                     </p:animEffect>
@@ -3631,7 +3972,7 @@
                                           </p:stCondLst>
                                         </p:cTn>
                                         <p:tgtEl>
-                                          <p:spTgt spid="17"/>
+                                          <p:spTgt spid="18"/>
                                         </p:tgtEl>
                                         <p:attrNameLst>
                                           <p:attrName>style.visibility</p:attrName>
@@ -3645,7 +3986,7 @@
                                       <p:cBhvr>
                                         <p:cTn id="36" dur="350"/>
                                         <p:tgtEl>
-                                          <p:spTgt spid="17"/>
+                                          <p:spTgt spid="18"/>
                                         </p:tgtEl>
                                       </p:cBhvr>
                                     </p:animEffect>
@@ -3666,7 +4007,7 @@
                                           </p:stCondLst>
                                         </p:cTn>
                                         <p:tgtEl>
-                                          <p:spTgt spid="18"/>
+                                          <p:spTgt spid="19"/>
                                         </p:tgtEl>
                                         <p:attrNameLst>
                                           <p:attrName>style.visibility</p:attrName>
@@ -3680,7 +4021,7 @@
                                       <p:cBhvr>
                                         <p:cTn id="39" dur="350"/>
                                         <p:tgtEl>
-                                          <p:spTgt spid="18"/>
+                                          <p:spTgt spid="19"/>
                                         </p:tgtEl>
                                       </p:cBhvr>
                                     </p:animEffect>
@@ -3701,7 +4042,7 @@
                                           </p:stCondLst>
                                         </p:cTn>
                                         <p:tgtEl>
-                                          <p:spTgt spid="19"/>
+                                          <p:spTgt spid="20"/>
                                         </p:tgtEl>
                                         <p:attrNameLst>
                                           <p:attrName>style.visibility</p:attrName>
@@ -3715,7 +4056,7 @@
                                       <p:cBhvr>
                                         <p:cTn id="42" dur="350"/>
                                         <p:tgtEl>
-                                          <p:spTgt spid="19"/>
+                                          <p:spTgt spid="20"/>
                                         </p:tgtEl>
                                       </p:cBhvr>
                                     </p:animEffect>
@@ -3750,16 +4091,16 @@
       </p:par>
     </p:tnLst>
     <p:bldLst>
-      <p:bldP spid="5" grpId="0" animBg="1"/>
       <p:bldP spid="6" grpId="0" animBg="1"/>
-      <p:bldP spid="9" grpId="0"/>
+      <p:bldP spid="7" grpId="0" animBg="1"/>
       <p:bldP spid="10" grpId="0"/>
-      <p:bldP spid="14" grpId="0"/>
+      <p:bldP spid="11" grpId="0"/>
       <p:bldP spid="15" grpId="0"/>
       <p:bldP spid="16" grpId="0"/>
       <p:bldP spid="17" grpId="0"/>
       <p:bldP spid="18" grpId="0"/>
       <p:bldP spid="19" grpId="0"/>
+      <p:bldP spid="20" grpId="0"/>
     </p:bldLst>
   </p:timing>
 </p:sld>
@@ -3792,10 +4133,10 @@
       </p:grpSpPr>
       <p:sp>
         <p:nvSpPr>
-          <p:cNvPr id="8" name="S03-title">
+          <p:cNvPr id="7" name="S03-title">
             <a:extLst>
               <a:ext uri="{FF2B5EF4-FFF2-40B4-BE49-F238E27FC236}">
-                <a16:creationId xmlns:a16="http://schemas.microsoft.com/office/drawing/2014/main" id="{2BFCB33E-D440-4E8E-9045-EBC7B2A4A73F}"/>
+                <a16:creationId xmlns:a16="http://schemas.microsoft.com/office/drawing/2014/main" id="{C41752D5-DD1F-4376-B169-90418CFAC891}"/>
               </a:ext>
             </a:extLst>
           </p:cNvPr>
@@ -3852,7 +4193,7 @@
           <p:cNvPr id="2" name="S03-disclosure">
             <a:extLst>
               <a:ext uri="{FF2B5EF4-FFF2-40B4-BE49-F238E27FC236}">
-                <a16:creationId xmlns:a16="http://schemas.microsoft.com/office/drawing/2014/main" id="{70AD51DF-4D9E-47A2-8535-1F0B7A490A4B}"/>
+                <a16:creationId xmlns:a16="http://schemas.microsoft.com/office/drawing/2014/main" id="{EE3275A8-0DAB-4B0D-9609-F428BB302C99}"/>
               </a:ext>
             </a:extLst>
           </p:cNvPr>
@@ -3899,7 +4240,7 @@
                 <a:ea typeface="Noto Sans KR"/>
                 <a:cs typeface="Noto Sans KR"/>
               </a:rPr>
-              <a:t>가상 데이터 · 실제 실험 결과가 아닙니다</a:t>
+              <a:t>가상 데이터</a:t>
             </a:r>
           </a:p>
         </p:txBody>
@@ -3909,7 +4250,7 @@
           <p:cNvPr id="3" name="S03-number">
             <a:extLst>
               <a:ext uri="{FF2B5EF4-FFF2-40B4-BE49-F238E27FC236}">
-                <a16:creationId xmlns:a16="http://schemas.microsoft.com/office/drawing/2014/main" id="{FAB2F029-CE85-4FD1-BF84-7F7926589296}"/>
+                <a16:creationId xmlns:a16="http://schemas.microsoft.com/office/drawing/2014/main" id="{0D100BAA-403D-4CEF-A57F-7602E7936EB5}"/>
               </a:ext>
             </a:extLst>
           </p:cNvPr>
@@ -3966,7 +4307,7 @@
           <p:cNvPr id="4" name="S03-direction">
             <a:extLst>
               <a:ext uri="{FF2B5EF4-FFF2-40B4-BE49-F238E27FC236}">
-                <a16:creationId xmlns:a16="http://schemas.microsoft.com/office/drawing/2014/main" id="{0C8B53CB-C902-45B2-9C8E-2CAB87D1DF26}"/>
+                <a16:creationId xmlns:a16="http://schemas.microsoft.com/office/drawing/2014/main" id="{9F7CA977-AE75-46C5-8707-32A90B765367}"/>
               </a:ext>
             </a:extLst>
           </p:cNvPr>
@@ -4020,13 +4361,13 @@
       </p:sp>
       <p:graphicFrame>
         <p:nvGraphicFramePr>
-          <p:cNvPr id="12" name="표 11"/>
+          <p:cNvPr id="11" name="표 10"/>
           <p:cNvGraphicFramePr/>
           <p:nvPr/>
         </p:nvGraphicFramePr>
         <p:xfrm>
-          <a:off x="609600" y="2314575"/>
-          <a:ext cx="10972800" cy="2857500"/>
+          <a:off x="609600" y="2343150"/>
+          <a:ext cx="10972800" cy="2933700"/>
         </p:xfrm>
         <a:graphic>
           <a:graphicData uri="http://schemas.openxmlformats.org/drawingml/2006/table">
@@ -4062,7 +4403,7 @@
                   </a:extLst>
                 </a:gridCol>
               </a:tblGrid>
-              <a:tr h="714375">
+              <a:tr h="733425">
                 <a:tc>
                   <a:txBody>
                     <a:bodyPr/>
@@ -4072,7 +4413,7 @@
                       <a:r>
                         <a:rPr sz="1800" b="0">
                           <a:solidFill>
-                            <a:srgbClr val="586C68"/>
+                            <a:srgbClr val="FFFFFF"/>
                           </a:solidFill>
                           <a:latin typeface="Noto Sans KR"/>
                           <a:ea typeface="Noto Sans KR"/>
@@ -4102,7 +4443,7 @@
                       <a:noFill/>
                     </a:lnBlToTr>
                     <a:solidFill>
-                      <a:srgbClr val="F6F4EE"/>
+                      <a:srgbClr val="1E302F"/>
                     </a:solidFill>
                   </a:tcPr>
                 </a:tc>
@@ -4115,7 +4456,7 @@
                       <a:r>
                         <a:rPr sz="1800" b="0">
                           <a:solidFill>
-                            <a:srgbClr val="586C68"/>
+                            <a:srgbClr val="FFFFFF"/>
                           </a:solidFill>
                           <a:latin typeface="Noto Sans KR"/>
                           <a:ea typeface="Noto Sans KR"/>
@@ -4145,7 +4486,7 @@
                       <a:noFill/>
                     </a:lnBlToTr>
                     <a:solidFill>
-                      <a:srgbClr val="F6F4EE"/>
+                      <a:srgbClr val="1E302F"/>
                     </a:solidFill>
                   </a:tcPr>
                 </a:tc>
@@ -4158,7 +4499,7 @@
                       <a:r>
                         <a:rPr sz="1800" b="0">
                           <a:solidFill>
-                            <a:srgbClr val="586C68"/>
+                            <a:srgbClr val="FFFFFF"/>
                           </a:solidFill>
                           <a:latin typeface="Noto Sans KR"/>
                           <a:ea typeface="Noto Sans KR"/>
@@ -4188,7 +4529,7 @@
                       <a:noFill/>
                     </a:lnBlToTr>
                     <a:solidFill>
-                      <a:srgbClr val="F6F4EE"/>
+                      <a:srgbClr val="1E302F"/>
                     </a:solidFill>
                   </a:tcPr>
                 </a:tc>
@@ -4201,7 +4542,7 @@
                       <a:r>
                         <a:rPr sz="1800" b="0">
                           <a:solidFill>
-                            <a:srgbClr val="586C68"/>
+                            <a:srgbClr val="FFFFFF"/>
                           </a:solidFill>
                           <a:latin typeface="Noto Sans KR"/>
                           <a:ea typeface="Noto Sans KR"/>
@@ -4231,7 +4572,7 @@
                       <a:noFill/>
                     </a:lnBlToTr>
                     <a:solidFill>
-                      <a:srgbClr val="F6F4EE"/>
+                      <a:srgbClr val="1E302F"/>
                     </a:solidFill>
                   </a:tcPr>
                 </a:tc>
@@ -4241,7 +4582,7 @@
                   </a:ext>
                 </a:extLst>
               </a:tr>
-              <a:tr h="714375">
+              <a:tr h="733425">
                 <a:tc>
                   <a:txBody>
                     <a:bodyPr/>
@@ -4281,7 +4622,7 @@
                       <a:noFill/>
                     </a:lnBlToTr>
                     <a:solidFill>
-                      <a:srgbClr val="F6F4EE"/>
+                      <a:srgbClr val="E8EDE5"/>
                     </a:solidFill>
                   </a:tcPr>
                 </a:tc>
@@ -4324,7 +4665,7 @@
                       <a:noFill/>
                     </a:lnBlToTr>
                     <a:solidFill>
-                      <a:srgbClr val="F6F4EE"/>
+                      <a:srgbClr val="E8EDE5"/>
                     </a:solidFill>
                   </a:tcPr>
                 </a:tc>
@@ -4367,7 +4708,7 @@
                       <a:noFill/>
                     </a:lnBlToTr>
                     <a:solidFill>
-                      <a:srgbClr val="F6F4EE"/>
+                      <a:srgbClr val="E8EDE5"/>
                     </a:solidFill>
                   </a:tcPr>
                 </a:tc>
@@ -4410,7 +4751,7 @@
                       <a:noFill/>
                     </a:lnBlToTr>
                     <a:solidFill>
-                      <a:srgbClr val="F6F4EE"/>
+                      <a:srgbClr val="E8EDE5"/>
                     </a:solidFill>
                   </a:tcPr>
                 </a:tc>
@@ -4420,7 +4761,7 @@
                   </a:ext>
                 </a:extLst>
               </a:tr>
-              <a:tr h="714375">
+              <a:tr h="733425">
                 <a:tc>
                   <a:txBody>
                     <a:bodyPr/>
@@ -4599,7 +4940,7 @@
                   </a:ext>
                 </a:extLst>
               </a:tr>
-              <a:tr h="714375">
+              <a:tr h="733425">
                 <a:tc>
                   <a:txBody>
                     <a:bodyPr/>
@@ -4639,7 +4980,7 @@
                       <a:noFill/>
                     </a:lnBlToTr>
                     <a:solidFill>
-                      <a:srgbClr val="F6F4EE"/>
+                      <a:srgbClr val="E8EDE5"/>
                     </a:solidFill>
                   </a:tcPr>
                 </a:tc>
@@ -4682,7 +5023,7 @@
                       <a:noFill/>
                     </a:lnBlToTr>
                     <a:solidFill>
-                      <a:srgbClr val="F6F4EE"/>
+                      <a:srgbClr val="E8EDE5"/>
                     </a:solidFill>
                   </a:tcPr>
                 </a:tc>
@@ -4725,7 +5066,7 @@
                       <a:noFill/>
                     </a:lnBlToTr>
                     <a:solidFill>
-                      <a:srgbClr val="F6F4EE"/>
+                      <a:srgbClr val="E8EDE5"/>
                     </a:solidFill>
                   </a:tcPr>
                 </a:tc>
@@ -4768,7 +5109,7 @@
                       <a:noFill/>
                     </a:lnBlToTr>
                     <a:solidFill>
-                      <a:srgbClr val="F6F4EE"/>
+                      <a:srgbClr val="E8EDE5"/>
                     </a:solidFill>
                   </a:tcPr>
                 </a:tc>
@@ -4784,39 +5125,10 @@
       </p:graphicFrame>
       <p:sp>
         <p:nvSpPr>
-          <p:cNvPr id="6" name="S03-header-rule">
+          <p:cNvPr id="6" name="S03-limit">
             <a:extLst>
               <a:ext uri="{FF2B5EF4-FFF2-40B4-BE49-F238E27FC236}">
-                <a16:creationId xmlns:a16="http://schemas.microsoft.com/office/drawing/2014/main" id="{D06DE6E8-A4B2-41DA-A73A-86E0E6937544}"/>
-              </a:ext>
-            </a:extLst>
-          </p:cNvPr>
-          <p:cNvSpPr>
-            <a:spLocks noGrp="1"/>
-          </p:cNvSpPr>
-          <p:nvPr/>
-        </p:nvSpPr>
-        <p:spPr>
-          <a:xfrm>
-            <a:off x="685800" y="3028950"/>
-            <a:ext cx="10820400" cy="0"/>
-          </a:xfrm>
-          <a:prstGeom prst="line">
-            <a:avLst/>
-          </a:prstGeom>
-          <a:ln w="9525">
-            <a:solidFill>
-              <a:srgbClr val="CFD8D1"/>
-            </a:solidFill>
-          </a:ln>
-        </p:spPr>
-      </p:sp>
-      <p:sp>
-        <p:nvSpPr>
-          <p:cNvPr id="7" name="S03-limit">
-            <a:extLst>
-              <a:ext uri="{FF2B5EF4-FFF2-40B4-BE49-F238E27FC236}">
-                <a16:creationId xmlns:a16="http://schemas.microsoft.com/office/drawing/2014/main" id="{1E0049A3-4E3D-4EDE-A422-2484BCDE561B}"/>
+                <a16:creationId xmlns:a16="http://schemas.microsoft.com/office/drawing/2014/main" id="{A1A9D84A-067B-4845-9DD7-6429EC59FBE6}"/>
               </a:ext>
             </a:extLst>
           </p:cNvPr>
@@ -4863,7 +5175,7 @@
                 <a:ea typeface="Noto Sans KR"/>
                 <a:cs typeface="Noto Sans KR"/>
               </a:rPr>
-              <a:t>동일 장치·데이터를 가정합니다. 표본수·분산·실제 데이터셋명은 미제공입니다.</a:t>
+              <a:t>동일 장치·데이터를 가정한 예시이며, 측정 변동성은 평가하지 않았습니다.</a:t>
             </a:r>
           </a:p>
         </p:txBody>
@@ -4871,7 +5183,7 @@
     </p:spTree>
     <p:extLst>
       <p:ext uri="{BB962C8B-B14F-4D97-AF65-F5344CB8AC3E}">
-        <p14:creationId xmlns:p14="http://schemas.microsoft.com/office/powerpoint/2010/main" val="1457840297"/>
+        <p14:creationId xmlns:p14="http://schemas.microsoft.com/office/powerpoint/2010/main" val="2008783958"/>
       </p:ext>
     </p:extLst>
   </p:cSld>
@@ -4908,10 +5220,10 @@
       </p:grpSpPr>
       <p:sp>
         <p:nvSpPr>
-          <p:cNvPr id="15" name="S04-title">
+          <p:cNvPr id="17" name="S04-title">
             <a:extLst>
               <a:ext uri="{FF2B5EF4-FFF2-40B4-BE49-F238E27FC236}">
-                <a16:creationId xmlns:a16="http://schemas.microsoft.com/office/drawing/2014/main" id="{25A89D26-9714-4F0E-899C-B3DCD32F3C69}"/>
+                <a16:creationId xmlns:a16="http://schemas.microsoft.com/office/drawing/2014/main" id="{DA8F1443-77C1-4F44-A728-5928FD40DABC}"/>
               </a:ext>
             </a:extLst>
           </p:cNvPr>
@@ -4968,7 +5280,7 @@
           <p:cNvPr id="2" name="S04-disclosure">
             <a:extLst>
               <a:ext uri="{FF2B5EF4-FFF2-40B4-BE49-F238E27FC236}">
-                <a16:creationId xmlns:a16="http://schemas.microsoft.com/office/drawing/2014/main" id="{7194345A-DD90-409E-B7D2-BD2FA43FBC31}"/>
+                <a16:creationId xmlns:a16="http://schemas.microsoft.com/office/drawing/2014/main" id="{5D0B6C74-F2F4-4E52-A1EC-6B61C7AA320C}"/>
               </a:ext>
             </a:extLst>
           </p:cNvPr>
@@ -5015,7 +5327,7 @@
                 <a:ea typeface="Noto Sans KR"/>
                 <a:cs typeface="Noto Sans KR"/>
               </a:rPr>
-              <a:t>가상 데이터 · 실제 실험 결과가 아닙니다</a:t>
+              <a:t>가상 데이터</a:t>
             </a:r>
           </a:p>
         </p:txBody>
@@ -5025,7 +5337,7 @@
           <p:cNvPr id="3" name="S04-number">
             <a:extLst>
               <a:ext uri="{FF2B5EF4-FFF2-40B4-BE49-F238E27FC236}">
-                <a16:creationId xmlns:a16="http://schemas.microsoft.com/office/drawing/2014/main" id="{8C81FEEE-2569-4AEE-BA59-58874E4CC3F2}"/>
+                <a16:creationId xmlns:a16="http://schemas.microsoft.com/office/drawing/2014/main" id="{4780A70D-5067-4C31-907F-3BAD7EE55A92}"/>
               </a:ext>
             </a:extLst>
           </p:cNvPr>
@@ -5079,10 +5391,40 @@
       </p:sp>
       <p:sp>
         <p:nvSpPr>
-          <p:cNvPr id="4" name="S04-chart-unit">
+          <p:cNvPr id="4" name="S04-interpretation-field">
             <a:extLst>
               <a:ext uri="{FF2B5EF4-FFF2-40B4-BE49-F238E27FC236}">
-                <a16:creationId xmlns:a16="http://schemas.microsoft.com/office/drawing/2014/main" id="{3476E6C3-4DEE-43C3-8DE3-72C707C373F9}"/>
+                <a16:creationId xmlns:a16="http://schemas.microsoft.com/office/drawing/2014/main" id="{165C88B8-725C-48C2-A646-7BD5533CB354}"/>
+              </a:ext>
+            </a:extLst>
+          </p:cNvPr>
+          <p:cNvSpPr>
+            <a:spLocks noGrp="1"/>
+          </p:cNvSpPr>
+          <p:nvPr/>
+        </p:nvSpPr>
+        <p:spPr>
+          <a:xfrm>
+            <a:off x="8143875" y="1666875"/>
+            <a:ext cx="3590925" cy="4191000"/>
+          </a:xfrm>
+          <a:prstGeom prst="rect">
+            <a:avLst/>
+          </a:prstGeom>
+          <a:solidFill>
+            <a:srgbClr val="1E302F"/>
+          </a:solidFill>
+          <a:ln w="0">
+            <a:noFill/>
+          </a:ln>
+        </p:spPr>
+      </p:sp>
+      <p:sp>
+        <p:nvSpPr>
+          <p:cNvPr id="5" name="S04-chart-unit">
+            <a:extLst>
+              <a:ext uri="{FF2B5EF4-FFF2-40B4-BE49-F238E27FC236}">
+                <a16:creationId xmlns:a16="http://schemas.microsoft.com/office/drawing/2014/main" id="{127418DE-DB21-421E-BF47-EC61D9F182F4}"/>
               </a:ext>
             </a:extLst>
           </p:cNvPr>
@@ -5136,13 +5478,13 @@
       </p:sp>
       <p:graphicFrame>
         <p:nvGraphicFramePr>
-          <p:cNvPr id="19" name="Chart"/>
+          <p:cNvPr id="22" name="Chart"/>
           <p:cNvGraphicFramePr/>
           <p:nvPr/>
         </p:nvGraphicFramePr>
         <p:xfrm>
-          <a:off x="619125" y="2095500"/>
-          <a:ext cx="7191375" cy="3219450"/>
+          <a:off x="619125" y="2114550"/>
+          <a:ext cx="7000875" cy="2857500"/>
         </p:xfrm>
         <a:graphic>
           <a:graphicData uri="http://schemas.openxmlformats.org/drawingml/2006/chart">
@@ -5152,10 +5494,10 @@
       </p:graphicFrame>
       <p:sp>
         <p:nvSpPr>
-          <p:cNvPr id="6" name="S04-x-unit">
+          <p:cNvPr id="7" name="S04-x-unit">
             <a:extLst>
               <a:ext uri="{FF2B5EF4-FFF2-40B4-BE49-F238E27FC236}">
-                <a16:creationId xmlns:a16="http://schemas.microsoft.com/office/drawing/2014/main" id="{8FE66CC3-0328-4D34-B7AE-49897BF48C40}"/>
+                <a16:creationId xmlns:a16="http://schemas.microsoft.com/office/drawing/2014/main" id="{92447F2B-B919-4200-84D7-BBF76BC08E30}"/>
               </a:ext>
             </a:extLst>
           </p:cNvPr>
@@ -5166,7 +5508,7 @@
         </p:nvSpPr>
         <p:spPr>
           <a:xfrm>
-            <a:off x="1428750" y="5181600"/>
+            <a:off x="1428750" y="4943475"/>
             <a:ext cx="6191250" cy="333375"/>
           </a:xfrm>
           <a:prstGeom prst="rect">
@@ -5209,10 +5551,10 @@
       </p:sp>
       <p:sp>
         <p:nvSpPr>
-          <p:cNvPr id="7" name="S04-basis">
+          <p:cNvPr id="8" name="S04-basis">
             <a:extLst>
               <a:ext uri="{FF2B5EF4-FFF2-40B4-BE49-F238E27FC236}">
-                <a16:creationId xmlns:a16="http://schemas.microsoft.com/office/drawing/2014/main" id="{E9F74EB1-8EC5-4C69-A69E-EE397C1B15F2}"/>
+                <a16:creationId xmlns:a16="http://schemas.microsoft.com/office/drawing/2014/main" id="{4040749D-EEEF-4233-A098-9244ADC0CACE}"/>
               </a:ext>
             </a:extLst>
           </p:cNvPr>
@@ -5223,8 +5565,8 @@
         </p:nvSpPr>
         <p:spPr>
           <a:xfrm>
-            <a:off x="8382000" y="1714500"/>
-            <a:ext cx="3124200" cy="333375"/>
+            <a:off x="8439150" y="1866900"/>
+            <a:ext cx="2857500" cy="333375"/>
           </a:xfrm>
           <a:prstGeom prst="rect">
             <a:avLst/>
@@ -5243,7 +5585,7 @@
             <a:pPr>
               <a:defRPr sz="1800" b="0">
                 <a:solidFill>
-                  <a:srgbClr val="586C68"/>
+                  <a:srgbClr val="B9DDD0"/>
                 </a:solidFill>
                 <a:latin typeface="Noto Sans KR"/>
                 <a:ea typeface="Noto Sans KR"/>
@@ -5253,7 +5595,7 @@
             <a:r>
               <a:rPr sz="1800" b="0">
                 <a:solidFill>
-                  <a:srgbClr val="586C68"/>
+                  <a:srgbClr val="B9DDD0"/>
                 </a:solidFill>
                 <a:latin typeface="Noto Sans KR"/>
                 <a:ea typeface="Noto Sans KR"/>
@@ -5266,10 +5608,10 @@
       </p:sp>
       <p:sp>
         <p:nvSpPr>
-          <p:cNvPr id="8" name="S04-latency">
+          <p:cNvPr id="9" name="S04-latency">
             <a:extLst>
               <a:ext uri="{FF2B5EF4-FFF2-40B4-BE49-F238E27FC236}">
-                <a16:creationId xmlns:a16="http://schemas.microsoft.com/office/drawing/2014/main" id="{B21799A0-8608-4BCC-81CF-BD51BA2BCE89}"/>
+                <a16:creationId xmlns:a16="http://schemas.microsoft.com/office/drawing/2014/main" id="{7CA9773E-0243-44F9-861A-E5ABD841EA7A}"/>
               </a:ext>
             </a:extLst>
           </p:cNvPr>
@@ -5280,8 +5622,8 @@
         </p:nvSpPr>
         <p:spPr>
           <a:xfrm>
-            <a:off x="8382000" y="2247900"/>
-            <a:ext cx="3048000" cy="628650"/>
+            <a:off x="8439150" y="2466975"/>
+            <a:ext cx="2857500" cy="628650"/>
           </a:xfrm>
           <a:prstGeom prst="rect">
             <a:avLst/>
@@ -5300,7 +5642,7 @@
             <a:pPr>
               <a:defRPr sz="3450" b="0">
                 <a:solidFill>
-                  <a:srgbClr val="1E302F"/>
+                  <a:srgbClr val="FFFFFF"/>
                 </a:solidFill>
                 <a:latin typeface="Noto Sans KR"/>
                 <a:ea typeface="Noto Sans KR"/>
@@ -5310,7 +5652,7 @@
             <a:r>
               <a:rPr sz="3450" b="0">
                 <a:solidFill>
-                  <a:srgbClr val="1E302F"/>
+                  <a:srgbClr val="FFFFFF"/>
                 </a:solidFill>
                 <a:latin typeface="Noto Sans KR"/>
                 <a:ea typeface="Noto Sans KR"/>
@@ -5323,10 +5665,10 @@
       </p:sp>
       <p:sp>
         <p:nvSpPr>
-          <p:cNvPr id="9" name="S04-latency-label">
+          <p:cNvPr id="10" name="S04-latency-label">
             <a:extLst>
               <a:ext uri="{FF2B5EF4-FFF2-40B4-BE49-F238E27FC236}">
-                <a16:creationId xmlns:a16="http://schemas.microsoft.com/office/drawing/2014/main" id="{395BC17C-9B37-4040-BA6F-9FDCE175910E}"/>
+                <a16:creationId xmlns:a16="http://schemas.microsoft.com/office/drawing/2014/main" id="{3EAD2E6F-447A-4371-8637-5964521115A7}"/>
               </a:ext>
             </a:extLst>
           </p:cNvPr>
@@ -5337,8 +5679,8 @@
         </p:nvSpPr>
         <p:spPr>
           <a:xfrm>
-            <a:off x="8382000" y="2876550"/>
-            <a:ext cx="3124200" cy="361950"/>
+            <a:off x="8439150" y="3095625"/>
+            <a:ext cx="2857500" cy="361950"/>
           </a:xfrm>
           <a:prstGeom prst="rect">
             <a:avLst/>
@@ -5355,9 +5697,9 @@
           <a:lstStyle/>
           <a:p>
             <a:pPr>
-              <a:defRPr sz="1725" b="0">
-                <a:solidFill>
-                  <a:srgbClr val="586C68"/>
+              <a:defRPr sz="1650" b="0">
+                <a:solidFill>
+                  <a:srgbClr val="D7E6DF"/>
                 </a:solidFill>
                 <a:latin typeface="Noto Sans KR"/>
                 <a:ea typeface="Noto Sans KR"/>
@@ -5365,9 +5707,9 @@
               </a:defRPr>
             </a:pPr>
             <a:r>
-              <a:rPr sz="1725" b="0">
-                <a:solidFill>
-                  <a:srgbClr val="586C68"/>
+              <a:rPr sz="1650" b="0">
+                <a:solidFill>
+                  <a:srgbClr val="D7E6DF"/>
                 </a:solidFill>
                 <a:latin typeface="Noto Sans KR"/>
                 <a:ea typeface="Noto Sans KR"/>
@@ -5380,10 +5722,10 @@
       </p:sp>
       <p:sp>
         <p:nvSpPr>
-          <p:cNvPr id="10" name="S04-f1">
+          <p:cNvPr id="11" name="S04-f1">
             <a:extLst>
               <a:ext uri="{FF2B5EF4-FFF2-40B4-BE49-F238E27FC236}">
-                <a16:creationId xmlns:a16="http://schemas.microsoft.com/office/drawing/2014/main" id="{69464394-F990-4519-8FA0-1ADAA43C76F5}"/>
+                <a16:creationId xmlns:a16="http://schemas.microsoft.com/office/drawing/2014/main" id="{3C0FC121-FE60-4D02-88E6-3C7DE221DE46}"/>
               </a:ext>
             </a:extLst>
           </p:cNvPr>
@@ -5394,8 +5736,8 @@
         </p:nvSpPr>
         <p:spPr>
           <a:xfrm>
-            <a:off x="8382000" y="3419475"/>
-            <a:ext cx="3048000" cy="628650"/>
+            <a:off x="8439150" y="3819525"/>
+            <a:ext cx="2857500" cy="628650"/>
           </a:xfrm>
           <a:prstGeom prst="rect">
             <a:avLst/>
@@ -5414,7 +5756,7 @@
             <a:pPr>
               <a:defRPr sz="3450" b="0">
                 <a:solidFill>
-                  <a:srgbClr val="1E302F"/>
+                  <a:srgbClr val="FFFFFF"/>
                 </a:solidFill>
                 <a:latin typeface="Noto Sans KR"/>
                 <a:ea typeface="Noto Sans KR"/>
@@ -5424,7 +5766,7 @@
             <a:r>
               <a:rPr sz="3450" b="0">
                 <a:solidFill>
-                  <a:srgbClr val="1E302F"/>
+                  <a:srgbClr val="FFFFFF"/>
                 </a:solidFill>
                 <a:latin typeface="Noto Sans KR"/>
                 <a:ea typeface="Noto Sans KR"/>
@@ -5437,10 +5779,10 @@
       </p:sp>
       <p:sp>
         <p:nvSpPr>
-          <p:cNvPr id="11" name="S04-f1-label">
+          <p:cNvPr id="12" name="S04-f1-label">
             <a:extLst>
               <a:ext uri="{FF2B5EF4-FFF2-40B4-BE49-F238E27FC236}">
-                <a16:creationId xmlns:a16="http://schemas.microsoft.com/office/drawing/2014/main" id="{031A2F0C-DF36-4E8F-BB80-36B0DE5095E8}"/>
+                <a16:creationId xmlns:a16="http://schemas.microsoft.com/office/drawing/2014/main" id="{399956CA-3003-4B27-A3D7-FFCA4103038C}"/>
               </a:ext>
             </a:extLst>
           </p:cNvPr>
@@ -5451,8 +5793,8 @@
         </p:nvSpPr>
         <p:spPr>
           <a:xfrm>
-            <a:off x="8382000" y="4048125"/>
-            <a:ext cx="3124200" cy="361950"/>
+            <a:off x="8439150" y="4448175"/>
+            <a:ext cx="2857500" cy="361950"/>
           </a:xfrm>
           <a:prstGeom prst="rect">
             <a:avLst/>
@@ -5469,66 +5811,9 @@
           <a:lstStyle/>
           <a:p>
             <a:pPr>
-              <a:defRPr sz="1725" b="0">
-                <a:solidFill>
-                  <a:srgbClr val="586C68"/>
-                </a:solidFill>
-                <a:latin typeface="Noto Sans KR"/>
-                <a:ea typeface="Noto Sans KR"/>
-                <a:cs typeface="Noto Sans KR"/>
-              </a:defRPr>
-            </a:pPr>
-            <a:r>
-              <a:rPr sz="1725" b="0">
-                <a:solidFill>
-                  <a:srgbClr val="586C68"/>
-                </a:solidFill>
-                <a:latin typeface="Noto Sans KR"/>
-                <a:ea typeface="Noto Sans KR"/>
-                <a:cs typeface="Noto Sans KR"/>
-              </a:rPr>
-              <a:t>F1 · 절대 차이</a:t>
-            </a:r>
-          </a:p>
-        </p:txBody>
-      </p:sp>
-      <p:sp>
-        <p:nvSpPr>
-          <p:cNvPr id="12" name="S04-size-values">
-            <a:extLst>
-              <a:ext uri="{FF2B5EF4-FFF2-40B4-BE49-F238E27FC236}">
-                <a16:creationId xmlns:a16="http://schemas.microsoft.com/office/drawing/2014/main" id="{1D8035D4-AE13-4CFF-82AD-929826B7A139}"/>
-              </a:ext>
-            </a:extLst>
-          </p:cNvPr>
-          <p:cNvSpPr>
-            <a:spLocks noGrp="1"/>
-          </p:cNvSpPr>
-          <p:nvPr/>
-        </p:nvSpPr>
-        <p:spPr>
-          <a:xfrm>
-            <a:off x="8382000" y="4772025"/>
-            <a:ext cx="3124200" cy="457200"/>
-          </a:xfrm>
-          <a:prstGeom prst="rect">
-            <a:avLst/>
-          </a:prstGeom>
-          <a:noFill/>
-          <a:ln w="0">
-            <a:noFill/>
-          </a:ln>
-        </p:spPr>
-        <p:txBody>
-          <a:bodyPr wrap="none" lIns="0" tIns="0" rIns="0" bIns="0" anchor="ctr">
-            <a:noAutofit/>
-          </a:bodyPr>
-          <a:lstStyle/>
-          <a:p>
-            <a:pPr>
               <a:defRPr sz="1650" b="0">
                 <a:solidFill>
-                  <a:srgbClr val="586C68"/>
+                  <a:srgbClr val="D7E6DF"/>
                 </a:solidFill>
                 <a:latin typeface="Noto Sans KR"/>
                 <a:ea typeface="Noto Sans KR"/>
@@ -5538,7 +5823,64 @@
             <a:r>
               <a:rPr sz="1650" b="0">
                 <a:solidFill>
-                  <a:srgbClr val="586C68"/>
+                  <a:srgbClr val="D7E6DF"/>
+                </a:solidFill>
+                <a:latin typeface="Noto Sans KR"/>
+                <a:ea typeface="Noto Sans KR"/>
+                <a:cs typeface="Noto Sans KR"/>
+              </a:rPr>
+              <a:t>F1 · 절대 차이</a:t>
+            </a:r>
+          </a:p>
+        </p:txBody>
+      </p:sp>
+      <p:sp>
+        <p:nvSpPr>
+          <p:cNvPr id="13" name="S04-size-values">
+            <a:extLst>
+              <a:ext uri="{FF2B5EF4-FFF2-40B4-BE49-F238E27FC236}">
+                <a16:creationId xmlns:a16="http://schemas.microsoft.com/office/drawing/2014/main" id="{67970E90-184C-4590-8201-3F322856A537}"/>
+              </a:ext>
+            </a:extLst>
+          </p:cNvPr>
+          <p:cNvSpPr>
+            <a:spLocks noGrp="1"/>
+          </p:cNvSpPr>
+          <p:nvPr/>
+        </p:nvSpPr>
+        <p:spPr>
+          <a:xfrm>
+            <a:off x="8439150" y="5210175"/>
+            <a:ext cx="2857500" cy="400050"/>
+          </a:xfrm>
+          <a:prstGeom prst="rect">
+            <a:avLst/>
+          </a:prstGeom>
+          <a:noFill/>
+          <a:ln w="0">
+            <a:noFill/>
+          </a:ln>
+        </p:spPr>
+        <p:txBody>
+          <a:bodyPr wrap="none" lIns="0" tIns="0" rIns="0" bIns="0" anchor="ctr">
+            <a:noAutofit/>
+          </a:bodyPr>
+          <a:lstStyle/>
+          <a:p>
+            <a:pPr>
+              <a:defRPr sz="1575" b="0">
+                <a:solidFill>
+                  <a:srgbClr val="D7E6DF"/>
+                </a:solidFill>
+                <a:latin typeface="Noto Sans KR"/>
+                <a:ea typeface="Noto Sans KR"/>
+                <a:cs typeface="Noto Sans KR"/>
+              </a:defRPr>
+            </a:pPr>
+            <a:r>
+              <a:rPr sz="1575" b="0">
+                <a:solidFill>
+                  <a:srgbClr val="D7E6DF"/>
                 </a:solidFill>
                 <a:latin typeface="Noto Sans KR"/>
                 <a:ea typeface="Noto Sans KR"/>
@@ -5551,10 +5893,10 @@
       </p:sp>
       <p:sp>
         <p:nvSpPr>
-          <p:cNvPr id="13" name="S04-stage1">
+          <p:cNvPr id="14" name="S04-decomposition-rule">
             <a:extLst>
               <a:ext uri="{FF2B5EF4-FFF2-40B4-BE49-F238E27FC236}">
-                <a16:creationId xmlns:a16="http://schemas.microsoft.com/office/drawing/2014/main" id="{586C2BEF-64EF-4888-BBD7-763AB6753C14}"/>
+                <a16:creationId xmlns:a16="http://schemas.microsoft.com/office/drawing/2014/main" id="{78A7E126-D1B9-40BD-AAC7-E327BCA292AF}"/>
               </a:ext>
             </a:extLst>
           </p:cNvPr>
@@ -5565,8 +5907,37 @@
         </p:nvSpPr>
         <p:spPr>
           <a:xfrm>
-            <a:off x="685800" y="5467350"/>
-            <a:ext cx="10820400" cy="304800"/>
+            <a:off x="685800" y="5400675"/>
+            <a:ext cx="6858000" cy="0"/>
+          </a:xfrm>
+          <a:prstGeom prst="line">
+            <a:avLst/>
+          </a:prstGeom>
+          <a:ln w="9525">
+            <a:solidFill>
+              <a:srgbClr val="CFD8D1"/>
+            </a:solidFill>
+          </a:ln>
+        </p:spPr>
+      </p:sp>
+      <p:sp>
+        <p:nvSpPr>
+          <p:cNvPr id="15" name="S04-stage1">
+            <a:extLst>
+              <a:ext uri="{FF2B5EF4-FFF2-40B4-BE49-F238E27FC236}">
+                <a16:creationId xmlns:a16="http://schemas.microsoft.com/office/drawing/2014/main" id="{DF1D5DC6-3B5E-4F74-9EEE-E3219DA70966}"/>
+              </a:ext>
+            </a:extLst>
+          </p:cNvPr>
+          <p:cNvSpPr>
+            <a:spLocks noGrp="1"/>
+          </p:cNvSpPr>
+          <p:nvPr/>
+        </p:nvSpPr>
+        <p:spPr>
+          <a:xfrm>
+            <a:off x="685800" y="5505450"/>
+            <a:ext cx="6858000" cy="304800"/>
           </a:xfrm>
           <a:prstGeom prst="rect">
             <a:avLst/>
@@ -5608,10 +5979,10 @@
       </p:sp>
       <p:sp>
         <p:nvSpPr>
-          <p:cNvPr id="14" name="S04-stage2">
+          <p:cNvPr id="16" name="S04-stage2">
             <a:extLst>
               <a:ext uri="{FF2B5EF4-FFF2-40B4-BE49-F238E27FC236}">
-                <a16:creationId xmlns:a16="http://schemas.microsoft.com/office/drawing/2014/main" id="{9DF67ADF-61F2-4493-9546-47594572DCEA}"/>
+                <a16:creationId xmlns:a16="http://schemas.microsoft.com/office/drawing/2014/main" id="{BD2D646E-0CEF-4328-A558-D244B4964EB7}"/>
               </a:ext>
             </a:extLst>
           </p:cNvPr>
@@ -5622,8 +5993,8 @@
         </p:nvSpPr>
         <p:spPr>
           <a:xfrm>
-            <a:off x="685800" y="5810250"/>
-            <a:ext cx="10820400" cy="304800"/>
+            <a:off x="685800" y="5857875"/>
+            <a:ext cx="6858000" cy="304800"/>
           </a:xfrm>
           <a:prstGeom prst="rect">
             <a:avLst/>
@@ -5666,7 +6037,7 @@
     </p:spTree>
     <p:extLst>
       <p:ext uri="{BB962C8B-B14F-4D97-AF65-F5344CB8AC3E}">
-        <p14:creationId xmlns:p14="http://schemas.microsoft.com/office/powerpoint/2010/main" val="44023269"/>
+        <p14:creationId xmlns:p14="http://schemas.microsoft.com/office/powerpoint/2010/main" val="1937587754"/>
       </p:ext>
     </p:extLst>
   </p:cSld>
@@ -5703,10 +6074,10 @@
       </p:grpSpPr>
       <p:sp>
         <p:nvSpPr>
-          <p:cNvPr id="14" name="S05-title">
+          <p:cNvPr id="14" name="S05-finding-field">
             <a:extLst>
               <a:ext uri="{FF2B5EF4-FFF2-40B4-BE49-F238E27FC236}">
-                <a16:creationId xmlns:a16="http://schemas.microsoft.com/office/drawing/2014/main" id="{4737C698-4CD5-45D5-A0F0-08B9F4769C2A}"/>
+                <a16:creationId xmlns:a16="http://schemas.microsoft.com/office/drawing/2014/main" id="{0ED6B1DB-9D9C-43A6-A827-E4A5AC5844C7}"/>
               </a:ext>
             </a:extLst>
           </p:cNvPr>
@@ -5717,8 +6088,38 @@
         </p:nvSpPr>
         <p:spPr>
           <a:xfrm>
-            <a:off x="685800" y="895350"/>
-            <a:ext cx="10820400" cy="666750"/>
+            <a:off x="0" y="0"/>
+            <a:ext cx="5905500" cy="6858000"/>
+          </a:xfrm>
+          <a:prstGeom prst="rect">
+            <a:avLst/>
+          </a:prstGeom>
+          <a:solidFill>
+            <a:srgbClr val="1E302F"/>
+          </a:solidFill>
+          <a:ln w="0">
+            <a:noFill/>
+          </a:ln>
+        </p:spPr>
+      </p:sp>
+      <p:sp>
+        <p:nvSpPr>
+          <p:cNvPr id="2" name="S05-main">
+            <a:extLst>
+              <a:ext uri="{FF2B5EF4-FFF2-40B4-BE49-F238E27FC236}">
+                <a16:creationId xmlns:a16="http://schemas.microsoft.com/office/drawing/2014/main" id="{3F25CD10-6CC4-4C22-844B-B03D009A1D0C}"/>
+              </a:ext>
+            </a:extLst>
+          </p:cNvPr>
+          <p:cNvSpPr>
+            <a:spLocks noGrp="1"/>
+          </p:cNvSpPr>
+          <p:nvPr/>
+        </p:nvSpPr>
+        <p:spPr>
+          <a:xfrm>
+            <a:off x="609600" y="1428750"/>
+            <a:ext cx="4781550" cy="1619250"/>
           </a:xfrm>
           <a:prstGeom prst="rect">
             <a:avLst/>
@@ -5735,9 +6136,9 @@
           <a:lstStyle/>
           <a:p>
             <a:pPr>
-              <a:defRPr sz="3000" b="0">
-                <a:solidFill>
-                  <a:srgbClr val="1E302F"/>
+              <a:defRPr sz="3600" b="0">
+                <a:solidFill>
+                  <a:srgbClr val="FFFFFF"/>
                 </a:solidFill>
                 <a:latin typeface="Noto Sans KR"/>
                 <a:ea typeface="Noto Sans KR"/>
@@ -5745,25 +6146,48 @@
               </a:defRPr>
             </a:pPr>
             <a:r>
-              <a:rPr sz="3000" b="0">
-                <a:solidFill>
-                  <a:srgbClr val="1E302F"/>
+              <a:rPr sz="3600" b="0">
+                <a:solidFill>
+                  <a:srgbClr val="FFFFFF"/>
                 </a:solidFill>
                 <a:latin typeface="Noto Sans KR"/>
                 <a:ea typeface="Noto Sans KR"/>
                 <a:cs typeface="Noto Sans KR"/>
               </a:rPr>
-              <a:t>배포 기준을 먼저 정해야 합니다</a:t>
+              <a:t>효율 개선에는</a:t>
             </a:r>
           </a:p>
-        </p:txBody>
-      </p:sp>
-      <p:sp>
-        <p:nvSpPr>
-          <p:cNvPr id="2" name="S05-disclosure">
+          <a:p>
+            <a:pPr>
+              <a:defRPr sz="3600" b="0">
+                <a:solidFill>
+                  <a:srgbClr val="FFFFFF"/>
+                </a:solidFill>
+                <a:latin typeface="Noto Sans KR"/>
+                <a:ea typeface="Noto Sans KR"/>
+                <a:cs typeface="Noto Sans KR"/>
+              </a:defRPr>
+            </a:pPr>
+            <a:r>
+              <a:rPr sz="3600" b="0">
+                <a:solidFill>
+                  <a:srgbClr val="FFFFFF"/>
+                </a:solidFill>
+                <a:latin typeface="Noto Sans KR"/>
+                <a:ea typeface="Noto Sans KR"/>
+                <a:cs typeface="Noto Sans KR"/>
+              </a:rPr>
+              <a:t>F1 저하가 따릅니다</a:t>
+            </a:r>
+          </a:p>
+        </p:txBody>
+      </p:sp>
+      <p:sp>
+        <p:nvSpPr>
+          <p:cNvPr id="3" name="S05-interpretation">
             <a:extLst>
               <a:ext uri="{FF2B5EF4-FFF2-40B4-BE49-F238E27FC236}">
-                <a16:creationId xmlns:a16="http://schemas.microsoft.com/office/drawing/2014/main" id="{42639841-CE3F-42F4-949D-BF2F8033C43C}"/>
+                <a16:creationId xmlns:a16="http://schemas.microsoft.com/office/drawing/2014/main" id="{D5FE73C6-67DD-4B77-AD2D-9CFC8A8B50AB}"/>
               </a:ext>
             </a:extLst>
           </p:cNvPr>
@@ -5774,8 +6198,8 @@
         </p:nvSpPr>
         <p:spPr>
           <a:xfrm>
-            <a:off x="685800" y="6372225"/>
-            <a:ext cx="9525000" cy="219075"/>
+            <a:off x="609600" y="3695700"/>
+            <a:ext cx="4762500" cy="1104900"/>
           </a:xfrm>
           <a:prstGeom prst="rect">
             <a:avLst/>
@@ -5792,9 +6216,569 @@
           <a:lstStyle/>
           <a:p>
             <a:pPr>
+              <a:defRPr sz="2025" b="0">
+                <a:solidFill>
+                  <a:srgbClr val="B9DDD0"/>
+                </a:solidFill>
+                <a:latin typeface="Noto Sans KR"/>
+                <a:ea typeface="Noto Sans KR"/>
+                <a:cs typeface="Noto Sans KR"/>
+              </a:defRPr>
+            </a:pPr>
+            <a:r>
+              <a:rPr sz="2025" b="0">
+                <a:solidFill>
+                  <a:srgbClr val="B9DDD0"/>
+                </a:solidFill>
+                <a:latin typeface="Noto Sans KR"/>
+                <a:ea typeface="Noto Sans KR"/>
+                <a:cs typeface="Noto Sans KR"/>
+              </a:rPr>
+              <a:t>허용 가능한 F1 저하와</a:t>
+            </a:r>
+          </a:p>
+          <a:p>
+            <a:pPr>
+              <a:defRPr sz="2025" b="0">
+                <a:solidFill>
+                  <a:srgbClr val="B9DDD0"/>
+                </a:solidFill>
+                <a:latin typeface="Noto Sans KR"/>
+                <a:ea typeface="Noto Sans KR"/>
+                <a:cs typeface="Noto Sans KR"/>
+              </a:defRPr>
+            </a:pPr>
+            <a:r>
+              <a:rPr sz="2025" b="0">
+                <a:solidFill>
+                  <a:srgbClr val="B9DDD0"/>
+                </a:solidFill>
+                <a:latin typeface="Noto Sans KR"/>
+                <a:ea typeface="Noto Sans KR"/>
+                <a:cs typeface="Noto Sans KR"/>
+              </a:rPr>
+              <a:t>지연 한도를 먼저 정해야 합니다.</a:t>
+            </a:r>
+          </a:p>
+        </p:txBody>
+      </p:sp>
+      <p:sp>
+        <p:nvSpPr>
+          <p:cNvPr id="4" name="S05-label1">
+            <a:extLst>
+              <a:ext uri="{FF2B5EF4-FFF2-40B4-BE49-F238E27FC236}">
+                <a16:creationId xmlns:a16="http://schemas.microsoft.com/office/drawing/2014/main" id="{B625A3C0-7B40-4491-A71D-B365EE1AEBD4}"/>
+              </a:ext>
+            </a:extLst>
+          </p:cNvPr>
+          <p:cNvSpPr>
+            <a:spLocks noGrp="1"/>
+          </p:cNvSpPr>
+          <p:nvPr/>
+        </p:nvSpPr>
+        <p:spPr>
+          <a:xfrm>
+            <a:off x="6515100" y="1152525"/>
+            <a:ext cx="4991100" cy="466725"/>
+          </a:xfrm>
+          <a:prstGeom prst="rect">
+            <a:avLst/>
+          </a:prstGeom>
+          <a:noFill/>
+          <a:ln w="0">
+            <a:noFill/>
+          </a:ln>
+        </p:spPr>
+        <p:txBody>
+          <a:bodyPr wrap="none" lIns="0" tIns="0" rIns="0" bIns="0" anchor="ctr">
+            <a:noAutofit/>
+          </a:bodyPr>
+          <a:lstStyle/>
+          <a:p>
+            <a:pPr>
+              <a:defRPr sz="2325" b="0">
+                <a:solidFill>
+                  <a:srgbClr val="1E302F"/>
+                </a:solidFill>
+                <a:latin typeface="Noto Sans KR"/>
+                <a:ea typeface="Noto Sans KR"/>
+                <a:cs typeface="Noto Sans KR"/>
+              </a:defRPr>
+            </a:pPr>
+            <a:r>
+              <a:rPr sz="2325" b="0">
+                <a:solidFill>
+                  <a:srgbClr val="1E302F"/>
+                </a:solidFill>
+                <a:latin typeface="Noto Sans KR"/>
+                <a:ea typeface="Noto Sans KR"/>
+                <a:cs typeface="Noto Sans KR"/>
+              </a:rPr>
+              <a:t>배포 기준</a:t>
+            </a:r>
+          </a:p>
+        </p:txBody>
+      </p:sp>
+      <p:sp>
+        <p:nvSpPr>
+          <p:cNvPr id="5" name="S05-body1">
+            <a:extLst>
+              <a:ext uri="{FF2B5EF4-FFF2-40B4-BE49-F238E27FC236}">
+                <a16:creationId xmlns:a16="http://schemas.microsoft.com/office/drawing/2014/main" id="{96D4C030-EF27-4168-A4F6-206227A34148}"/>
+              </a:ext>
+            </a:extLst>
+          </p:cNvPr>
+          <p:cNvSpPr>
+            <a:spLocks noGrp="1"/>
+          </p:cNvSpPr>
+          <p:nvPr/>
+        </p:nvSpPr>
+        <p:spPr>
+          <a:xfrm>
+            <a:off x="6515100" y="1704975"/>
+            <a:ext cx="4991100" cy="457200"/>
+          </a:xfrm>
+          <a:prstGeom prst="rect">
+            <a:avLst/>
+          </a:prstGeom>
+          <a:noFill/>
+          <a:ln w="0">
+            <a:noFill/>
+          </a:ln>
+        </p:spPr>
+        <p:txBody>
+          <a:bodyPr wrap="none" lIns="0" tIns="0" rIns="0" bIns="0" anchor="ctr">
+            <a:noAutofit/>
+          </a:bodyPr>
+          <a:lstStyle/>
+          <a:p>
+            <a:pPr>
+              <a:defRPr sz="1800" b="0">
+                <a:solidFill>
+                  <a:srgbClr val="586C68"/>
+                </a:solidFill>
+                <a:latin typeface="Noto Sans KR"/>
+                <a:ea typeface="Noto Sans KR"/>
+                <a:cs typeface="Noto Sans KR"/>
+              </a:defRPr>
+            </a:pPr>
+            <a:r>
+              <a:rPr sz="1800" b="0">
+                <a:solidFill>
+                  <a:srgbClr val="586C68"/>
+                </a:solidFill>
+                <a:latin typeface="Noto Sans KR"/>
+                <a:ea typeface="Noto Sans KR"/>
+                <a:cs typeface="Noto Sans KR"/>
+              </a:rPr>
+              <a:t>허용할 F1 저하와 지연 한도</a:t>
+            </a:r>
+          </a:p>
+        </p:txBody>
+      </p:sp>
+      <p:sp>
+        <p:nvSpPr>
+          <p:cNvPr id="6" name="S05-rule-1">
+            <a:extLst>
+              <a:ext uri="{FF2B5EF4-FFF2-40B4-BE49-F238E27FC236}">
+                <a16:creationId xmlns:a16="http://schemas.microsoft.com/office/drawing/2014/main" id="{C0F1DA74-3D48-474E-9D98-35AAA1904F1E}"/>
+              </a:ext>
+            </a:extLst>
+          </p:cNvPr>
+          <p:cNvSpPr>
+            <a:spLocks noGrp="1"/>
+          </p:cNvSpPr>
+          <p:nvPr/>
+        </p:nvSpPr>
+        <p:spPr>
+          <a:xfrm>
+            <a:off x="6515100" y="2276475"/>
+            <a:ext cx="4991100" cy="0"/>
+          </a:xfrm>
+          <a:prstGeom prst="line">
+            <a:avLst/>
+          </a:prstGeom>
+          <a:ln w="9525">
+            <a:solidFill>
+              <a:srgbClr val="CFD8D1"/>
+            </a:solidFill>
+          </a:ln>
+        </p:spPr>
+      </p:sp>
+      <p:sp>
+        <p:nvSpPr>
+          <p:cNvPr id="7" name="S05-label2">
+            <a:extLst>
+              <a:ext uri="{FF2B5EF4-FFF2-40B4-BE49-F238E27FC236}">
+                <a16:creationId xmlns:a16="http://schemas.microsoft.com/office/drawing/2014/main" id="{9ACCA409-2EA2-469A-B367-574DA5AE3EE5}"/>
+              </a:ext>
+            </a:extLst>
+          </p:cNvPr>
+          <p:cNvSpPr>
+            <a:spLocks noGrp="1"/>
+          </p:cNvSpPr>
+          <p:nvPr/>
+        </p:nvSpPr>
+        <p:spPr>
+          <a:xfrm>
+            <a:off x="6515100" y="2438400"/>
+            <a:ext cx="4991100" cy="466725"/>
+          </a:xfrm>
+          <a:prstGeom prst="rect">
+            <a:avLst/>
+          </a:prstGeom>
+          <a:noFill/>
+          <a:ln w="0">
+            <a:noFill/>
+          </a:ln>
+        </p:spPr>
+        <p:txBody>
+          <a:bodyPr wrap="none" lIns="0" tIns="0" rIns="0" bIns="0" anchor="ctr">
+            <a:noAutofit/>
+          </a:bodyPr>
+          <a:lstStyle/>
+          <a:p>
+            <a:pPr>
+              <a:defRPr sz="2325" b="0">
+                <a:solidFill>
+                  <a:srgbClr val="1E302F"/>
+                </a:solidFill>
+                <a:latin typeface="Noto Sans KR"/>
+                <a:ea typeface="Noto Sans KR"/>
+                <a:cs typeface="Noto Sans KR"/>
+              </a:defRPr>
+            </a:pPr>
+            <a:r>
+              <a:rPr sz="2325" b="0">
+                <a:solidFill>
+                  <a:srgbClr val="1E302F"/>
+                </a:solidFill>
+                <a:latin typeface="Noto Sans KR"/>
+                <a:ea typeface="Noto Sans KR"/>
+                <a:cs typeface="Noto Sans KR"/>
+              </a:rPr>
+              <a:t>측정 신뢰도</a:t>
+            </a:r>
+          </a:p>
+        </p:txBody>
+      </p:sp>
+      <p:sp>
+        <p:nvSpPr>
+          <p:cNvPr id="8" name="S05-body2">
+            <a:extLst>
+              <a:ext uri="{FF2B5EF4-FFF2-40B4-BE49-F238E27FC236}">
+                <a16:creationId xmlns:a16="http://schemas.microsoft.com/office/drawing/2014/main" id="{CDFCC17F-4966-4B9A-836D-A60CA1592AED}"/>
+              </a:ext>
+            </a:extLst>
+          </p:cNvPr>
+          <p:cNvSpPr>
+            <a:spLocks noGrp="1"/>
+          </p:cNvSpPr>
+          <p:nvPr/>
+        </p:nvSpPr>
+        <p:spPr>
+          <a:xfrm>
+            <a:off x="6515100" y="2990850"/>
+            <a:ext cx="4991100" cy="457200"/>
+          </a:xfrm>
+          <a:prstGeom prst="rect">
+            <a:avLst/>
+          </a:prstGeom>
+          <a:noFill/>
+          <a:ln w="0">
+            <a:noFill/>
+          </a:ln>
+        </p:spPr>
+        <p:txBody>
+          <a:bodyPr wrap="none" lIns="0" tIns="0" rIns="0" bIns="0" anchor="ctr">
+            <a:noAutofit/>
+          </a:bodyPr>
+          <a:lstStyle/>
+          <a:p>
+            <a:pPr>
+              <a:defRPr sz="1800" b="0">
+                <a:solidFill>
+                  <a:srgbClr val="586C68"/>
+                </a:solidFill>
+                <a:latin typeface="Noto Sans KR"/>
+                <a:ea typeface="Noto Sans KR"/>
+                <a:cs typeface="Noto Sans KR"/>
+              </a:defRPr>
+            </a:pPr>
+            <a:r>
+              <a:rPr sz="1800" b="0">
+                <a:solidFill>
+                  <a:srgbClr val="586C68"/>
+                </a:solidFill>
+                <a:latin typeface="Noto Sans KR"/>
+                <a:ea typeface="Noto Sans KR"/>
+                <a:cs typeface="Noto Sans KR"/>
+              </a:rPr>
+              <a:t>실제 데이터에서 반복 측정</a:t>
+            </a:r>
+          </a:p>
+        </p:txBody>
+      </p:sp>
+      <p:sp>
+        <p:nvSpPr>
+          <p:cNvPr id="9" name="S05-rule-2">
+            <a:extLst>
+              <a:ext uri="{FF2B5EF4-FFF2-40B4-BE49-F238E27FC236}">
+                <a16:creationId xmlns:a16="http://schemas.microsoft.com/office/drawing/2014/main" id="{87F7A805-B1DE-4D32-8DF1-167BA6C38117}"/>
+              </a:ext>
+            </a:extLst>
+          </p:cNvPr>
+          <p:cNvSpPr>
+            <a:spLocks noGrp="1"/>
+          </p:cNvSpPr>
+          <p:nvPr/>
+        </p:nvSpPr>
+        <p:spPr>
+          <a:xfrm>
+            <a:off x="6515100" y="3562350"/>
+            <a:ext cx="4991100" cy="0"/>
+          </a:xfrm>
+          <a:prstGeom prst="line">
+            <a:avLst/>
+          </a:prstGeom>
+          <a:ln w="9525">
+            <a:solidFill>
+              <a:srgbClr val="CFD8D1"/>
+            </a:solidFill>
+          </a:ln>
+        </p:spPr>
+      </p:sp>
+      <p:sp>
+        <p:nvSpPr>
+          <p:cNvPr id="10" name="S05-label3">
+            <a:extLst>
+              <a:ext uri="{FF2B5EF4-FFF2-40B4-BE49-F238E27FC236}">
+                <a16:creationId xmlns:a16="http://schemas.microsoft.com/office/drawing/2014/main" id="{63137E54-EFC8-4891-8B2F-3BE5F8A64F7C}"/>
+              </a:ext>
+            </a:extLst>
+          </p:cNvPr>
+          <p:cNvSpPr>
+            <a:spLocks noGrp="1"/>
+          </p:cNvSpPr>
+          <p:nvPr/>
+        </p:nvSpPr>
+        <p:spPr>
+          <a:xfrm>
+            <a:off x="6515100" y="3724275"/>
+            <a:ext cx="4991100" cy="466725"/>
+          </a:xfrm>
+          <a:prstGeom prst="rect">
+            <a:avLst/>
+          </a:prstGeom>
+          <a:noFill/>
+          <a:ln w="0">
+            <a:noFill/>
+          </a:ln>
+        </p:spPr>
+        <p:txBody>
+          <a:bodyPr wrap="none" lIns="0" tIns="0" rIns="0" bIns="0" anchor="ctr">
+            <a:noAutofit/>
+          </a:bodyPr>
+          <a:lstStyle/>
+          <a:p>
+            <a:pPr>
+              <a:defRPr sz="2325" b="0">
+                <a:solidFill>
+                  <a:srgbClr val="1E302F"/>
+                </a:solidFill>
+                <a:latin typeface="Noto Sans KR"/>
+                <a:ea typeface="Noto Sans KR"/>
+                <a:cs typeface="Noto Sans KR"/>
+              </a:defRPr>
+            </a:pPr>
+            <a:r>
+              <a:rPr sz="2325" b="0">
+                <a:solidFill>
+                  <a:srgbClr val="1E302F"/>
+                </a:solidFill>
+                <a:latin typeface="Noto Sans KR"/>
+                <a:ea typeface="Noto Sans KR"/>
+                <a:cs typeface="Noto Sans KR"/>
+              </a:rPr>
+              <a:t>실패 유형</a:t>
+            </a:r>
+          </a:p>
+        </p:txBody>
+      </p:sp>
+      <p:sp>
+        <p:nvSpPr>
+          <p:cNvPr id="11" name="S05-body3">
+            <a:extLst>
+              <a:ext uri="{FF2B5EF4-FFF2-40B4-BE49-F238E27FC236}">
+                <a16:creationId xmlns:a16="http://schemas.microsoft.com/office/drawing/2014/main" id="{CC70882B-1221-4F7B-80C3-7C5F0E3596A2}"/>
+              </a:ext>
+            </a:extLst>
+          </p:cNvPr>
+          <p:cNvSpPr>
+            <a:spLocks noGrp="1"/>
+          </p:cNvSpPr>
+          <p:nvPr/>
+        </p:nvSpPr>
+        <p:spPr>
+          <a:xfrm>
+            <a:off x="6515100" y="4276725"/>
+            <a:ext cx="4991100" cy="457200"/>
+          </a:xfrm>
+          <a:prstGeom prst="rect">
+            <a:avLst/>
+          </a:prstGeom>
+          <a:noFill/>
+          <a:ln w="0">
+            <a:noFill/>
+          </a:ln>
+        </p:spPr>
+        <p:txBody>
+          <a:bodyPr wrap="none" lIns="0" tIns="0" rIns="0" bIns="0" anchor="ctr">
+            <a:noAutofit/>
+          </a:bodyPr>
+          <a:lstStyle/>
+          <a:p>
+            <a:pPr>
+              <a:defRPr sz="1800" b="0">
+                <a:solidFill>
+                  <a:srgbClr val="586C68"/>
+                </a:solidFill>
+                <a:latin typeface="Noto Sans KR"/>
+                <a:ea typeface="Noto Sans KR"/>
+                <a:cs typeface="Noto Sans KR"/>
+              </a:defRPr>
+            </a:pPr>
+            <a:r>
+              <a:rPr sz="1800" b="0">
+                <a:solidFill>
+                  <a:srgbClr val="586C68"/>
+                </a:solidFill>
+                <a:latin typeface="Noto Sans KR"/>
+                <a:ea typeface="Noto Sans KR"/>
+                <a:cs typeface="Noto Sans KR"/>
+              </a:rPr>
+              <a:t>이상 유형별 오탐과 누락 확인</a:t>
+            </a:r>
+          </a:p>
+        </p:txBody>
+      </p:sp>
+      <p:sp>
+        <p:nvSpPr>
+          <p:cNvPr id="12" name="S05-limit">
+            <a:extLst>
+              <a:ext uri="{FF2B5EF4-FFF2-40B4-BE49-F238E27FC236}">
+                <a16:creationId xmlns:a16="http://schemas.microsoft.com/office/drawing/2014/main" id="{2C4079A9-A86E-4BD1-8398-6960655B9426}"/>
+              </a:ext>
+            </a:extLst>
+          </p:cNvPr>
+          <p:cNvSpPr>
+            <a:spLocks noGrp="1"/>
+          </p:cNvSpPr>
+          <p:nvPr/>
+        </p:nvSpPr>
+        <p:spPr>
+          <a:xfrm>
+            <a:off x="6515100" y="5448300"/>
+            <a:ext cx="4991100" cy="723900"/>
+          </a:xfrm>
+          <a:prstGeom prst="rect">
+            <a:avLst/>
+          </a:prstGeom>
+          <a:noFill/>
+          <a:ln w="0">
+            <a:noFill/>
+          </a:ln>
+        </p:spPr>
+        <p:txBody>
+          <a:bodyPr wrap="none" lIns="0" tIns="0" rIns="0" bIns="0" anchor="ctr">
+            <a:noAutofit/>
+          </a:bodyPr>
+          <a:lstStyle/>
+          <a:p>
+            <a:pPr>
+              <a:defRPr sz="1650" b="0">
+                <a:solidFill>
+                  <a:srgbClr val="586C68"/>
+                </a:solidFill>
+                <a:latin typeface="Noto Sans KR"/>
+                <a:ea typeface="Noto Sans KR"/>
+                <a:cs typeface="Noto Sans KR"/>
+              </a:defRPr>
+            </a:pPr>
+            <a:r>
+              <a:rPr sz="1650" b="0">
+                <a:solidFill>
+                  <a:srgbClr val="586C68"/>
+                </a:solidFill>
+                <a:latin typeface="Noto Sans KR"/>
+                <a:ea typeface="Noto Sans KR"/>
+                <a:cs typeface="Noto Sans KR"/>
+              </a:rPr>
+              <a:t>실제 데이터셋·표본수가 없어</a:t>
+            </a:r>
+          </a:p>
+          <a:p>
+            <a:pPr>
+              <a:defRPr sz="1650" b="0">
+                <a:solidFill>
+                  <a:srgbClr val="586C68"/>
+                </a:solidFill>
+                <a:latin typeface="Noto Sans KR"/>
+                <a:ea typeface="Noto Sans KR"/>
+                <a:cs typeface="Noto Sans KR"/>
+              </a:defRPr>
+            </a:pPr>
+            <a:r>
+              <a:rPr sz="1650" b="0">
+                <a:solidFill>
+                  <a:srgbClr val="586C68"/>
+                </a:solidFill>
+                <a:latin typeface="Noto Sans KR"/>
+                <a:ea typeface="Noto Sans KR"/>
+                <a:cs typeface="Noto Sans KR"/>
+              </a:rPr>
+              <a:t>일반화 여부는 확인할 수 없습니다.</a:t>
+            </a:r>
+          </a:p>
+        </p:txBody>
+      </p:sp>
+      <p:sp>
+        <p:nvSpPr>
+          <p:cNvPr id="13" name="S05-disclosure">
+            <a:extLst>
+              <a:ext uri="{FF2B5EF4-FFF2-40B4-BE49-F238E27FC236}">
+                <a16:creationId xmlns:a16="http://schemas.microsoft.com/office/drawing/2014/main" id="{C696A0B6-2120-4791-A822-6B4057645033}"/>
+              </a:ext>
+            </a:extLst>
+          </p:cNvPr>
+          <p:cNvSpPr>
+            <a:spLocks noGrp="1"/>
+          </p:cNvSpPr>
+          <p:nvPr/>
+        </p:nvSpPr>
+        <p:spPr>
+          <a:xfrm>
+            <a:off x="609600" y="6372225"/>
+            <a:ext cx="4572000" cy="219075"/>
+          </a:xfrm>
+          <a:prstGeom prst="rect">
+            <a:avLst/>
+          </a:prstGeom>
+          <a:noFill/>
+          <a:ln w="0">
+            <a:noFill/>
+          </a:ln>
+        </p:spPr>
+        <p:txBody>
+          <a:bodyPr wrap="none" lIns="0" tIns="0" rIns="0" bIns="0" anchor="ctr">
+            <a:noAutofit/>
+          </a:bodyPr>
+          <a:lstStyle/>
+          <a:p>
+            <a:pPr>
               <a:defRPr sz="1275" b="0">
                 <a:solidFill>
-                  <a:srgbClr val="586C68"/>
+                  <a:srgbClr val="B9DDD0"/>
                 </a:solidFill>
                 <a:latin typeface="Noto Sans KR"/>
                 <a:ea typeface="Noto Sans KR"/>
@@ -5804,556 +6788,13 @@
             <a:r>
               <a:rPr sz="1275" b="0">
                 <a:solidFill>
-                  <a:srgbClr val="586C68"/>
+                  <a:srgbClr val="B9DDD0"/>
                 </a:solidFill>
                 <a:latin typeface="Noto Sans KR"/>
                 <a:ea typeface="Noto Sans KR"/>
                 <a:cs typeface="Noto Sans KR"/>
               </a:rPr>
-              <a:t>가상 데이터 · 실제 실험 결과가 아닙니다</a:t>
-            </a:r>
-          </a:p>
-        </p:txBody>
-      </p:sp>
-      <p:sp>
-        <p:nvSpPr>
-          <p:cNvPr id="3" name="S05-number">
-            <a:extLst>
-              <a:ext uri="{FF2B5EF4-FFF2-40B4-BE49-F238E27FC236}">
-                <a16:creationId xmlns:a16="http://schemas.microsoft.com/office/drawing/2014/main" id="{7F9FAA97-72BE-4A4E-B53B-2FCD5772A653}"/>
-              </a:ext>
-            </a:extLst>
-          </p:cNvPr>
-          <p:cNvSpPr>
-            <a:spLocks noGrp="1"/>
-          </p:cNvSpPr>
-          <p:nvPr/>
-        </p:nvSpPr>
-        <p:spPr>
-          <a:xfrm>
-            <a:off x="11144250" y="6372225"/>
-            <a:ext cx="361950" cy="219075"/>
-          </a:xfrm>
-          <a:prstGeom prst="rect">
-            <a:avLst/>
-          </a:prstGeom>
-          <a:noFill/>
-          <a:ln w="0">
-            <a:noFill/>
-          </a:ln>
-        </p:spPr>
-        <p:txBody>
-          <a:bodyPr wrap="none" lIns="0" tIns="0" rIns="0" bIns="0" anchor="ctr">
-            <a:noAutofit/>
-          </a:bodyPr>
-          <a:lstStyle/>
-          <a:p>
-            <a:pPr>
-              <a:defRPr sz="1275" b="0">
-                <a:solidFill>
-                  <a:srgbClr val="586C68"/>
-                </a:solidFill>
-                <a:latin typeface="Noto Sans KR"/>
-                <a:ea typeface="Noto Sans KR"/>
-                <a:cs typeface="Noto Sans KR"/>
-              </a:defRPr>
-            </a:pPr>
-            <a:r>
-              <a:rPr sz="1275" b="0">
-                <a:solidFill>
-                  <a:srgbClr val="586C68"/>
-                </a:solidFill>
-                <a:latin typeface="Noto Sans KR"/>
-                <a:ea typeface="Noto Sans KR"/>
-                <a:cs typeface="Noto Sans KR"/>
-              </a:rPr>
-              <a:t>05</a:t>
-            </a:r>
-          </a:p>
-        </p:txBody>
-      </p:sp>
-      <p:sp>
-        <p:nvSpPr>
-          <p:cNvPr id="4" name="S05-main">
-            <a:extLst>
-              <a:ext uri="{FF2B5EF4-FFF2-40B4-BE49-F238E27FC236}">
-                <a16:creationId xmlns:a16="http://schemas.microsoft.com/office/drawing/2014/main" id="{DC2100DC-2E95-4332-B2A6-3029477C105A}"/>
-              </a:ext>
-            </a:extLst>
-          </p:cNvPr>
-          <p:cNvSpPr>
-            <a:spLocks noGrp="1"/>
-          </p:cNvSpPr>
-          <p:nvPr/>
-        </p:nvSpPr>
-        <p:spPr>
-          <a:xfrm>
-            <a:off x="685800" y="1990725"/>
-            <a:ext cx="10820400" cy="723900"/>
-          </a:xfrm>
-          <a:prstGeom prst="rect">
-            <a:avLst/>
-          </a:prstGeom>
-          <a:noFill/>
-          <a:ln w="0">
-            <a:noFill/>
-          </a:ln>
-        </p:spPr>
-        <p:txBody>
-          <a:bodyPr wrap="none" lIns="0" tIns="0" rIns="0" bIns="0" anchor="ctr">
-            <a:noAutofit/>
-          </a:bodyPr>
-          <a:lstStyle/>
-          <a:p>
-            <a:pPr>
-              <a:defRPr sz="3450" b="0">
-                <a:solidFill>
-                  <a:srgbClr val="287D78"/>
-                </a:solidFill>
-                <a:latin typeface="Noto Sans KR"/>
-                <a:ea typeface="Noto Sans KR"/>
-                <a:cs typeface="Noto Sans KR"/>
-              </a:defRPr>
-            </a:pPr>
-            <a:r>
-              <a:rPr sz="3450" b="0">
-                <a:solidFill>
-                  <a:srgbClr val="287D78"/>
-                </a:solidFill>
-                <a:latin typeface="Noto Sans KR"/>
-                <a:ea typeface="Noto Sans KR"/>
-                <a:cs typeface="Noto Sans KR"/>
-              </a:rPr>
-              <a:t>효율 개선에는 F1 저하가 따릅니다</a:t>
-            </a:r>
-          </a:p>
-        </p:txBody>
-      </p:sp>
-      <p:sp>
-        <p:nvSpPr>
-          <p:cNvPr id="5" name="S05-rule-1">
-            <a:extLst>
-              <a:ext uri="{FF2B5EF4-FFF2-40B4-BE49-F238E27FC236}">
-                <a16:creationId xmlns:a16="http://schemas.microsoft.com/office/drawing/2014/main" id="{E698A027-85A2-4EA9-BF8A-7E2544EAEFF4}"/>
-              </a:ext>
-            </a:extLst>
-          </p:cNvPr>
-          <p:cNvSpPr>
-            <a:spLocks noGrp="1"/>
-          </p:cNvSpPr>
-          <p:nvPr/>
-        </p:nvSpPr>
-        <p:spPr>
-          <a:xfrm>
-            <a:off x="685800" y="3124200"/>
-            <a:ext cx="10820400" cy="0"/>
-          </a:xfrm>
-          <a:prstGeom prst="line">
-            <a:avLst/>
-          </a:prstGeom>
-          <a:ln w="9525">
-            <a:solidFill>
-              <a:srgbClr val="CFD8D1"/>
-            </a:solidFill>
-          </a:ln>
-        </p:spPr>
-      </p:sp>
-      <p:sp>
-        <p:nvSpPr>
-          <p:cNvPr id="6" name="S05-label1">
-            <a:extLst>
-              <a:ext uri="{FF2B5EF4-FFF2-40B4-BE49-F238E27FC236}">
-                <a16:creationId xmlns:a16="http://schemas.microsoft.com/office/drawing/2014/main" id="{9D6977D7-6C65-42C3-9741-CB1C7DDDB054}"/>
-              </a:ext>
-            </a:extLst>
-          </p:cNvPr>
-          <p:cNvSpPr>
-            <a:spLocks noGrp="1"/>
-          </p:cNvSpPr>
-          <p:nvPr/>
-        </p:nvSpPr>
-        <p:spPr>
-          <a:xfrm>
-            <a:off x="685800" y="3257550"/>
-            <a:ext cx="2914650" cy="495300"/>
-          </a:xfrm>
-          <a:prstGeom prst="rect">
-            <a:avLst/>
-          </a:prstGeom>
-          <a:noFill/>
-          <a:ln w="0">
-            <a:noFill/>
-          </a:ln>
-        </p:spPr>
-        <p:txBody>
-          <a:bodyPr wrap="none" lIns="0" tIns="0" rIns="0" bIns="0" anchor="ctr">
-            <a:noAutofit/>
-          </a:bodyPr>
-          <a:lstStyle/>
-          <a:p>
-            <a:pPr>
-              <a:defRPr sz="1950" b="0">
-                <a:solidFill>
-                  <a:srgbClr val="1E302F"/>
-                </a:solidFill>
-                <a:latin typeface="Noto Sans KR"/>
-                <a:ea typeface="Noto Sans KR"/>
-                <a:cs typeface="Noto Sans KR"/>
-              </a:defRPr>
-            </a:pPr>
-            <a:r>
-              <a:rPr sz="1950" b="0">
-                <a:solidFill>
-                  <a:srgbClr val="1E302F"/>
-                </a:solidFill>
-                <a:latin typeface="Noto Sans KR"/>
-                <a:ea typeface="Noto Sans KR"/>
-                <a:cs typeface="Noto Sans KR"/>
-              </a:rPr>
-              <a:t>먼저 정할 기준</a:t>
-            </a:r>
-          </a:p>
-        </p:txBody>
-      </p:sp>
-      <p:sp>
-        <p:nvSpPr>
-          <p:cNvPr id="7" name="S05-body1">
-            <a:extLst>
-              <a:ext uri="{FF2B5EF4-FFF2-40B4-BE49-F238E27FC236}">
-                <a16:creationId xmlns:a16="http://schemas.microsoft.com/office/drawing/2014/main" id="{89842C62-B6C5-48A9-B4F9-68744343FF74}"/>
-              </a:ext>
-            </a:extLst>
-          </p:cNvPr>
-          <p:cNvSpPr>
-            <a:spLocks noGrp="1"/>
-          </p:cNvSpPr>
-          <p:nvPr/>
-        </p:nvSpPr>
-        <p:spPr>
-          <a:xfrm>
-            <a:off x="3829050" y="3257550"/>
-            <a:ext cx="7677150" cy="495300"/>
-          </a:xfrm>
-          <a:prstGeom prst="rect">
-            <a:avLst/>
-          </a:prstGeom>
-          <a:noFill/>
-          <a:ln w="0">
-            <a:noFill/>
-          </a:ln>
-        </p:spPr>
-        <p:txBody>
-          <a:bodyPr wrap="none" lIns="0" tIns="0" rIns="0" bIns="0" anchor="ctr">
-            <a:noAutofit/>
-          </a:bodyPr>
-          <a:lstStyle/>
-          <a:p>
-            <a:pPr>
-              <a:defRPr sz="1950" b="0">
-                <a:solidFill>
-                  <a:srgbClr val="586C68"/>
-                </a:solidFill>
-                <a:latin typeface="Noto Sans KR"/>
-                <a:ea typeface="Noto Sans KR"/>
-                <a:cs typeface="Noto Sans KR"/>
-              </a:defRPr>
-            </a:pPr>
-            <a:r>
-              <a:rPr sz="1950" b="0">
-                <a:solidFill>
-                  <a:srgbClr val="586C68"/>
-                </a:solidFill>
-                <a:latin typeface="Noto Sans KR"/>
-                <a:ea typeface="Noto Sans KR"/>
-                <a:cs typeface="Noto Sans KR"/>
-              </a:rPr>
-              <a:t>허용 가능한 F1 저하와 지연 한도</a:t>
-            </a:r>
-          </a:p>
-        </p:txBody>
-      </p:sp>
-      <p:sp>
-        <p:nvSpPr>
-          <p:cNvPr id="8" name="S05-rule-2">
-            <a:extLst>
-              <a:ext uri="{FF2B5EF4-FFF2-40B4-BE49-F238E27FC236}">
-                <a16:creationId xmlns:a16="http://schemas.microsoft.com/office/drawing/2014/main" id="{50ED2E59-FBD9-49CE-A222-F071A2C1C335}"/>
-              </a:ext>
-            </a:extLst>
-          </p:cNvPr>
-          <p:cNvSpPr>
-            <a:spLocks noGrp="1"/>
-          </p:cNvSpPr>
-          <p:nvPr/>
-        </p:nvSpPr>
-        <p:spPr>
-          <a:xfrm>
-            <a:off x="685800" y="3962400"/>
-            <a:ext cx="10820400" cy="0"/>
-          </a:xfrm>
-          <a:prstGeom prst="line">
-            <a:avLst/>
-          </a:prstGeom>
-          <a:ln w="9525">
-            <a:solidFill>
-              <a:srgbClr val="CFD8D1"/>
-            </a:solidFill>
-          </a:ln>
-        </p:spPr>
-      </p:sp>
-      <p:sp>
-        <p:nvSpPr>
-          <p:cNvPr id="9" name="S05-label2">
-            <a:extLst>
-              <a:ext uri="{FF2B5EF4-FFF2-40B4-BE49-F238E27FC236}">
-                <a16:creationId xmlns:a16="http://schemas.microsoft.com/office/drawing/2014/main" id="{2E44F1E7-3F37-4F6D-9BA9-8A10DD3586F6}"/>
-              </a:ext>
-            </a:extLst>
-          </p:cNvPr>
-          <p:cNvSpPr>
-            <a:spLocks noGrp="1"/>
-          </p:cNvSpPr>
-          <p:nvPr/>
-        </p:nvSpPr>
-        <p:spPr>
-          <a:xfrm>
-            <a:off x="685800" y="4095750"/>
-            <a:ext cx="2914650" cy="495300"/>
-          </a:xfrm>
-          <a:prstGeom prst="rect">
-            <a:avLst/>
-          </a:prstGeom>
-          <a:noFill/>
-          <a:ln w="0">
-            <a:noFill/>
-          </a:ln>
-        </p:spPr>
-        <p:txBody>
-          <a:bodyPr wrap="none" lIns="0" tIns="0" rIns="0" bIns="0" anchor="ctr">
-            <a:noAutofit/>
-          </a:bodyPr>
-          <a:lstStyle/>
-          <a:p>
-            <a:pPr>
-              <a:defRPr sz="1950" b="0">
-                <a:solidFill>
-                  <a:srgbClr val="1E302F"/>
-                </a:solidFill>
-                <a:latin typeface="Noto Sans KR"/>
-                <a:ea typeface="Noto Sans KR"/>
-                <a:cs typeface="Noto Sans KR"/>
-              </a:defRPr>
-            </a:pPr>
-            <a:r>
-              <a:rPr sz="1950" b="0">
-                <a:solidFill>
-                  <a:srgbClr val="1E302F"/>
-                </a:solidFill>
-                <a:latin typeface="Noto Sans KR"/>
-                <a:ea typeface="Noto Sans KR"/>
-                <a:cs typeface="Noto Sans KR"/>
-              </a:rPr>
-              <a:t>다음 검증</a:t>
-            </a:r>
-          </a:p>
-        </p:txBody>
-      </p:sp>
-      <p:sp>
-        <p:nvSpPr>
-          <p:cNvPr id="10" name="S05-body2">
-            <a:extLst>
-              <a:ext uri="{FF2B5EF4-FFF2-40B4-BE49-F238E27FC236}">
-                <a16:creationId xmlns:a16="http://schemas.microsoft.com/office/drawing/2014/main" id="{605E1C97-5A36-412E-ABEA-A69DA6BB455C}"/>
-              </a:ext>
-            </a:extLst>
-          </p:cNvPr>
-          <p:cNvSpPr>
-            <a:spLocks noGrp="1"/>
-          </p:cNvSpPr>
-          <p:nvPr/>
-        </p:nvSpPr>
-        <p:spPr>
-          <a:xfrm>
-            <a:off x="3829050" y="4095750"/>
-            <a:ext cx="7677150" cy="495300"/>
-          </a:xfrm>
-          <a:prstGeom prst="rect">
-            <a:avLst/>
-          </a:prstGeom>
-          <a:noFill/>
-          <a:ln w="0">
-            <a:noFill/>
-          </a:ln>
-        </p:spPr>
-        <p:txBody>
-          <a:bodyPr wrap="none" lIns="0" tIns="0" rIns="0" bIns="0" anchor="ctr">
-            <a:noAutofit/>
-          </a:bodyPr>
-          <a:lstStyle/>
-          <a:p>
-            <a:pPr>
-              <a:defRPr sz="1950" b="0">
-                <a:solidFill>
-                  <a:srgbClr val="586C68"/>
-                </a:solidFill>
-                <a:latin typeface="Noto Sans KR"/>
-                <a:ea typeface="Noto Sans KR"/>
-                <a:cs typeface="Noto Sans KR"/>
-              </a:defRPr>
-            </a:pPr>
-            <a:r>
-              <a:rPr sz="1950" b="0">
-                <a:solidFill>
-                  <a:srgbClr val="586C68"/>
-                </a:solidFill>
-                <a:latin typeface="Noto Sans KR"/>
-                <a:ea typeface="Noto Sans KR"/>
-                <a:cs typeface="Noto Sans KR"/>
-              </a:rPr>
-              <a:t>반복 측정의 분산과 이상 유형별 실패 사례</a:t>
-            </a:r>
-          </a:p>
-        </p:txBody>
-      </p:sp>
-      <p:sp>
-        <p:nvSpPr>
-          <p:cNvPr id="11" name="S05-rule-3">
-            <a:extLst>
-              <a:ext uri="{FF2B5EF4-FFF2-40B4-BE49-F238E27FC236}">
-                <a16:creationId xmlns:a16="http://schemas.microsoft.com/office/drawing/2014/main" id="{ADD61140-B570-4E07-A12B-810D670CF658}"/>
-              </a:ext>
-            </a:extLst>
-          </p:cNvPr>
-          <p:cNvSpPr>
-            <a:spLocks noGrp="1"/>
-          </p:cNvSpPr>
-          <p:nvPr/>
-        </p:nvSpPr>
-        <p:spPr>
-          <a:xfrm>
-            <a:off x="685800" y="4800600"/>
-            <a:ext cx="10820400" cy="0"/>
-          </a:xfrm>
-          <a:prstGeom prst="line">
-            <a:avLst/>
-          </a:prstGeom>
-          <a:ln w="9525">
-            <a:solidFill>
-              <a:srgbClr val="CFD8D1"/>
-            </a:solidFill>
-          </a:ln>
-        </p:spPr>
-      </p:sp>
-      <p:sp>
-        <p:nvSpPr>
-          <p:cNvPr id="12" name="S05-label3">
-            <a:extLst>
-              <a:ext uri="{FF2B5EF4-FFF2-40B4-BE49-F238E27FC236}">
-                <a16:creationId xmlns:a16="http://schemas.microsoft.com/office/drawing/2014/main" id="{BE3AA318-48A1-4234-B7BE-05EFBFD78697}"/>
-              </a:ext>
-            </a:extLst>
-          </p:cNvPr>
-          <p:cNvSpPr>
-            <a:spLocks noGrp="1"/>
-          </p:cNvSpPr>
-          <p:nvPr/>
-        </p:nvSpPr>
-        <p:spPr>
-          <a:xfrm>
-            <a:off x="685800" y="4933950"/>
-            <a:ext cx="2914650" cy="495300"/>
-          </a:xfrm>
-          <a:prstGeom prst="rect">
-            <a:avLst/>
-          </a:prstGeom>
-          <a:noFill/>
-          <a:ln w="0">
-            <a:noFill/>
-          </a:ln>
-        </p:spPr>
-        <p:txBody>
-          <a:bodyPr wrap="none" lIns="0" tIns="0" rIns="0" bIns="0" anchor="ctr">
-            <a:noAutofit/>
-          </a:bodyPr>
-          <a:lstStyle/>
-          <a:p>
-            <a:pPr>
-              <a:defRPr sz="1950" b="0">
-                <a:solidFill>
-                  <a:srgbClr val="1E302F"/>
-                </a:solidFill>
-                <a:latin typeface="Noto Sans KR"/>
-                <a:ea typeface="Noto Sans KR"/>
-                <a:cs typeface="Noto Sans KR"/>
-              </a:defRPr>
-            </a:pPr>
-            <a:r>
-              <a:rPr sz="1950" b="0">
-                <a:solidFill>
-                  <a:srgbClr val="1E302F"/>
-                </a:solidFill>
-                <a:latin typeface="Noto Sans KR"/>
-                <a:ea typeface="Noto Sans KR"/>
-                <a:cs typeface="Noto Sans KR"/>
-              </a:rPr>
-              <a:t>현재의 한계</a:t>
-            </a:r>
-          </a:p>
-        </p:txBody>
-      </p:sp>
-      <p:sp>
-        <p:nvSpPr>
-          <p:cNvPr id="13" name="S05-body3">
-            <a:extLst>
-              <a:ext uri="{FF2B5EF4-FFF2-40B4-BE49-F238E27FC236}">
-                <a16:creationId xmlns:a16="http://schemas.microsoft.com/office/drawing/2014/main" id="{B7CA930B-B241-480F-9CC0-727D9BCFAE49}"/>
-              </a:ext>
-            </a:extLst>
-          </p:cNvPr>
-          <p:cNvSpPr>
-            <a:spLocks noGrp="1"/>
-          </p:cNvSpPr>
-          <p:nvPr/>
-        </p:nvSpPr>
-        <p:spPr>
-          <a:xfrm>
-            <a:off x="3829050" y="4933950"/>
-            <a:ext cx="7677150" cy="495300"/>
-          </a:xfrm>
-          <a:prstGeom prst="rect">
-            <a:avLst/>
-          </a:prstGeom>
-          <a:noFill/>
-          <a:ln w="0">
-            <a:noFill/>
-          </a:ln>
-        </p:spPr>
-        <p:txBody>
-          <a:bodyPr wrap="none" lIns="0" tIns="0" rIns="0" bIns="0" anchor="ctr">
-            <a:noAutofit/>
-          </a:bodyPr>
-          <a:lstStyle/>
-          <a:p>
-            <a:pPr>
-              <a:defRPr sz="1950" b="0">
-                <a:solidFill>
-                  <a:srgbClr val="586C68"/>
-                </a:solidFill>
-                <a:latin typeface="Noto Sans KR"/>
-                <a:ea typeface="Noto Sans KR"/>
-                <a:cs typeface="Noto Sans KR"/>
-              </a:defRPr>
-            </a:pPr>
-            <a:r>
-              <a:rPr sz="1950" b="0">
-                <a:solidFill>
-                  <a:srgbClr val="586C68"/>
-                </a:solidFill>
-                <a:latin typeface="Noto Sans KR"/>
-                <a:ea typeface="Noto Sans KR"/>
-                <a:cs typeface="Noto Sans KR"/>
-              </a:rPr>
-              <a:t>실제 데이터셋·표본수가 없어 일반화 판단 불가</a:t>
+              <a:t>가상 데이터</a:t>
             </a:r>
           </a:p>
         </p:txBody>
@@ -6361,7 +6802,7 @@
     </p:spTree>
     <p:extLst>
       <p:ext uri="{BB962C8B-B14F-4D97-AF65-F5344CB8AC3E}">
-        <p14:creationId xmlns:p14="http://schemas.microsoft.com/office/powerpoint/2010/main" val="907048644"/>
+        <p14:creationId xmlns:p14="http://schemas.microsoft.com/office/powerpoint/2010/main" val="971475065"/>
       </p:ext>
     </p:extLst>
   </p:cSld>

</xml_diff>